<commit_message>
Final slide: key idea, Q&A and QR codes again (teacher feedback)
</commit_message>
<xml_diff>
--- a/defense-materials/NewBalanceShop-presentation.pptx
+++ b/defense-materials/NewBalanceShop-presentation.pptx
@@ -124,7 +124,7 @@
   <p:extLst>
     <p:ext uri="{521415D9-36F7-43E2-AB2F-B90AF26B5E84}">
       <p14:sectionLst xmlns:p14="http://schemas.microsoft.com/office/powerpoint/2010/main">
-        <p14:section name="Доповідь" id="{c3d74c9c-5b3f-7dc1-9bed-a5c11d6e17bc}">
+        <p14:section name="Доповідь" id="{9066d5ff-0b6a-3889-d206-4420d3e6d171}">
           <p14:sldIdLst>
             <p14:sldId id="256"/>
             <p14:sldId id="257"/>
@@ -143,7 +143,7 @@
             <p14:sldId id="270"/>
           </p14:sldIdLst>
         </p14:section>
-        <p14:section name="Додатки (запасні слайди)" id="{2178c5e0-af2b-6055-ecd1-60d2e47a723d}">
+        <p14:section name="Додатки (запасні слайди)" id="{3f46e6d7-2ddb-e2e2-1aaa-54f24c9fa02f}">
           <p14:sldIdLst>
             <p14:sldId id="271"/>
             <p14:sldId id="272"/>
@@ -1082,7 +1082,7 @@
           <a:p>
             <a:r>
               <a:rPr lang="en-US" dirty="0"/>
-              <a:t>Ключова думка: від каталогу до замовлення за кілька кліків, без зайвої реєстрації. Дякуємо за увагу, готові до запитань.</a:t>
+              <a:t>Ключова думка: від каталогу до замовлення за кілька кліків, без зайвої реєстрації. Дякуємо за увагу, готові до запитань. QR-коди ведуть на живий сайт, код і документацію.</a:t>
             </a:r>
             <a:endParaRPr lang="en-US" dirty="0"/>
           </a:p>

</xml_diff>

<commit_message>
Switch public links to newbalanceshop.vercel.app, rebuild presentation
</commit_message>
<xml_diff>
--- a/defense-materials/NewBalanceShop-presentation.pptx
+++ b/defense-materials/NewBalanceShop-presentation.pptx
@@ -124,7 +124,7 @@
   <p:extLst>
     <p:ext uri="{521415D9-36F7-43E2-AB2F-B90AF26B5E84}">
       <p14:sectionLst xmlns:p14="http://schemas.microsoft.com/office/powerpoint/2010/main">
-        <p14:section name="Доповідь" id="{9066d5ff-0b6a-3889-d206-4420d3e6d171}">
+        <p14:section name="Доповідь" id="{a2ebd831-3fcd-0bb9-beab-d4c4ea119efc}">
           <p14:sldIdLst>
             <p14:sldId id="256"/>
             <p14:sldId id="257"/>
@@ -143,7 +143,7 @@
             <p14:sldId id="270"/>
           </p14:sldIdLst>
         </p14:section>
-        <p14:section name="Додатки (запасні слайди)" id="{3f46e6d7-2ddb-e2e2-1aaa-54f24c9fa02f}">
+        <p14:section name="Додатки (запасні слайди)" id="{2e549367-e551-fa6d-5cd6-75699c40c7b0}">
           <p14:sldIdLst>
             <p14:sldId id="271"/>
             <p14:sldId id="272"/>

</xml_diff>

<commit_message>
Add phone screenshots slide, rebuild presentation (pptx and pdf)
</commit_message>
<xml_diff>
--- a/defense-materials/NewBalanceShop-presentation.pptx
+++ b/defense-materials/NewBalanceShop-presentation.pptx
@@ -23,9 +23,10 @@
     <p:sldId id="271" r:id="rId17"/>
     <p:sldId id="272" r:id="rId18"/>
     <p:sldId id="273" r:id="rId19"/>
+    <p:sldId id="274" r:id="rId20"/>
   </p:sldIdLst>
   <p:notesMasterIdLst>
-    <p:notesMasterId r:id="rId20"/>
+    <p:notesMasterId r:id="rId21"/>
   </p:notesMasterIdLst>
   <p:sldSz cx="12192000" cy="6858000"/>
   <p:notesSz cx="6858000" cy="12192000"/>
@@ -124,7 +125,7 @@
   <p:extLst>
     <p:ext uri="{521415D9-36F7-43E2-AB2F-B90AF26B5E84}">
       <p14:sectionLst xmlns:p14="http://schemas.microsoft.com/office/powerpoint/2010/main">
-        <p14:section name="Доповідь" id="{a2ebd831-3fcd-0bb9-beab-d4c4ea119efc}">
+        <p14:section name="Доповідь" id="{ceefb699-ad92-82ca-9ef2-ef2c318ea6fe}">
           <p14:sldIdLst>
             <p14:sldId id="256"/>
             <p14:sldId id="257"/>
@@ -141,13 +142,14 @@
             <p14:sldId id="268"/>
             <p14:sldId id="269"/>
             <p14:sldId id="270"/>
+            <p14:sldId id="271"/>
           </p14:sldIdLst>
         </p14:section>
-        <p14:section name="Додатки (запасні слайди)" id="{2e549367-e551-fa6d-5cd6-75699c40c7b0}">
+        <p14:section name="Додатки (запасні слайди)" id="{b6cab27b-a2b2-9950-1a7d-be4705e582b4}">
           <p14:sldIdLst>
-            <p14:sldId id="271"/>
             <p14:sldId id="272"/>
             <p14:sldId id="273"/>
+            <p14:sldId id="274"/>
           </p14:sldIdLst>
         </p14:section>
       </p14:sectionLst>
@@ -994,7 +996,7 @@
           <a:p>
             <a:r>
               <a:rPr lang="en-US" dirty="0"/>
-              <a:t>Для розробників: повний цикл від вимог до деплою. Для цільової аудиторії: швидка покупка, кабінет, три мови. Монетизація: комісія, доставка, оплата, реклама.</a:t>
+              <a:t>Сайт адаптовано під телефон: шапка переноситься, меню прокручується, товари у дві колонки, кошик під каталогом. Скріни зроблено на живому деплої. Це відповідь на зауваження щодо UI.</a:t>
             </a:r>
             <a:endParaRPr lang="en-US" dirty="0"/>
           </a:p>
@@ -1082,7 +1084,7 @@
           <a:p>
             <a:r>
               <a:rPr lang="en-US" dirty="0"/>
-              <a:t>Ключова думка: від каталогу до замовлення за кілька кліків, без зайвої реєстрації. Дякуємо за увагу, готові до запитань. QR-коди ведуть на живий сайт, код і документацію.</a:t>
+              <a:t>Для розробників: повний цикл від вимог до деплою. Для цільової аудиторії: швидка покупка, кабінет, три мови. Монетизація: комісія, доставка, оплата, реклама.</a:t>
             </a:r>
             <a:endParaRPr lang="en-US" dirty="0"/>
           </a:p>
@@ -1170,7 +1172,7 @@
           <a:p>
             <a:r>
               <a:rPr lang="en-US" dirty="0"/>
-              <a:t>Резервний слайд. Ключові класи за шарами: контролери, сервіси, сутності Domain, репозиторії та DbContext.</a:t>
+              <a:t>Ключова думка: від каталогу до замовлення за кілька кліків, без зайвої реєстрації. Дякуємо за увагу, готові до запитань. QR-коди ведуть на живий сайт, код і документацію.</a:t>
             </a:r>
             <a:endParaRPr lang="en-US" dirty="0"/>
           </a:p>
@@ -1258,7 +1260,7 @@
           <a:p>
             <a:r>
               <a:rPr lang="en-US" dirty="0"/>
-              <a:t>Резервний слайд. Коміти за днями, гілки, внесок учасників. Внесок Team Lead у планування й Jira у Git не видно.</a:t>
+              <a:t>Резервний слайд. Ключові класи за шарами: контролери, сервіси, сутності Domain, репозиторії та DbContext.</a:t>
             </a:r>
             <a:endParaRPr lang="en-US" dirty="0"/>
           </a:p>
@@ -1346,6 +1348,94 @@
           <a:p>
             <a:r>
               <a:rPr lang="en-US" dirty="0"/>
+              <a:t>Резервний слайд. Коміти за днями, гілки, внесок учасників. Внесок Team Lead у планування й Jira у Git не видно.</a:t>
+            </a:r>
+            <a:endParaRPr lang="en-US" dirty="0"/>
+          </a:p>
+        </p:txBody>
+      </p:sp>
+      <p:sp>
+        <p:nvSpPr>
+          <p:cNvPr id="4" name="Slide Number Placeholder 3"/>
+          <p:cNvSpPr>
+            <a:spLocks noGrp="1"/>
+          </p:cNvSpPr>
+          <p:nvPr>
+            <p:ph type="sldNum" sz="quarter" idx="10"/>
+          </p:nvPr>
+        </p:nvSpPr>
+        <p:spPr/>
+        <p:txBody>
+          <a:bodyPr/>
+          <a:lstStyle/>
+          <a:p>
+            <a:fld id="{F7021451-1387-4CA6-816F-3879F97B5CBC}" type="slidenum">
+              <a:rPr lang="en-US"/>
+              <a:t>18</a:t>
+            </a:fld>
+            <a:endParaRPr lang="en-US"/>
+          </a:p>
+        </p:txBody>
+      </p:sp>
+    </p:spTree>
+    <p:extLst>
+      <p:ext uri="{BB962C8B-B14F-4D97-AF65-F5344CB8AC3E}">
+        <p14:creationId xmlns:p14="http://schemas.microsoft.com/office/powerpoint/2010/main" val="1024086991"/>
+      </p:ext>
+    </p:extLst>
+  </p:cSld>
+  <p:clrMapOvr>
+    <a:masterClrMapping/>
+  </p:clrMapOvr>
+</p:notes>
+</file>
+
+<file path=ppt/notesSlides/notesSlide19.xml><?xml version="1.0" encoding="utf-8"?>
+<p:notes xmlns:a="http://schemas.openxmlformats.org/drawingml/2006/main" xmlns:r="http://schemas.openxmlformats.org/officeDocument/2006/relationships" xmlns:p="http://schemas.openxmlformats.org/presentationml/2006/main">
+  <p:cSld>
+    <p:spTree>
+      <p:nvGrpSpPr>
+        <p:cNvPr id="1" name=""/>
+        <p:cNvGrpSpPr/>
+        <p:nvPr/>
+      </p:nvGrpSpPr>
+      <p:grpSpPr>
+        <a:xfrm>
+          <a:off x="0" y="0"/>
+          <a:ext cx="0" cy="0"/>
+          <a:chOff x="0" y="0"/>
+          <a:chExt cx="0" cy="0"/>
+        </a:xfrm>
+      </p:grpSpPr>
+      <p:sp>
+        <p:nvSpPr>
+          <p:cNvPr id="2" name="Slide Image Placeholder 1"/>
+          <p:cNvSpPr>
+            <a:spLocks noGrp="1" noRot="1" noChangeAspect="1"/>
+          </p:cNvSpPr>
+          <p:nvPr>
+            <p:ph type="sldImg"/>
+          </p:nvPr>
+        </p:nvSpPr>
+        <p:spPr/>
+      </p:sp>
+      <p:sp>
+        <p:nvSpPr>
+          <p:cNvPr id="3" name="Notes Placeholder 2"/>
+          <p:cNvSpPr>
+            <a:spLocks noGrp="1"/>
+          </p:cNvSpPr>
+          <p:nvPr>
+            <p:ph type="body" idx="1"/>
+          </p:nvPr>
+        </p:nvSpPr>
+        <p:spPr/>
+        <p:txBody>
+          <a:bodyPr/>
+          <a:lstStyle/>
+          <a:p>
+            <a:r>
+              <a:rPr lang="en-US" dirty="0"/>
               <a:t>Резервний слайд. README, SRS, архітектура, Scalar-документація API, Swagger. DocFX у плані.</a:t>
             </a:r>
             <a:endParaRPr lang="en-US" dirty="0"/>
@@ -1369,7 +1459,7 @@
           <a:p>
             <a:fld id="{F7021451-1387-4CA6-816F-3879F97B5CBC}" type="slidenum">
               <a:rPr lang="en-US"/>
-              <a:t>18</a:t>
+              <a:t>19</a:t>
             </a:fld>
             <a:endParaRPr lang="en-US"/>
           </a:p>
@@ -2705,6 +2795,62 @@
       </p:grpSpPr>
       <p:pic>
         <p:nvPicPr>
+          <p:cNvPr id="2" name="Image 0" descr="Мобільна версія сайту: скріни з телефона">    </p:cNvPr>
+          <p:cNvPicPr>
+            <a:picLocks noChangeAspect="1"/>
+          </p:cNvPicPr>
+          <p:nvPr/>
+        </p:nvPicPr>
+        <p:blipFill>
+          <a:blip r:embed="rId1"/>
+          <a:stretch>
+            <a:fillRect/>
+          </a:stretch>
+        </p:blipFill>
+        <p:spPr>
+          <a:xfrm>
+            <a:off x="0" y="0"/>
+            <a:ext cx="12191695" cy="6858000"/>
+          </a:xfrm>
+          <a:prstGeom prst="rect">
+            <a:avLst/>
+          </a:prstGeom>
+        </p:spPr>
+      </p:pic>
+    </p:spTree>
+  </p:cSld>
+  <p:clrMapOvr>
+    <a:masterClrMapping/>
+  </p:clrMapOvr>
+</p:sld>
+</file>
+
+<file path=ppt/slides/slide15.xml><?xml version="1.0" encoding="utf-8"?>
+<p:sld xmlns:a="http://schemas.openxmlformats.org/drawingml/2006/main" xmlns:r="http://schemas.openxmlformats.org/officeDocument/2006/relationships" xmlns:p="http://schemas.openxmlformats.org/presentationml/2006/main">
+  <p:cSld name="Slide 15">
+    <p:bg>
+      <p:bgPr>
+        <a:solidFill>
+          <a:srgbClr val="111111"/>
+        </a:solidFill>
+      </p:bgPr>
+    </p:bg>
+    <p:spTree>
+      <p:nvGrpSpPr>
+        <p:cNvPr id="1" name=""/>
+        <p:cNvGrpSpPr/>
+        <p:nvPr/>
+      </p:nvGrpSpPr>
+      <p:grpSpPr>
+        <a:xfrm>
+          <a:off x="0" y="0"/>
+          <a:ext cx="0" cy="0"/>
+          <a:chOff x="0" y="0"/>
+          <a:chExt cx="0" cy="0"/>
+        </a:xfrm>
+      </p:grpSpPr>
+      <p:pic>
+        <p:nvPicPr>
           <p:cNvPr id="2" name="Image 0" descr="Портфоліо-цінність проєкту">    </p:cNvPr>
           <p:cNvPicPr>
             <a:picLocks noChangeAspect="1"/>
@@ -2735,9 +2881,9 @@
 </p:sld>
 </file>
 
-<file path=ppt/slides/slide15.xml><?xml version="1.0" encoding="utf-8"?>
+<file path=ppt/slides/slide16.xml><?xml version="1.0" encoding="utf-8"?>
 <p:sld xmlns:a="http://schemas.openxmlformats.org/drawingml/2006/main" xmlns:r="http://schemas.openxmlformats.org/officeDocument/2006/relationships" xmlns:p="http://schemas.openxmlformats.org/presentationml/2006/main">
-  <p:cSld name="Slide 15">
+  <p:cSld name="Slide 16">
     <p:bg>
       <p:bgPr>
         <a:solidFill>
@@ -2791,9 +2937,9 @@
 </p:sld>
 </file>
 
-<file path=ppt/slides/slide16.xml><?xml version="1.0" encoding="utf-8"?>
+<file path=ppt/slides/slide17.xml><?xml version="1.0" encoding="utf-8"?>
 <p:sld xmlns:a="http://schemas.openxmlformats.org/drawingml/2006/main" xmlns:r="http://schemas.openxmlformats.org/officeDocument/2006/relationships" xmlns:p="http://schemas.openxmlformats.org/presentationml/2006/main">
-  <p:cSld name="Slide 16">
+  <p:cSld name="Slide 17">
     <p:bg>
       <p:bgPr>
         <a:solidFill>
@@ -2847,9 +2993,9 @@
 </p:sld>
 </file>
 
-<file path=ppt/slides/slide17.xml><?xml version="1.0" encoding="utf-8"?>
+<file path=ppt/slides/slide18.xml><?xml version="1.0" encoding="utf-8"?>
 <p:sld xmlns:a="http://schemas.openxmlformats.org/drawingml/2006/main" xmlns:r="http://schemas.openxmlformats.org/officeDocument/2006/relationships" xmlns:p="http://schemas.openxmlformats.org/presentationml/2006/main">
-  <p:cSld name="Slide 17">
+  <p:cSld name="Slide 18">
     <p:bg>
       <p:bgPr>
         <a:solidFill>
@@ -2903,9 +3049,9 @@
 </p:sld>
 </file>
 
-<file path=ppt/slides/slide18.xml><?xml version="1.0" encoding="utf-8"?>
+<file path=ppt/slides/slide19.xml><?xml version="1.0" encoding="utf-8"?>
 <p:sld xmlns:a="http://schemas.openxmlformats.org/drawingml/2006/main" xmlns:r="http://schemas.openxmlformats.org/officeDocument/2006/relationships" xmlns:p="http://schemas.openxmlformats.org/presentationml/2006/main">
-  <p:cSld name="Slide 18">
+  <p:cSld name="Slide 19">
     <p:bg>
       <p:bgPr>
         <a:solidFill>

</xml_diff>

<commit_message>
Refresh defense presentation: new site, security, metrics, live screenshots
</commit_message>
<xml_diff>
--- a/defense-materials/NewBalanceShop-presentation.pptx
+++ b/defense-materials/NewBalanceShop-presentation.pptx
@@ -24,9 +24,13 @@
     <p:sldId id="272" r:id="rId18"/>
     <p:sldId id="273" r:id="rId19"/>
     <p:sldId id="274" r:id="rId20"/>
+    <p:sldId id="275" r:id="rId21"/>
+    <p:sldId id="276" r:id="rId22"/>
+    <p:sldId id="277" r:id="rId23"/>
+    <p:sldId id="278" r:id="rId24"/>
   </p:sldIdLst>
   <p:notesMasterIdLst>
-    <p:notesMasterId r:id="rId21"/>
+    <p:notesMasterId r:id="rId25"/>
   </p:notesMasterIdLst>
   <p:sldSz cx="12192000" cy="6858000"/>
   <p:notesSz cx="6858000" cy="12192000"/>
@@ -125,7 +129,7 @@
   <p:extLst>
     <p:ext uri="{521415D9-36F7-43E2-AB2F-B90AF26B5E84}">
       <p14:sectionLst xmlns:p14="http://schemas.microsoft.com/office/powerpoint/2010/main">
-        <p14:section name="Доповідь" id="{ceefb699-ad92-82ca-9ef2-ef2c318ea6fe}">
+        <p14:section name="Доповідь" id="{3ee61ac1-abed-07f5-db7d-f421f717f36b}">
           <p14:sldIdLst>
             <p14:sldId id="256"/>
             <p14:sldId id="257"/>
@@ -143,13 +147,17 @@
             <p14:sldId id="269"/>
             <p14:sldId id="270"/>
             <p14:sldId id="271"/>
-          </p14:sldIdLst>
-        </p14:section>
-        <p14:section name="Додатки (запасні слайди)" id="{b6cab27b-a2b2-9950-1a7d-be4705e582b4}">
-          <p14:sldIdLst>
             <p14:sldId id="272"/>
             <p14:sldId id="273"/>
             <p14:sldId id="274"/>
+            <p14:sldId id="275"/>
+          </p14:sldIdLst>
+        </p14:section>
+        <p14:section name="Додатки (запасні слайди)" id="{437af76a-2b4b-cbfa-be22-d607c48dc3f8}">
+          <p14:sldIdLst>
+            <p14:sldId id="276"/>
+            <p14:sldId id="277"/>
+            <p14:sldId id="278"/>
           </p14:sldIdLst>
         </p14:section>
       </p14:sectionLst>
@@ -644,7 +652,7 @@
           <a:p>
             <a:r>
               <a:rPr lang="en-US" dirty="0"/>
-              <a:t>145 тестів: 102 unit і 43 integration, усі проходять. Тести знайшли три реальні баги: Forbid давав 500, Secure-cookie ламала сесію, конфлікт двох провайдерів БД. Логування: вбудований ILogger.</a:t>
+              <a:t>219 тестів: 141 unit і 78 integration, усі проходять. Тести знайшли реальні баги: Forbid давав 500, Secure-cookie ламала сесію, конфлікт двох провайдерів БД. Логування: ILogger і глобальний ExceptionHandlingMiddleware. У плані: CI в GitHub Actions і звіт ZAP.</a:t>
             </a:r>
             <a:endParaRPr lang="en-US" dirty="0"/>
           </a:p>
@@ -732,7 +740,7 @@
           <a:p>
             <a:r>
               <a:rPr lang="en-US" dirty="0"/>
-              <a:t>Покриття коду 86,7%. 12 із 13 вимог SRS, 29 ендпоінтів, 30 комітів, три тижні активної розробки. Усі цифри виміряні з репозиторіїв і прогону тестів.</a:t>
+              <a:t>Покриття коду 91,1%. 13 із 13 вимог SRS, 33 ендпоінти, 78 комітів (бекенд 56 і фронтенд 22), 18 merge-комітів, чотири тижні розробки. Усі цифри виміряні з репозиторіїв і прогону тестів.</a:t>
             </a:r>
             <a:endParaRPr lang="en-US" dirty="0"/>
           </a:p>
@@ -820,7 +828,7 @@
           <a:p>
             <a:r>
               <a:rPr lang="en-US" dirty="0"/>
-              <a:t>Шість спринтів за графіком курсу, беклог і канбан-стан на дату захисту. Jira-дошка команди: SCRUM board. Внесок учасників і гілки показані в додатку.</a:t>
+              <a:t>Шість спринтів за графіком курсу, беклог і канбан-стан на 14 жовтня. Jira-дошка команди: SCRUM board. Внесок учасників і гілки показані в додатку.</a:t>
             </a:r>
             <a:endParaRPr lang="en-US" dirty="0"/>
           </a:p>
@@ -996,7 +1004,7 @@
           <a:p>
             <a:r>
               <a:rPr lang="en-US" dirty="0"/>
-              <a:t>Сайт адаптовано під телефон: шапка переноситься, меню прокручується, товари у дві колонки, кошик під каталогом. Скріни зроблено на живому деплої. Це відповідь на зауваження щодо UI.</a:t>
+              <a:t>Живий сайт newbalance.cc.cd: 18 товарів, реальні фото з вільних ліцензій, фільтри в адресі, галерея з трьох кадрів і вибір розміру. Розмір можна обрати прямо на картці в каталозі.</a:t>
             </a:r>
             <a:endParaRPr lang="en-US" dirty="0"/>
           </a:p>
@@ -1084,7 +1092,7 @@
           <a:p>
             <a:r>
               <a:rPr lang="en-US" dirty="0"/>
-              <a:t>Для розробників: повний цикл від вимог до деплою. Для цільової аудиторії: швидка покупка, кабінет, три мови. Монетизація: комісія, доставка, оплата, реклама.</a:t>
+              <a:t>Сценарій покупця: кошик із розмірами, оформлення без обов'язкової реєстрації, обране. Покупець береться із сесії на сервері, гість оформляє на службового Гостя.</a:t>
             </a:r>
             <a:endParaRPr lang="en-US" dirty="0"/>
           </a:p>
@@ -1172,7 +1180,7 @@
           <a:p>
             <a:r>
               <a:rPr lang="en-US" dirty="0"/>
-              <a:t>Ключова думка: від каталогу до замовлення за кілька кліків, без зайвої реєстрації. Дякуємо за увагу, готові до запитань. QR-коди ведуть на живий сайт, код і документацію.</a:t>
+              <a:t>Сценарій перший: реєстрація і вхід нового користувача. Одна сторінка з перемикачем, email і пароль, Google, GitHub. Куки працюють, бо запити йдуть через домен сайту.</a:t>
             </a:r>
             <a:endParaRPr lang="en-US" dirty="0"/>
           </a:p>
@@ -1260,7 +1268,7 @@
           <a:p>
             <a:r>
               <a:rPr lang="en-US" dirty="0"/>
-              <a:t>Резервний слайд. Ключові класи за шарами: контролери, сервіси, сутності Domain, репозиторії та DbContext.</a:t>
+              <a:t>Сценарій другий: адмін-панель. Користувачі (блокування, видалення), товари (додати, змінити, видалити з розмірами і фото), замовлення (статуси). Усе захищене ролью: 401 без входу, 403 для звичайного покупця.</a:t>
             </a:r>
             <a:endParaRPr lang="en-US" dirty="0"/>
           </a:p>
@@ -1348,7 +1356,7 @@
           <a:p>
             <a:r>
               <a:rPr lang="en-US" dirty="0"/>
-              <a:t>Резервний слайд. Коміти за днями, гілки, внесок учасників. Внесок Team Lead у планування й Jira у Git не видно.</a:t>
+              <a:t>Сайт адаптовано під телефон: шапка переноситься, меню прокручується, товари в дві колонки, розміри на картці, адмін-таблиці стають картками. Скріни зроблено на живому коді.</a:t>
             </a:r>
             <a:endParaRPr lang="en-US" dirty="0"/>
           </a:p>
@@ -1436,7 +1444,7 @@
           <a:p>
             <a:r>
               <a:rPr lang="en-US" dirty="0"/>
-              <a:t>Резервний слайд. README, SRS, архітектура, Scalar-документація API, Swagger. DocFX у плані.</a:t>
+              <a:t>Для розробників: повний цикл від вимог до деплою. Для цільової аудиторії: швидка покупка, кабінет, три мови. Монетизація: комісія, доставка, оплата, реклама.</a:t>
             </a:r>
             <a:endParaRPr lang="en-US" dirty="0"/>
           </a:p>
@@ -1566,6 +1574,358 @@
 </p:notes>
 </file>
 
+<file path=ppt/notesSlides/notesSlide20.xml><?xml version="1.0" encoding="utf-8"?>
+<p:notes xmlns:a="http://schemas.openxmlformats.org/drawingml/2006/main" xmlns:r="http://schemas.openxmlformats.org/officeDocument/2006/relationships" xmlns:p="http://schemas.openxmlformats.org/presentationml/2006/main">
+  <p:cSld>
+    <p:spTree>
+      <p:nvGrpSpPr>
+        <p:cNvPr id="1" name=""/>
+        <p:cNvGrpSpPr/>
+        <p:nvPr/>
+      </p:nvGrpSpPr>
+      <p:grpSpPr>
+        <a:xfrm>
+          <a:off x="0" y="0"/>
+          <a:ext cx="0" cy="0"/>
+          <a:chOff x="0" y="0"/>
+          <a:chExt cx="0" cy="0"/>
+        </a:xfrm>
+      </p:grpSpPr>
+      <p:sp>
+        <p:nvSpPr>
+          <p:cNvPr id="2" name="Slide Image Placeholder 1"/>
+          <p:cNvSpPr>
+            <a:spLocks noGrp="1" noRot="1" noChangeAspect="1"/>
+          </p:cNvSpPr>
+          <p:nvPr>
+            <p:ph type="sldImg"/>
+          </p:nvPr>
+        </p:nvSpPr>
+        <p:spPr/>
+      </p:sp>
+      <p:sp>
+        <p:nvSpPr>
+          <p:cNvPr id="3" name="Notes Placeholder 2"/>
+          <p:cNvSpPr>
+            <a:spLocks noGrp="1"/>
+          </p:cNvSpPr>
+          <p:nvPr>
+            <p:ph type="body" idx="1"/>
+          </p:nvPr>
+        </p:nvSpPr>
+        <p:spPr/>
+        <p:txBody>
+          <a:bodyPr/>
+          <a:lstStyle/>
+          <a:p>
+            <a:r>
+              <a:rPr lang="en-US" dirty="0"/>
+              <a:t>Ключова думка: від каталогу до замовлення за кілька кліків, без зайвої реєстрації. Дякуємо за увагу, готові до запитань. QR-коди ведуть на живий сайт, код і документацію.</a:t>
+            </a:r>
+            <a:endParaRPr lang="en-US" dirty="0"/>
+          </a:p>
+        </p:txBody>
+      </p:sp>
+      <p:sp>
+        <p:nvSpPr>
+          <p:cNvPr id="4" name="Slide Number Placeholder 3"/>
+          <p:cNvSpPr>
+            <a:spLocks noGrp="1"/>
+          </p:cNvSpPr>
+          <p:nvPr>
+            <p:ph type="sldNum" sz="quarter" idx="10"/>
+          </p:nvPr>
+        </p:nvSpPr>
+        <p:spPr/>
+        <p:txBody>
+          <a:bodyPr/>
+          <a:lstStyle/>
+          <a:p>
+            <a:fld id="{F7021451-1387-4CA6-816F-3879F97B5CBC}" type="slidenum">
+              <a:rPr lang="en-US"/>
+              <a:t>20</a:t>
+            </a:fld>
+            <a:endParaRPr lang="en-US"/>
+          </a:p>
+        </p:txBody>
+      </p:sp>
+    </p:spTree>
+    <p:extLst>
+      <p:ext uri="{BB962C8B-B14F-4D97-AF65-F5344CB8AC3E}">
+        <p14:creationId xmlns:p14="http://schemas.microsoft.com/office/powerpoint/2010/main" val="1024086991"/>
+      </p:ext>
+    </p:extLst>
+  </p:cSld>
+  <p:clrMapOvr>
+    <a:masterClrMapping/>
+  </p:clrMapOvr>
+</p:notes>
+</file>
+
+<file path=ppt/notesSlides/notesSlide21.xml><?xml version="1.0" encoding="utf-8"?>
+<p:notes xmlns:a="http://schemas.openxmlformats.org/drawingml/2006/main" xmlns:r="http://schemas.openxmlformats.org/officeDocument/2006/relationships" xmlns:p="http://schemas.openxmlformats.org/presentationml/2006/main">
+  <p:cSld>
+    <p:spTree>
+      <p:nvGrpSpPr>
+        <p:cNvPr id="1" name=""/>
+        <p:cNvGrpSpPr/>
+        <p:nvPr/>
+      </p:nvGrpSpPr>
+      <p:grpSpPr>
+        <a:xfrm>
+          <a:off x="0" y="0"/>
+          <a:ext cx="0" cy="0"/>
+          <a:chOff x="0" y="0"/>
+          <a:chExt cx="0" cy="0"/>
+        </a:xfrm>
+      </p:grpSpPr>
+      <p:sp>
+        <p:nvSpPr>
+          <p:cNvPr id="2" name="Slide Image Placeholder 1"/>
+          <p:cNvSpPr>
+            <a:spLocks noGrp="1" noRot="1" noChangeAspect="1"/>
+          </p:cNvSpPr>
+          <p:nvPr>
+            <p:ph type="sldImg"/>
+          </p:nvPr>
+        </p:nvSpPr>
+        <p:spPr/>
+      </p:sp>
+      <p:sp>
+        <p:nvSpPr>
+          <p:cNvPr id="3" name="Notes Placeholder 2"/>
+          <p:cNvSpPr>
+            <a:spLocks noGrp="1"/>
+          </p:cNvSpPr>
+          <p:nvPr>
+            <p:ph type="body" idx="1"/>
+          </p:nvPr>
+        </p:nvSpPr>
+        <p:spPr/>
+        <p:txBody>
+          <a:bodyPr/>
+          <a:lstStyle/>
+          <a:p>
+            <a:r>
+              <a:rPr lang="en-US" dirty="0"/>
+              <a:t>Резервний слайд. Ключові класи за шарами: контролери, сервіси, сутності Domain, репозиторії та DbContext.</a:t>
+            </a:r>
+            <a:endParaRPr lang="en-US" dirty="0"/>
+          </a:p>
+        </p:txBody>
+      </p:sp>
+      <p:sp>
+        <p:nvSpPr>
+          <p:cNvPr id="4" name="Slide Number Placeholder 3"/>
+          <p:cNvSpPr>
+            <a:spLocks noGrp="1"/>
+          </p:cNvSpPr>
+          <p:nvPr>
+            <p:ph type="sldNum" sz="quarter" idx="10"/>
+          </p:nvPr>
+        </p:nvSpPr>
+        <p:spPr/>
+        <p:txBody>
+          <a:bodyPr/>
+          <a:lstStyle/>
+          <a:p>
+            <a:fld id="{F7021451-1387-4CA6-816F-3879F97B5CBC}" type="slidenum">
+              <a:rPr lang="en-US"/>
+              <a:t>21</a:t>
+            </a:fld>
+            <a:endParaRPr lang="en-US"/>
+          </a:p>
+        </p:txBody>
+      </p:sp>
+    </p:spTree>
+    <p:extLst>
+      <p:ext uri="{BB962C8B-B14F-4D97-AF65-F5344CB8AC3E}">
+        <p14:creationId xmlns:p14="http://schemas.microsoft.com/office/powerpoint/2010/main" val="1024086991"/>
+      </p:ext>
+    </p:extLst>
+  </p:cSld>
+  <p:clrMapOvr>
+    <a:masterClrMapping/>
+  </p:clrMapOvr>
+</p:notes>
+</file>
+
+<file path=ppt/notesSlides/notesSlide22.xml><?xml version="1.0" encoding="utf-8"?>
+<p:notes xmlns:a="http://schemas.openxmlformats.org/drawingml/2006/main" xmlns:r="http://schemas.openxmlformats.org/officeDocument/2006/relationships" xmlns:p="http://schemas.openxmlformats.org/presentationml/2006/main">
+  <p:cSld>
+    <p:spTree>
+      <p:nvGrpSpPr>
+        <p:cNvPr id="1" name=""/>
+        <p:cNvGrpSpPr/>
+        <p:nvPr/>
+      </p:nvGrpSpPr>
+      <p:grpSpPr>
+        <a:xfrm>
+          <a:off x="0" y="0"/>
+          <a:ext cx="0" cy="0"/>
+          <a:chOff x="0" y="0"/>
+          <a:chExt cx="0" cy="0"/>
+        </a:xfrm>
+      </p:grpSpPr>
+      <p:sp>
+        <p:nvSpPr>
+          <p:cNvPr id="2" name="Slide Image Placeholder 1"/>
+          <p:cNvSpPr>
+            <a:spLocks noGrp="1" noRot="1" noChangeAspect="1"/>
+          </p:cNvSpPr>
+          <p:nvPr>
+            <p:ph type="sldImg"/>
+          </p:nvPr>
+        </p:nvSpPr>
+        <p:spPr/>
+      </p:sp>
+      <p:sp>
+        <p:nvSpPr>
+          <p:cNvPr id="3" name="Notes Placeholder 2"/>
+          <p:cNvSpPr>
+            <a:spLocks noGrp="1"/>
+          </p:cNvSpPr>
+          <p:nvPr>
+            <p:ph type="body" idx="1"/>
+          </p:nvPr>
+        </p:nvSpPr>
+        <p:spPr/>
+        <p:txBody>
+          <a:bodyPr/>
+          <a:lstStyle/>
+          <a:p>
+            <a:r>
+              <a:rPr lang="en-US" dirty="0"/>
+              <a:t>Резервний слайд. 78 комітів за днями, гілки feature і fix з merge-комітами, внесок учасників. Внесок Team Lead у планування й Jira у Git не видно.</a:t>
+            </a:r>
+            <a:endParaRPr lang="en-US" dirty="0"/>
+          </a:p>
+        </p:txBody>
+      </p:sp>
+      <p:sp>
+        <p:nvSpPr>
+          <p:cNvPr id="4" name="Slide Number Placeholder 3"/>
+          <p:cNvSpPr>
+            <a:spLocks noGrp="1"/>
+          </p:cNvSpPr>
+          <p:nvPr>
+            <p:ph type="sldNum" sz="quarter" idx="10"/>
+          </p:nvPr>
+        </p:nvSpPr>
+        <p:spPr/>
+        <p:txBody>
+          <a:bodyPr/>
+          <a:lstStyle/>
+          <a:p>
+            <a:fld id="{F7021451-1387-4CA6-816F-3879F97B5CBC}" type="slidenum">
+              <a:rPr lang="en-US"/>
+              <a:t>22</a:t>
+            </a:fld>
+            <a:endParaRPr lang="en-US"/>
+          </a:p>
+        </p:txBody>
+      </p:sp>
+    </p:spTree>
+    <p:extLst>
+      <p:ext uri="{BB962C8B-B14F-4D97-AF65-F5344CB8AC3E}">
+        <p14:creationId xmlns:p14="http://schemas.microsoft.com/office/powerpoint/2010/main" val="1024086991"/>
+      </p:ext>
+    </p:extLst>
+  </p:cSld>
+  <p:clrMapOvr>
+    <a:masterClrMapping/>
+  </p:clrMapOvr>
+</p:notes>
+</file>
+
+<file path=ppt/notesSlides/notesSlide23.xml><?xml version="1.0" encoding="utf-8"?>
+<p:notes xmlns:a="http://schemas.openxmlformats.org/drawingml/2006/main" xmlns:r="http://schemas.openxmlformats.org/officeDocument/2006/relationships" xmlns:p="http://schemas.openxmlformats.org/presentationml/2006/main">
+  <p:cSld>
+    <p:spTree>
+      <p:nvGrpSpPr>
+        <p:cNvPr id="1" name=""/>
+        <p:cNvGrpSpPr/>
+        <p:nvPr/>
+      </p:nvGrpSpPr>
+      <p:grpSpPr>
+        <a:xfrm>
+          <a:off x="0" y="0"/>
+          <a:ext cx="0" cy="0"/>
+          <a:chOff x="0" y="0"/>
+          <a:chExt cx="0" cy="0"/>
+        </a:xfrm>
+      </p:grpSpPr>
+      <p:sp>
+        <p:nvSpPr>
+          <p:cNvPr id="2" name="Slide Image Placeholder 1"/>
+          <p:cNvSpPr>
+            <a:spLocks noGrp="1" noRot="1" noChangeAspect="1"/>
+          </p:cNvSpPr>
+          <p:nvPr>
+            <p:ph type="sldImg"/>
+          </p:nvPr>
+        </p:nvSpPr>
+        <p:spPr/>
+      </p:sp>
+      <p:sp>
+        <p:nvSpPr>
+          <p:cNvPr id="3" name="Notes Placeholder 2"/>
+          <p:cNvSpPr>
+            <a:spLocks noGrp="1"/>
+          </p:cNvSpPr>
+          <p:nvPr>
+            <p:ph type="body" idx="1"/>
+          </p:nvPr>
+        </p:nvSpPr>
+        <p:spPr/>
+        <p:txBody>
+          <a:bodyPr/>
+          <a:lstStyle/>
+          <a:p>
+            <a:r>
+              <a:rPr lang="en-US" dirty="0"/>
+              <a:t>Резервний слайд. README за шаблоном викладача, SRS, архітектура, Scalar-документація API, Swagger, DocFX на GitHub Pages.</a:t>
+            </a:r>
+            <a:endParaRPr lang="en-US" dirty="0"/>
+          </a:p>
+        </p:txBody>
+      </p:sp>
+      <p:sp>
+        <p:nvSpPr>
+          <p:cNvPr id="4" name="Slide Number Placeholder 3"/>
+          <p:cNvSpPr>
+            <a:spLocks noGrp="1"/>
+          </p:cNvSpPr>
+          <p:nvPr>
+            <p:ph type="sldNum" sz="quarter" idx="10"/>
+          </p:nvPr>
+        </p:nvSpPr>
+        <p:spPr/>
+        <p:txBody>
+          <a:bodyPr/>
+          <a:lstStyle/>
+          <a:p>
+            <a:fld id="{F7021451-1387-4CA6-816F-3879F97B5CBC}" type="slidenum">
+              <a:rPr lang="en-US"/>
+              <a:t>23</a:t>
+            </a:fld>
+            <a:endParaRPr lang="en-US"/>
+          </a:p>
+        </p:txBody>
+      </p:sp>
+    </p:spTree>
+    <p:extLst>
+      <p:ext uri="{BB962C8B-B14F-4D97-AF65-F5344CB8AC3E}">
+        <p14:creationId xmlns:p14="http://schemas.microsoft.com/office/powerpoint/2010/main" val="1024086991"/>
+      </p:ext>
+    </p:extLst>
+  </p:cSld>
+  <p:clrMapOvr>
+    <a:masterClrMapping/>
+  </p:clrMapOvr>
+</p:notes>
+</file>
+
 <file path=ppt/notesSlides/notesSlide3.xml><?xml version="1.0" encoding="utf-8"?>
 <p:notes xmlns:a="http://schemas.openxmlformats.org/drawingml/2006/main" xmlns:r="http://schemas.openxmlformats.org/officeDocument/2006/relationships" xmlns:p="http://schemas.openxmlformats.org/presentationml/2006/main">
   <p:cSld>
@@ -1612,7 +1972,7 @@
           <a:p>
             <a:r>
               <a:rPr lang="en-US" dirty="0"/>
-              <a:t>У SRS 13 функціональних вимог: 12 реалізовано повністю, FR-03 (фільтр за брендом і ціною) частково. Нефункціональні вимоги: продуктивність, масштабованість, безпека, надійність, зручність. План по спринтах є у файлі SRS і в додатку.</a:t>
+              <a:t>У SRS 13 функціональних вимог і нефункціональні вимоги. Усі 13 реалізовано, зокрема FR-03: фільтри за категорією, брендом, розміром, ціною, пошук і сортування. Нефункціональні: продуктивність, масштабованість, безпека, надійність, зручність (UA/EN/FR, адаптивна верстка).</a:t>
             </a:r>
             <a:endParaRPr lang="en-US" dirty="0"/>
           </a:p>
@@ -1788,7 +2148,7 @@
           <a:p>
             <a:r>
               <a:rPr lang="en-US" dirty="0"/>
-              <a:t>React на Vercel, API на ASP.NET Core 9 у Docker на Render, база PostgreSQL на Render. Вхід через Google (Firebase) і GitHub OAuth. Фронтенд з бекендом спілкується по HTTPS із cookie.</a:t>
+              <a:t>React на Vercel, API на ASP.NET Core 9 у Docker на Render, PostgreSQL на Render. Запити /api йдуть на той самий домен сайту, а Vercel проксує їх на сервер: так сесійна кука належить сайту й браузер її не блокує. Вхід через Google (Firebase) і GitHub OAuth.</a:t>
             </a:r>
             <a:endParaRPr lang="en-US" dirty="0"/>
           </a:p>
@@ -1876,7 +2236,7 @@
           <a:p>
             <a:r>
               <a:rPr lang="en-US" dirty="0"/>
-              <a:t>Чотири проєкти: Domain без залежностей, Application залежить від Domain, Infrastructure реалізує репозиторії, Web API збирає все через DI. Відоме відхилення: Firebase SDK лежить в Application, план винести за інтерфейс.</a:t>
+              <a:t>Чотири проєкти: Domain без залежностей, Application залежить від Domain, Infrastructure реалізує репозиторії та перевірку Google-токена, Web API збирає все через DI. Раніше Firebase SDK лежав в Application, тепер він схований за інтерфейсом IGoogleTokenVerifier.</a:t>
             </a:r>
             <a:endParaRPr lang="en-US" dirty="0"/>
           </a:p>
@@ -2052,7 +2412,7 @@
           <a:p>
             <a:r>
               <a:rPr lang="en-US" dirty="0"/>
-              <a:t>PostgreSQL: реляційні зв'язки замовлення, позиції, товар, потрібна транзакційність, безкоштовно на Render. П'ять таблиць, індекси на зовнішніх ключах, ціна позиції фіксується на момент замовлення. Що покращити: унікальний Email, м'яке видалення.</a:t>
+              <a:t>PostgreSQL: реляційні зв'язки замовлення, позиції, товар, потрібна транзакційність, безкоштовно на Render. У товару список розмірів і галерея, у позиції замовлення обраний розмір. Унікальний Email, покупця із замовленнями видалити не можна. Що покращити: залишок окремо по кожному розміру.</a:t>
             </a:r>
             <a:endParaRPr lang="en-US" dirty="0"/>
           </a:p>
@@ -2140,7 +2500,7 @@
           <a:p>
             <a:r>
               <a:rPr lang="en-US" dirty="0"/>
-              <a:t>Три способи входу: пароль, Google, GitHub. Паролі зберігаються як PBKDF2 із сіллю, 100 000 ітерацій. Адмін-ендпоінти повертають 401 або 403. Чесно про ризики: ID покупця в замовленнях береться з параметра, CRUD товарів без перевірки ролі, широкий CORS. Є план закриття.</a:t>
+              <a:t>Три способи входу: пароль, Google, GitHub. Паролі зберігаються як PBKDF2 із сіллю, 100 000 ітерацій. Закрито: BOLA (покупець береться із сесії), запис товарів лише для адміністратора, білий список CORS, rate limiting на вхід, унікальний email, пароль адміна прибрано з коду. Ще в плані: сесії в Redis або БД і звіт ZAP.</a:t>
             </a:r>
             <a:endParaRPr lang="en-US" dirty="0"/>
           </a:p>
@@ -2795,6 +3155,230 @@
       </p:grpSpPr>
       <p:pic>
         <p:nvPicPr>
+          <p:cNvPr id="2" name="Image 0" descr="Каталог і картка товару на живому сайті">    </p:cNvPr>
+          <p:cNvPicPr>
+            <a:picLocks noChangeAspect="1"/>
+          </p:cNvPicPr>
+          <p:nvPr/>
+        </p:nvPicPr>
+        <p:blipFill>
+          <a:blip r:embed="rId1"/>
+          <a:stretch>
+            <a:fillRect/>
+          </a:stretch>
+        </p:blipFill>
+        <p:spPr>
+          <a:xfrm>
+            <a:off x="0" y="0"/>
+            <a:ext cx="12191695" cy="6858000"/>
+          </a:xfrm>
+          <a:prstGeom prst="rect">
+            <a:avLst/>
+          </a:prstGeom>
+        </p:spPr>
+      </p:pic>
+    </p:spTree>
+  </p:cSld>
+  <p:clrMapOvr>
+    <a:masterClrMapping/>
+  </p:clrMapOvr>
+</p:sld>
+</file>
+
+<file path=ppt/slides/slide15.xml><?xml version="1.0" encoding="utf-8"?>
+<p:sld xmlns:a="http://schemas.openxmlformats.org/drawingml/2006/main" xmlns:r="http://schemas.openxmlformats.org/officeDocument/2006/relationships" xmlns:p="http://schemas.openxmlformats.org/presentationml/2006/main">
+  <p:cSld name="Slide 15">
+    <p:bg>
+      <p:bgPr>
+        <a:solidFill>
+          <a:srgbClr val="111111"/>
+        </a:solidFill>
+      </p:bgPr>
+    </p:bg>
+    <p:spTree>
+      <p:nvGrpSpPr>
+        <p:cNvPr id="1" name=""/>
+        <p:cNvGrpSpPr/>
+        <p:nvPr/>
+      </p:nvGrpSpPr>
+      <p:grpSpPr>
+        <a:xfrm>
+          <a:off x="0" y="0"/>
+          <a:ext cx="0" cy="0"/>
+          <a:chOff x="0" y="0"/>
+          <a:chExt cx="0" cy="0"/>
+        </a:xfrm>
+      </p:grpSpPr>
+      <p:pic>
+        <p:nvPicPr>
+          <p:cNvPr id="2" name="Image 0" descr="Кошик, оформлення і обране">    </p:cNvPr>
+          <p:cNvPicPr>
+            <a:picLocks noChangeAspect="1"/>
+          </p:cNvPicPr>
+          <p:nvPr/>
+        </p:nvPicPr>
+        <p:blipFill>
+          <a:blip r:embed="rId1"/>
+          <a:stretch>
+            <a:fillRect/>
+          </a:stretch>
+        </p:blipFill>
+        <p:spPr>
+          <a:xfrm>
+            <a:off x="0" y="0"/>
+            <a:ext cx="12191695" cy="6858000"/>
+          </a:xfrm>
+          <a:prstGeom prst="rect">
+            <a:avLst/>
+          </a:prstGeom>
+        </p:spPr>
+      </p:pic>
+    </p:spTree>
+  </p:cSld>
+  <p:clrMapOvr>
+    <a:masterClrMapping/>
+  </p:clrMapOvr>
+</p:sld>
+</file>
+
+<file path=ppt/slides/slide16.xml><?xml version="1.0" encoding="utf-8"?>
+<p:sld xmlns:a="http://schemas.openxmlformats.org/drawingml/2006/main" xmlns:r="http://schemas.openxmlformats.org/officeDocument/2006/relationships" xmlns:p="http://schemas.openxmlformats.org/presentationml/2006/main">
+  <p:cSld name="Slide 16">
+    <p:bg>
+      <p:bgPr>
+        <a:solidFill>
+          <a:srgbClr val="111111"/>
+        </a:solidFill>
+      </p:bgPr>
+    </p:bg>
+    <p:spTree>
+      <p:nvGrpSpPr>
+        <p:cNvPr id="1" name=""/>
+        <p:cNvGrpSpPr/>
+        <p:nvPr/>
+      </p:nvGrpSpPr>
+      <p:grpSpPr>
+        <a:xfrm>
+          <a:off x="0" y="0"/>
+          <a:ext cx="0" cy="0"/>
+          <a:chOff x="0" y="0"/>
+          <a:chExt cx="0" cy="0"/>
+        </a:xfrm>
+      </p:grpSpPr>
+      <p:pic>
+        <p:nvPicPr>
+          <p:cNvPr id="2" name="Image 0" descr="Вхід і реєстрація">    </p:cNvPr>
+          <p:cNvPicPr>
+            <a:picLocks noChangeAspect="1"/>
+          </p:cNvPicPr>
+          <p:nvPr/>
+        </p:nvPicPr>
+        <p:blipFill>
+          <a:blip r:embed="rId1"/>
+          <a:stretch>
+            <a:fillRect/>
+          </a:stretch>
+        </p:blipFill>
+        <p:spPr>
+          <a:xfrm>
+            <a:off x="0" y="0"/>
+            <a:ext cx="12191695" cy="6858000"/>
+          </a:xfrm>
+          <a:prstGeom prst="rect">
+            <a:avLst/>
+          </a:prstGeom>
+        </p:spPr>
+      </p:pic>
+    </p:spTree>
+  </p:cSld>
+  <p:clrMapOvr>
+    <a:masterClrMapping/>
+  </p:clrMapOvr>
+</p:sld>
+</file>
+
+<file path=ppt/slides/slide17.xml><?xml version="1.0" encoding="utf-8"?>
+<p:sld xmlns:a="http://schemas.openxmlformats.org/drawingml/2006/main" xmlns:r="http://schemas.openxmlformats.org/officeDocument/2006/relationships" xmlns:p="http://schemas.openxmlformats.org/presentationml/2006/main">
+  <p:cSld name="Slide 17">
+    <p:bg>
+      <p:bgPr>
+        <a:solidFill>
+          <a:srgbClr val="111111"/>
+        </a:solidFill>
+      </p:bgPr>
+    </p:bg>
+    <p:spTree>
+      <p:nvGrpSpPr>
+        <p:cNvPr id="1" name=""/>
+        <p:cNvGrpSpPr/>
+        <p:nvPr/>
+      </p:nvGrpSpPr>
+      <p:grpSpPr>
+        <a:xfrm>
+          <a:off x="0" y="0"/>
+          <a:ext cx="0" cy="0"/>
+          <a:chOff x="0" y="0"/>
+          <a:chExt cx="0" cy="0"/>
+        </a:xfrm>
+      </p:grpSpPr>
+      <p:pic>
+        <p:nvPicPr>
+          <p:cNvPr id="2" name="Image 0" descr="Адмін-панель модератора">    </p:cNvPr>
+          <p:cNvPicPr>
+            <a:picLocks noChangeAspect="1"/>
+          </p:cNvPicPr>
+          <p:nvPr/>
+        </p:nvPicPr>
+        <p:blipFill>
+          <a:blip r:embed="rId1"/>
+          <a:stretch>
+            <a:fillRect/>
+          </a:stretch>
+        </p:blipFill>
+        <p:spPr>
+          <a:xfrm>
+            <a:off x="0" y="0"/>
+            <a:ext cx="12191695" cy="6858000"/>
+          </a:xfrm>
+          <a:prstGeom prst="rect">
+            <a:avLst/>
+          </a:prstGeom>
+        </p:spPr>
+      </p:pic>
+    </p:spTree>
+  </p:cSld>
+  <p:clrMapOvr>
+    <a:masterClrMapping/>
+  </p:clrMapOvr>
+</p:sld>
+</file>
+
+<file path=ppt/slides/slide18.xml><?xml version="1.0" encoding="utf-8"?>
+<p:sld xmlns:a="http://schemas.openxmlformats.org/drawingml/2006/main" xmlns:r="http://schemas.openxmlformats.org/officeDocument/2006/relationships" xmlns:p="http://schemas.openxmlformats.org/presentationml/2006/main">
+  <p:cSld name="Slide 18">
+    <p:bg>
+      <p:bgPr>
+        <a:solidFill>
+          <a:srgbClr val="111111"/>
+        </a:solidFill>
+      </p:bgPr>
+    </p:bg>
+    <p:spTree>
+      <p:nvGrpSpPr>
+        <p:cNvPr id="1" name=""/>
+        <p:cNvGrpSpPr/>
+        <p:nvPr/>
+      </p:nvGrpSpPr>
+      <p:grpSpPr>
+        <a:xfrm>
+          <a:off x="0" y="0"/>
+          <a:ext cx="0" cy="0"/>
+          <a:chOff x="0" y="0"/>
+          <a:chExt cx="0" cy="0"/>
+        </a:xfrm>
+      </p:grpSpPr>
+      <p:pic>
+        <p:nvPicPr>
           <p:cNvPr id="2" name="Image 0" descr="Мобільна версія сайту: скріни з телефона">    </p:cNvPr>
           <p:cNvPicPr>
             <a:picLocks noChangeAspect="1"/>
@@ -2825,9 +3409,9 @@
 </p:sld>
 </file>
 
-<file path=ppt/slides/slide15.xml><?xml version="1.0" encoding="utf-8"?>
+<file path=ppt/slides/slide19.xml><?xml version="1.0" encoding="utf-8"?>
 <p:sld xmlns:a="http://schemas.openxmlformats.org/drawingml/2006/main" xmlns:r="http://schemas.openxmlformats.org/officeDocument/2006/relationships" xmlns:p="http://schemas.openxmlformats.org/presentationml/2006/main">
-  <p:cSld name="Slide 15">
+  <p:cSld name="Slide 19">
     <p:bg>
       <p:bgPr>
         <a:solidFill>
@@ -2881,9 +3465,65 @@
 </p:sld>
 </file>
 
-<file path=ppt/slides/slide16.xml><?xml version="1.0" encoding="utf-8"?>
+<file path=ppt/slides/slide2.xml><?xml version="1.0" encoding="utf-8"?>
 <p:sld xmlns:a="http://schemas.openxmlformats.org/drawingml/2006/main" xmlns:r="http://schemas.openxmlformats.org/officeDocument/2006/relationships" xmlns:p="http://schemas.openxmlformats.org/presentationml/2006/main">
-  <p:cSld name="Slide 16">
+  <p:cSld name="Slide 2">
+    <p:bg>
+      <p:bgPr>
+        <a:solidFill>
+          <a:srgbClr val="111111"/>
+        </a:solidFill>
+      </p:bgPr>
+    </p:bg>
+    <p:spTree>
+      <p:nvGrpSpPr>
+        <p:cNvPr id="1" name=""/>
+        <p:cNvGrpSpPr/>
+        <p:nvPr/>
+      </p:nvGrpSpPr>
+      <p:grpSpPr>
+        <a:xfrm>
+          <a:off x="0" y="0"/>
+          <a:ext cx="0" cy="0"/>
+          <a:chOff x="0" y="0"/>
+          <a:chExt cx="0" cy="0"/>
+        </a:xfrm>
+      </p:grpSpPr>
+      <p:pic>
+        <p:nvPicPr>
+          <p:cNvPr id="2" name="Image 0" descr="Навіщо проєкт: проблема, рішення, цільова аудиторія">    </p:cNvPr>
+          <p:cNvPicPr>
+            <a:picLocks noChangeAspect="1"/>
+          </p:cNvPicPr>
+          <p:nvPr/>
+        </p:nvPicPr>
+        <p:blipFill>
+          <a:blip r:embed="rId1"/>
+          <a:stretch>
+            <a:fillRect/>
+          </a:stretch>
+        </p:blipFill>
+        <p:spPr>
+          <a:xfrm>
+            <a:off x="0" y="0"/>
+            <a:ext cx="12191695" cy="6858000"/>
+          </a:xfrm>
+          <a:prstGeom prst="rect">
+            <a:avLst/>
+          </a:prstGeom>
+        </p:spPr>
+      </p:pic>
+    </p:spTree>
+  </p:cSld>
+  <p:clrMapOvr>
+    <a:masterClrMapping/>
+  </p:clrMapOvr>
+</p:sld>
+</file>
+
+<file path=ppt/slides/slide20.xml><?xml version="1.0" encoding="utf-8"?>
+<p:sld xmlns:a="http://schemas.openxmlformats.org/drawingml/2006/main" xmlns:r="http://schemas.openxmlformats.org/officeDocument/2006/relationships" xmlns:p="http://schemas.openxmlformats.org/presentationml/2006/main">
+  <p:cSld name="Slide 20">
     <p:bg>
       <p:bgPr>
         <a:solidFill>
@@ -2937,9 +3577,9 @@
 </p:sld>
 </file>
 
-<file path=ppt/slides/slide17.xml><?xml version="1.0" encoding="utf-8"?>
+<file path=ppt/slides/slide21.xml><?xml version="1.0" encoding="utf-8"?>
 <p:sld xmlns:a="http://schemas.openxmlformats.org/drawingml/2006/main" xmlns:r="http://schemas.openxmlformats.org/officeDocument/2006/relationships" xmlns:p="http://schemas.openxmlformats.org/presentationml/2006/main">
-  <p:cSld name="Slide 17">
+  <p:cSld name="Slide 21">
     <p:bg>
       <p:bgPr>
         <a:solidFill>
@@ -2993,9 +3633,9 @@
 </p:sld>
 </file>
 
-<file path=ppt/slides/slide18.xml><?xml version="1.0" encoding="utf-8"?>
+<file path=ppt/slides/slide22.xml><?xml version="1.0" encoding="utf-8"?>
 <p:sld xmlns:a="http://schemas.openxmlformats.org/drawingml/2006/main" xmlns:r="http://schemas.openxmlformats.org/officeDocument/2006/relationships" xmlns:p="http://schemas.openxmlformats.org/presentationml/2006/main">
-  <p:cSld name="Slide 18">
+  <p:cSld name="Slide 22">
     <p:bg>
       <p:bgPr>
         <a:solidFill>
@@ -3049,9 +3689,9 @@
 </p:sld>
 </file>
 
-<file path=ppt/slides/slide19.xml><?xml version="1.0" encoding="utf-8"?>
+<file path=ppt/slides/slide23.xml><?xml version="1.0" encoding="utf-8"?>
 <p:sld xmlns:a="http://schemas.openxmlformats.org/drawingml/2006/main" xmlns:r="http://schemas.openxmlformats.org/officeDocument/2006/relationships" xmlns:p="http://schemas.openxmlformats.org/presentationml/2006/main">
-  <p:cSld name="Slide 19">
+  <p:cSld name="Slide 23">
     <p:bg>
       <p:bgPr>
         <a:solidFill>
@@ -3105,62 +3745,6 @@
 </p:sld>
 </file>
 
-<file path=ppt/slides/slide2.xml><?xml version="1.0" encoding="utf-8"?>
-<p:sld xmlns:a="http://schemas.openxmlformats.org/drawingml/2006/main" xmlns:r="http://schemas.openxmlformats.org/officeDocument/2006/relationships" xmlns:p="http://schemas.openxmlformats.org/presentationml/2006/main">
-  <p:cSld name="Slide 2">
-    <p:bg>
-      <p:bgPr>
-        <a:solidFill>
-          <a:srgbClr val="111111"/>
-        </a:solidFill>
-      </p:bgPr>
-    </p:bg>
-    <p:spTree>
-      <p:nvGrpSpPr>
-        <p:cNvPr id="1" name=""/>
-        <p:cNvGrpSpPr/>
-        <p:nvPr/>
-      </p:nvGrpSpPr>
-      <p:grpSpPr>
-        <a:xfrm>
-          <a:off x="0" y="0"/>
-          <a:ext cx="0" cy="0"/>
-          <a:chOff x="0" y="0"/>
-          <a:chExt cx="0" cy="0"/>
-        </a:xfrm>
-      </p:grpSpPr>
-      <p:pic>
-        <p:nvPicPr>
-          <p:cNvPr id="2" name="Image 0" descr="Навіщо проєкт: проблема, рішення, цільова аудиторія">    </p:cNvPr>
-          <p:cNvPicPr>
-            <a:picLocks noChangeAspect="1"/>
-          </p:cNvPicPr>
-          <p:nvPr/>
-        </p:nvPicPr>
-        <p:blipFill>
-          <a:blip r:embed="rId1"/>
-          <a:stretch>
-            <a:fillRect/>
-          </a:stretch>
-        </p:blipFill>
-        <p:spPr>
-          <a:xfrm>
-            <a:off x="0" y="0"/>
-            <a:ext cx="12191695" cy="6858000"/>
-          </a:xfrm>
-          <a:prstGeom prst="rect">
-            <a:avLst/>
-          </a:prstGeom>
-        </p:spPr>
-      </p:pic>
-    </p:spTree>
-  </p:cSld>
-  <p:clrMapOvr>
-    <a:masterClrMapping/>
-  </p:clrMapOvr>
-</p:sld>
-</file>
-
 <file path=ppt/slides/slide3.xml><?xml version="1.0" encoding="utf-8"?>
 <p:sld xmlns:a="http://schemas.openxmlformats.org/drawingml/2006/main" xmlns:r="http://schemas.openxmlformats.org/officeDocument/2006/relationships" xmlns:p="http://schemas.openxmlformats.org/presentationml/2006/main">
   <p:cSld name="Slide 3">
@@ -3187,7 +3771,7 @@
       </p:grpSpPr>
       <p:pic>
         <p:nvPicPr>
-          <p:cNvPr id="2" name="Image 0" descr="SRS: 13 функціональних вимог і нефункціональні">    </p:cNvPr>
+          <p:cNvPr id="2" name="Image 0" descr="SRS: 13 функціональних вимог, усі реалізовано">    </p:cNvPr>
           <p:cNvPicPr>
             <a:picLocks noChangeAspect="1"/>
           </p:cNvPicPr>

</xml_diff>

<commit_message>
docs: rebuild defense presentation
</commit_message>
<xml_diff>
--- a/defense-materials/NewBalanceShop-presentation.pptx
+++ b/defense-materials/NewBalanceShop-presentation.pptx
@@ -129,7 +129,7 @@
   <p:extLst>
     <p:ext uri="{521415D9-36F7-43E2-AB2F-B90AF26B5E84}">
       <p14:sectionLst xmlns:p14="http://schemas.microsoft.com/office/powerpoint/2010/main">
-        <p14:section name="Доповідь" id="{3ee61ac1-abed-07f5-db7d-f421f717f36b}">
+        <p14:section name="Доповідь" id="{9414b494-3e0f-898c-4cae-ac4c2c798f6c}">
           <p14:sldIdLst>
             <p14:sldId id="256"/>
             <p14:sldId id="257"/>
@@ -153,7 +153,7 @@
             <p14:sldId id="275"/>
           </p14:sldIdLst>
         </p14:section>
-        <p14:section name="Додатки (запасні слайди)" id="{437af76a-2b4b-cbfa-be22-d607c48dc3f8}">
+        <p14:section name="Додатки (запасні слайди)" id="{3576b0e6-524e-90dc-d26a-b8bd42de1206}">
           <p14:sldIdLst>
             <p14:sldId id="276"/>
             <p14:sldId id="277"/>
@@ -652,7 +652,7 @@
           <a:p>
             <a:r>
               <a:rPr lang="en-US" dirty="0"/>
-              <a:t>219 тестів: 141 unit і 78 integration, усі проходять. Тести знайшли реальні баги: Forbid давав 500, Secure-cookie ламала сесію, конфлікт двох провайдерів БД. Логування: ILogger і глобальний ExceptionHandlingMiddleware. У плані: CI в GitHub Actions і звіт ZAP.</a:t>
+              <a:t>295 тестів: 190 unit і 105 integration, усі проходять, покриття рядків 93,4%. Тести знайшли реальні баги: Forbid давав 500, Secure-cookie ламала сесію, конфлікт двох провайдерів БД. CI у GitHub Actions (обидва репозиторії) зелений. Логування: ILogger і глобальний ExceptionHandlingMiddleware.</a:t>
             </a:r>
             <a:endParaRPr lang="en-US" dirty="0"/>
           </a:p>
@@ -740,7 +740,7 @@
           <a:p>
             <a:r>
               <a:rPr lang="en-US" dirty="0"/>
-              <a:t>Покриття коду 91,1%. 13 із 13 вимог SRS, 33 ендпоінти, 78 комітів (бекенд 56 і фронтенд 22), 18 merge-комітів, чотири тижні розробки. Усі цифри виміряні з репозиторіїв і прогону тестів.</a:t>
+              <a:t>13 із 13 вимог SRS, 34 ендпоїнти, 295 тестів із покриттям 93,4%, 114 комітів (бекенд 71 і фронтенд 43), 70 товарів, 8 тижневих спринтів. CI зелений, ZAP: 0 High. Цифри виміряно з репозиторіїв і прогону тестів 19.10.</a:t>
             </a:r>
             <a:endParaRPr lang="en-US" dirty="0"/>
           </a:p>
@@ -828,7 +828,7 @@
           <a:p>
             <a:r>
               <a:rPr lang="en-US" dirty="0"/>
-              <a:t>Шість спринтів за графіком курсу, беклог і канбан-стан на 14 жовтня. Jira-дошка команди: SCRUM board. Внесок учасників і гілки показані в додатку.</a:t>
+              <a:t>Вісім спринтів у Jira, кожен по одному тижню (не по два). Спринти 1-7 закрито, спринт 8 активний. 44 задачі, 33 виконано. Чесно: статуси в Jira відстають від коду, а внесок Team Lead (Панчук Вадим) у Git відсутній: 0 комітів, його роль у плануванні, Jira й документах.</a:t>
             </a:r>
             <a:endParaRPr lang="en-US" dirty="0"/>
           </a:p>
@@ -1004,7 +1004,7 @@
           <a:p>
             <a:r>
               <a:rPr lang="en-US" dirty="0"/>
-              <a:t>Живий сайт newbalance.cc.cd: 18 товарів, реальні фото з вільних ліцензій, фільтри в адресі, галерея з трьох кадрів і вибір розміру. Розмір можна обрати прямо на картці в каталозі.</a:t>
+              <a:t>Живий сайт newbalance.cc.cd у стилі newbalance.com: чорна смуга, біла шапка, герой, плитки категорій, добірка. Каталог з фільтрами ліворуч: стать, категорія, тип, розмір, ціна, сортування; усе в адресі. 70 товарів, UA/EN/FR. Фото й назви з newbalance.com: навчальний макет, не афілійований з брендом.</a:t>
             </a:r>
             <a:endParaRPr lang="en-US" dirty="0"/>
           </a:p>
@@ -1092,7 +1092,7 @@
           <a:p>
             <a:r>
               <a:rPr lang="en-US" dirty="0"/>
-              <a:t>Сценарій покупця: кошик із розмірами, оформлення без обов'язкової реєстрації, обране. Покупець береться із сесії на сервері, гість оформляє на службового Гостя.</a:t>
+              <a:t>Сценарій покупця: кошик із розмірами, оформлення без обов'язкової реєстрації, обране. Покупець береться із сесії на сервері, гість оформляє на службового Гостя. Оплати немає: це навчальний макет.</a:t>
             </a:r>
             <a:endParaRPr lang="en-US" dirty="0"/>
           </a:p>
@@ -1180,7 +1180,7 @@
           <a:p>
             <a:r>
               <a:rPr lang="en-US" dirty="0"/>
-              <a:t>Сценарій перший: реєстрація і вхід нового користувача. Одна сторінка з перемикачем, email і пароль, Google, GitHub. Куки працюють, бо запити йдуть через домен сайту.</a:t>
+              <a:t>Сценарій перший: реєстрація й вхід нового користувача. Одна сторінка з перемикачем, email і пароль від 8 символів, або Google. Куки працюють, бо запити йдуть через домен сайту.</a:t>
             </a:r>
             <a:endParaRPr lang="en-US" dirty="0"/>
           </a:p>
@@ -1268,7 +1268,7 @@
           <a:p>
             <a:r>
               <a:rPr lang="en-US" dirty="0"/>
-              <a:t>Сценарій другий: адмін-панель. Користувачі (блокування, видалення), товари (додати, змінити, видалити з розмірами і фото), замовлення (статуси). Усе захищене ролью: 401 без входу, 403 для звичайного покупця.</a:t>
+              <a:t>Сценарій другий: адмін-панель модератора. Користувачі (блокування, видалення), товари (додати, змінити, видалити), замовлення (статуси). Захищено роллю: 401 без входу, 403 для звичайного покупця. Персональні дані на знімку приховано.</a:t>
             </a:r>
             <a:endParaRPr lang="en-US" dirty="0"/>
           </a:p>
@@ -1356,7 +1356,7 @@
           <a:p>
             <a:r>
               <a:rPr lang="en-US" dirty="0"/>
-              <a:t>Сайт адаптовано під телефон: шапка переноситься, меню прокручується, товари в дві колонки, розміри на картці, адмін-таблиці стають картками. Скріни зроблено на живому коді.</a:t>
+              <a:t>Мобільна версія 390 px: шапка переноситься, меню прокручується, картка товару з мініатюрами. Чесно: сітка каталогу у дві колонки на вузькому екрані має зсув правої колонки, у планах виправлення.</a:t>
             </a:r>
             <a:endParaRPr lang="en-US" dirty="0"/>
           </a:p>
@@ -1444,7 +1444,7 @@
           <a:p>
             <a:r>
               <a:rPr lang="en-US" dirty="0"/>
-              <a:t>Для розробників: повний цикл від вимог до деплою. Для цільової аудиторії: швидка покупка, кабінет, три мови. Монетизація: комісія, доставка, оплата, реклама.</a:t>
+              <a:t>Для розробників: повний цикл від вимог до деплою, 295 тестів, CI. Для цільової аудиторії: швидка покупка, кабінет, три мови. Монетизація: комісія, доставка, оплата, реклама.</a:t>
             </a:r>
             <a:endParaRPr lang="en-US" dirty="0"/>
           </a:p>
@@ -2060,7 +2060,7 @@
           <a:p>
             <a:r>
               <a:rPr lang="en-US" dirty="0"/>
-              <a:t>UI Kit: червоно-чорна палітра, один шрифт. Орієнтир інтерфейсу: newbalance.com. Офіційні фото бренду не використовуємо, замість них типографські плитки. Персони, Empathy Map і CJM складено командою на основі сценарію використання, без опитування реальних користувачів.</a:t>
+              <a:t>UI Kit: чорне, біле, червоний акцент, заголовки Cormorant Garamond, текст Mulish, круглі кнопки. Орієнтир: newbalance.com. Фото й назви товарів з newbalance.com, навчальний макет без афілійованості з брендом.</a:t>
             </a:r>
             <a:endParaRPr lang="en-US" dirty="0"/>
           </a:p>
@@ -2148,7 +2148,7 @@
           <a:p>
             <a:r>
               <a:rPr lang="en-US" dirty="0"/>
-              <a:t>React на Vercel, API на ASP.NET Core 9 у Docker на Render, PostgreSQL на Render. Запити /api йдуть на той самий домен сайту, а Vercel проксує їх на сервер: так сесійна кука належить сайту й браузер її не блокує. Вхід через Google (Firebase) і GitHub OAuth.</a:t>
+              <a:t>React на Vercel, API на ASP.NET Core 9 у Docker на Render, PostgreSQL на Render. Запити /api ідуть на той самий домен сайту, а Vercel проксує їх на сервер: так сесійна кука належить сайту й браузер її не блокує. Вхід: пароль і Google (Firebase), GitHub-вхід прибрано.</a:t>
             </a:r>
             <a:endParaRPr lang="en-US" dirty="0"/>
           </a:p>
@@ -2500,7 +2500,7 @@
           <a:p>
             <a:r>
               <a:rPr lang="en-US" dirty="0"/>
-              <a:t>Три способи входу: пароль, Google, GitHub. Паролі зберігаються як PBKDF2 із сіллю, 100 000 ітерацій. Закрито: BOLA (покупець береться із сесії), запис товарів лише для адміністратора, білий список CORS, rate limiting на вхід, унікальний email, пароль адміна прибрано з коду. Ще в плані: сесії в Redis або БД і звіт ZAP.</a:t>
+              <a:t>Два способи входу: пароль і Google. Паролі зберігаються як PBKDF2 із сіллю, 100 000 ітерацій. Закрито: BOLA (покупець береться із сесії), запис товарів лише для адміністратора, білий список CORS, rate limiting на вхід, унікальний email, пароль адміна прибрано з коду. Заголовки CSP, X-Frame-Options, nosniff, Permissions-Policy додано після звіту OWASP ZAP: було 0 High, 4 Medium, 4 Low. Відкрито чесно: сесії в пам'яті процесу, SRI, COOP/COEP.</a:t>
             </a:r>
             <a:endParaRPr lang="en-US" dirty="0"/>
           </a:p>

</xml_diff>

<commit_message>
Slide 5: remove stray arrow left after dropping GitHub login
</commit_message>
<xml_diff>
--- a/defense-materials/NewBalanceShop-presentation.pptx
+++ b/defense-materials/NewBalanceShop-presentation.pptx
@@ -129,7 +129,7 @@
   <p:extLst>
     <p:ext uri="{521415D9-36F7-43E2-AB2F-B90AF26B5E84}">
       <p14:sectionLst xmlns:p14="http://schemas.microsoft.com/office/powerpoint/2010/main">
-        <p14:section name="Доповідь" id="{9414b494-3e0f-898c-4cae-ac4c2c798f6c}">
+        <p14:section name="Доповідь" id="{4c23f2a1-3ebb-7f84-0d16-15cf58ef228d}">
           <p14:sldIdLst>
             <p14:sldId id="256"/>
             <p14:sldId id="257"/>
@@ -153,7 +153,7 @@
             <p14:sldId id="275"/>
           </p14:sldIdLst>
         </p14:section>
-        <p14:section name="Додатки (запасні слайди)" id="{3576b0e6-524e-90dc-d26a-b8bd42de1206}">
+        <p14:section name="Додатки (запасні слайди)" id="{b9f68535-e3e9-e2ef-4647-19888732f43c}">
           <p14:sldIdLst>
             <p14:sldId id="276"/>
             <p14:sldId id="277"/>

</xml_diff>

<commit_message>
Slide 5: shorten DB label so it fits the box
</commit_message>
<xml_diff>
--- a/defense-materials/NewBalanceShop-presentation.pptx
+++ b/defense-materials/NewBalanceShop-presentation.pptx
@@ -129,7 +129,7 @@
   <p:extLst>
     <p:ext uri="{521415D9-36F7-43E2-AB2F-B90AF26B5E84}">
       <p14:sectionLst xmlns:p14="http://schemas.microsoft.com/office/powerpoint/2010/main">
-        <p14:section name="Доповідь" id="{4c23f2a1-3ebb-7f84-0d16-15cf58ef228d}">
+        <p14:section name="Доповідь" id="{db1c0749-7238-185e-a385-8314f8ca2d16}">
           <p14:sldIdLst>
             <p14:sldId id="256"/>
             <p14:sldId id="257"/>
@@ -153,7 +153,7 @@
             <p14:sldId id="275"/>
           </p14:sldIdLst>
         </p14:section>
-        <p14:section name="Додатки (запасні слайди)" id="{b9f68535-e3e9-e2ef-4647-19888732f43c}">
+        <p14:section name="Додатки (запасні слайди)" id="{e8712e7a-bb8e-cf88-3563-897d968fbb84}">
           <p14:sldIdLst>
             <p14:sldId id="276"/>
             <p14:sldId id="277"/>

</xml_diff>

<commit_message>
Move closing slide to the end of the deck
</commit_message>
<xml_diff>
--- a/defense-materials/NewBalanceShop-presentation.pptx
+++ b/defense-materials/NewBalanceShop-presentation.pptx
@@ -129,7 +129,7 @@
   <p:extLst>
     <p:ext uri="{521415D9-36F7-43E2-AB2F-B90AF26B5E84}">
       <p14:sectionLst xmlns:p14="http://schemas.microsoft.com/office/powerpoint/2010/main">
-        <p14:section name="Доповідь" id="{db1c0749-7238-185e-a385-8314f8ca2d16}">
+        <p14:section name="Доповідь" id="{8b287ba3-7c26-cc8e-8386-27f59f645bce}">
           <p14:sldIdLst>
             <p14:sldId id="256"/>
             <p14:sldId id="257"/>
@@ -150,13 +150,17 @@
             <p14:sldId id="272"/>
             <p14:sldId id="273"/>
             <p14:sldId id="274"/>
-            <p14:sldId id="275"/>
           </p14:sldIdLst>
         </p14:section>
-        <p14:section name="Додатки (запасні слайди)" id="{e8712e7a-bb8e-cf88-3563-897d968fbb84}">
+        <p14:section name="Додатки (запасні слайди)" id="{bda6fbd9-6ab7-f24a-b839-a85895ac17cd}">
           <p14:sldIdLst>
+            <p14:sldId id="275"/>
             <p14:sldId id="276"/>
             <p14:sldId id="277"/>
+          </p14:sldIdLst>
+        </p14:section>
+        <p14:section name="Фінал" id="{8742e05e-c4f5-7c61-cb8e-923a0ac584d5}">
+          <p14:sldIdLst>
             <p14:sldId id="278"/>
           </p14:sldIdLst>
         </p14:section>
@@ -1620,7 +1624,7 @@
           <a:p>
             <a:r>
               <a:rPr lang="en-US" dirty="0"/>
-              <a:t>Ключова думка: від каталогу до замовлення за кілька кліків, без зайвої реєстрації. Дякуємо за увагу, готові до запитань. QR-коди ведуть на живий сайт, код і документацію.</a:t>
+              <a:t>Резервний слайд. Ключові класи за шарами: контролери, сервіси, сутності Domain, репозиторії та DbContext.</a:t>
             </a:r>
             <a:endParaRPr lang="en-US" dirty="0"/>
           </a:p>
@@ -1708,7 +1712,7 @@
           <a:p>
             <a:r>
               <a:rPr lang="en-US" dirty="0"/>
-              <a:t>Резервний слайд. Ключові класи за шарами: контролери, сервіси, сутності Domain, репозиторії та DbContext.</a:t>
+              <a:t>Резервний слайд. 78 комітів за днями, гілки feature і fix з merge-комітами, внесок учасників. Внесок Team Lead у планування й Jira у Git не видно.</a:t>
             </a:r>
             <a:endParaRPr lang="en-US" dirty="0"/>
           </a:p>
@@ -1796,7 +1800,7 @@
           <a:p>
             <a:r>
               <a:rPr lang="en-US" dirty="0"/>
-              <a:t>Резервний слайд. 78 комітів за днями, гілки feature і fix з merge-комітами, внесок учасників. Внесок Team Lead у планування й Jira у Git не видно.</a:t>
+              <a:t>Резервний слайд. README за шаблоном викладача, SRS, архітектура, Scalar-документація API, Swagger, DocFX на GitHub Pages.</a:t>
             </a:r>
             <a:endParaRPr lang="en-US" dirty="0"/>
           </a:p>
@@ -1884,7 +1888,7 @@
           <a:p>
             <a:r>
               <a:rPr lang="en-US" dirty="0"/>
-              <a:t>Резервний слайд. README за шаблоном викладача, SRS, архітектура, Scalar-документація API, Swagger, DocFX на GitHub Pages.</a:t>
+              <a:t>Ключова думка: від каталогу до замовлення за кілька кліків, без зайвої реєстрації. Дякуємо за увагу, готові до запитань. QR-коди ведуть на живий сайт, код і документацію.</a:t>
             </a:r>
             <a:endParaRPr lang="en-US" dirty="0"/>
           </a:p>
@@ -3547,62 +3551,6 @@
       </p:grpSpPr>
       <p:pic>
         <p:nvPicPr>
-          <p:cNvPr id="2" name="Image 0" descr="Ключова думка проєкту і запитання">    </p:cNvPr>
-          <p:cNvPicPr>
-            <a:picLocks noChangeAspect="1"/>
-          </p:cNvPicPr>
-          <p:nvPr/>
-        </p:nvPicPr>
-        <p:blipFill>
-          <a:blip r:embed="rId1"/>
-          <a:stretch>
-            <a:fillRect/>
-          </a:stretch>
-        </p:blipFill>
-        <p:spPr>
-          <a:xfrm>
-            <a:off x="0" y="0"/>
-            <a:ext cx="12191695" cy="6858000"/>
-          </a:xfrm>
-          <a:prstGeom prst="rect">
-            <a:avLst/>
-          </a:prstGeom>
-        </p:spPr>
-      </p:pic>
-    </p:spTree>
-  </p:cSld>
-  <p:clrMapOvr>
-    <a:masterClrMapping/>
-  </p:clrMapOvr>
-</p:sld>
-</file>
-
-<file path=ppt/slides/slide21.xml><?xml version="1.0" encoding="utf-8"?>
-<p:sld xmlns:a="http://schemas.openxmlformats.org/drawingml/2006/main" xmlns:r="http://schemas.openxmlformats.org/officeDocument/2006/relationships" xmlns:p="http://schemas.openxmlformats.org/presentationml/2006/main">
-  <p:cSld name="Slide 21">
-    <p:bg>
-      <p:bgPr>
-        <a:solidFill>
-          <a:srgbClr val="111111"/>
-        </a:solidFill>
-      </p:bgPr>
-    </p:bg>
-    <p:spTree>
-      <p:nvGrpSpPr>
-        <p:cNvPr id="1" name=""/>
-        <p:cNvGrpSpPr/>
-        <p:nvPr/>
-      </p:nvGrpSpPr>
-      <p:grpSpPr>
-        <a:xfrm>
-          <a:off x="0" y="0"/>
-          <a:ext cx="0" cy="0"/>
-          <a:chOff x="0" y="0"/>
-          <a:chExt cx="0" cy="0"/>
-        </a:xfrm>
-      </p:grpSpPr>
-      <p:pic>
-        <p:nvPicPr>
           <p:cNvPr id="2" name="Image 0" descr="Додаток: діаграма класів">    </p:cNvPr>
           <p:cNvPicPr>
             <a:picLocks noChangeAspect="1"/>
@@ -3633,9 +3581,9 @@
 </p:sld>
 </file>
 
-<file path=ppt/slides/slide22.xml><?xml version="1.0" encoding="utf-8"?>
+<file path=ppt/slides/slide21.xml><?xml version="1.0" encoding="utf-8"?>
 <p:sld xmlns:a="http://schemas.openxmlformats.org/drawingml/2006/main" xmlns:r="http://schemas.openxmlformats.org/officeDocument/2006/relationships" xmlns:p="http://schemas.openxmlformats.org/presentationml/2006/main">
-  <p:cSld name="Slide 22">
+  <p:cSld name="Slide 21">
     <p:bg>
       <p:bgPr>
         <a:solidFill>
@@ -3689,6 +3637,62 @@
 </p:sld>
 </file>
 
+<file path=ppt/slides/slide22.xml><?xml version="1.0" encoding="utf-8"?>
+<p:sld xmlns:a="http://schemas.openxmlformats.org/drawingml/2006/main" xmlns:r="http://schemas.openxmlformats.org/officeDocument/2006/relationships" xmlns:p="http://schemas.openxmlformats.org/presentationml/2006/main">
+  <p:cSld name="Slide 22">
+    <p:bg>
+      <p:bgPr>
+        <a:solidFill>
+          <a:srgbClr val="111111"/>
+        </a:solidFill>
+      </p:bgPr>
+    </p:bg>
+    <p:spTree>
+      <p:nvGrpSpPr>
+        <p:cNvPr id="1" name=""/>
+        <p:cNvGrpSpPr/>
+        <p:nvPr/>
+      </p:nvGrpSpPr>
+      <p:grpSpPr>
+        <a:xfrm>
+          <a:off x="0" y="0"/>
+          <a:ext cx="0" cy="0"/>
+          <a:chOff x="0" y="0"/>
+          <a:chExt cx="0" cy="0"/>
+        </a:xfrm>
+      </p:grpSpPr>
+      <p:pic>
+        <p:nvPicPr>
+          <p:cNvPr id="2" name="Image 0" descr="Додаток: документація">    </p:cNvPr>
+          <p:cNvPicPr>
+            <a:picLocks noChangeAspect="1"/>
+          </p:cNvPicPr>
+          <p:nvPr/>
+        </p:nvPicPr>
+        <p:blipFill>
+          <a:blip r:embed="rId1"/>
+          <a:stretch>
+            <a:fillRect/>
+          </a:stretch>
+        </p:blipFill>
+        <p:spPr>
+          <a:xfrm>
+            <a:off x="0" y="0"/>
+            <a:ext cx="12191695" cy="6858000"/>
+          </a:xfrm>
+          <a:prstGeom prst="rect">
+            <a:avLst/>
+          </a:prstGeom>
+        </p:spPr>
+      </p:pic>
+    </p:spTree>
+  </p:cSld>
+  <p:clrMapOvr>
+    <a:masterClrMapping/>
+  </p:clrMapOvr>
+</p:sld>
+</file>
+
 <file path=ppt/slides/slide23.xml><?xml version="1.0" encoding="utf-8"?>
 <p:sld xmlns:a="http://schemas.openxmlformats.org/drawingml/2006/main" xmlns:r="http://schemas.openxmlformats.org/officeDocument/2006/relationships" xmlns:p="http://schemas.openxmlformats.org/presentationml/2006/main">
   <p:cSld name="Slide 23">
@@ -3715,7 +3719,7 @@
       </p:grpSpPr>
       <p:pic>
         <p:nvPicPr>
-          <p:cNvPr id="2" name="Image 0" descr="Додаток: документація">    </p:cNvPr>
+          <p:cNvPr id="2" name="Image 0" descr="Ключова думка проєкту і запитання">    </p:cNvPr>
           <p:cNvPicPr>
             <a:picLocks noChangeAspect="1"/>
           </p:cNvPicPr>

</xml_diff>

<commit_message>
docs: rebuild deck with clickable links and links slide
</commit_message>
<xml_diff>
--- a/defense-materials/NewBalanceShop-presentation.pptx
+++ b/defense-materials/NewBalanceShop-presentation.pptx
@@ -28,9 +28,14 @@
     <p:sldId id="276" r:id="rId22"/>
     <p:sldId id="277" r:id="rId23"/>
     <p:sldId id="278" r:id="rId24"/>
+    <p:sldId id="279" r:id="rId25"/>
+    <p:sldId id="280" r:id="rId26"/>
+    <p:sldId id="281" r:id="rId27"/>
+    <p:sldId id="282" r:id="rId28"/>
+    <p:sldId id="283" r:id="rId29"/>
   </p:sldIdLst>
   <p:notesMasterIdLst>
-    <p:notesMasterId r:id="rId25"/>
+    <p:notesMasterId r:id="rId30"/>
   </p:notesMasterIdLst>
   <p:sldSz cx="12192000" cy="6858000"/>
   <p:notesSz cx="6858000" cy="12192000"/>
@@ -129,7 +134,7 @@
   <p:extLst>
     <p:ext uri="{521415D9-36F7-43E2-AB2F-B90AF26B5E84}">
       <p14:sectionLst xmlns:p14="http://schemas.microsoft.com/office/powerpoint/2010/main">
-        <p14:section name="Доповідь" id="{8b287ba3-7c26-cc8e-8386-27f59f645bce}">
+        <p14:section name="Доповідь" id="{bbfbffc3-593c-097b-7294-c63454278678}">
           <p14:sldIdLst>
             <p14:sldId id="256"/>
             <p14:sldId id="257"/>
@@ -139,6 +144,10 @@
             <p14:sldId id="261"/>
             <p14:sldId id="262"/>
             <p14:sldId id="263"/>
+          </p14:sldIdLst>
+        </p14:section>
+        <p14:section name="Додатки (запасні слайди)" id="{267287c3-39fc-c54b-32d3-72d4ea457d9f}">
+          <p14:sldIdLst>
             <p14:sldId id="264"/>
             <p14:sldId id="265"/>
             <p14:sldId id="266"/>
@@ -150,18 +159,19 @@
             <p14:sldId id="272"/>
             <p14:sldId id="273"/>
             <p14:sldId id="274"/>
-          </p14:sldIdLst>
-        </p14:section>
-        <p14:section name="Додатки (запасні слайди)" id="{bda6fbd9-6ab7-f24a-b839-a85895ac17cd}">
-          <p14:sldIdLst>
             <p14:sldId id="275"/>
             <p14:sldId id="276"/>
             <p14:sldId id="277"/>
+            <p14:sldId id="278"/>
+            <p14:sldId id="279"/>
+            <p14:sldId id="280"/>
+            <p14:sldId id="281"/>
+            <p14:sldId id="282"/>
           </p14:sldIdLst>
         </p14:section>
-        <p14:section name="Фінал" id="{8742e05e-c4f5-7c61-cb8e-923a0ac584d5}">
+        <p14:section name="Запитання" id="{32e45559-ee65-695b-86c2-02fcb5ccdfd5}">
           <p14:sldIdLst>
-            <p14:sldId id="278"/>
+            <p14:sldId id="283"/>
           </p14:sldIdLst>
         </p14:section>
       </p14:sectionLst>
@@ -568,7 +578,7 @@
           <a:p>
             <a:r>
               <a:rPr lang="en-US" dirty="0"/>
-              <a:t>Команда Team 1, проєкт New Balance Shop: інтернет-магазин спортивного одягу та взуття. Склад команди та ролі. QR-коди ведуть на репозиторій і живий сайт.</a:t>
+              <a:t>Вадим. Команда Team 1, проєкт New Balance Shop. Двоє учасників: Вадим Панчук, Team Lead, вимоги, план, Scrum; Рафаїл Ноцколіні, full-stack: код, архітектура, безпека, демо.</a:t>
             </a:r>
             <a:endParaRPr lang="en-US" dirty="0"/>
           </a:p>
@@ -656,7 +666,7 @@
           <a:p>
             <a:r>
               <a:rPr lang="en-US" dirty="0"/>
-              <a:t>295 тестів: 190 unit і 105 integration, усі проходять, покриття рядків 93,4%. Тести знайшли реальні баги: Forbid давав 500, Secure-cookie ламала сесію, конфлікт двох провайдерів БД. CI у GitHub Actions (обидва репозиторії) зелений. Логування: ILogger і глобальний ExceptionHandlingMiddleware.</a:t>
+              <a:t>Запасний слайд. UI Kit: чорне, біле, червоний акцент, заголовки Cormorant Garamond, текст Mulish, круглі кнопки. Орієнтир: newbalance.com. Фото й назви товарів з newbalance.com, навчальний макет без афілійованості з брендом.</a:t>
             </a:r>
             <a:endParaRPr lang="en-US" dirty="0"/>
           </a:p>
@@ -744,7 +754,7 @@
           <a:p>
             <a:r>
               <a:rPr lang="en-US" dirty="0"/>
-              <a:t>13 із 13 вимог SRS, 34 ендпоїнти, 295 тестів із покриттям 93,4%, 114 комітів (бекенд 71 і фронтенд 43), 70 товарів, 8 тижневих спринтів. CI зелений, ZAP: 0 High. Цифри виміряно з репозиторіїв і прогону тестів 19.10.</a:t>
+              <a:t>Запасний слайд. React на Vercel, API на ASP.NET Core 9 у Docker на Render, PostgreSQL на Render. Запити /api ідуть на той самий домен сайту, а Vercel проксує їх на сервер: так сесійна кука належить сайту й браузер її не блокує. Вхід: пароль і Google (Firebase), GitHub-вхід прибрано.</a:t>
             </a:r>
             <a:endParaRPr lang="en-US" dirty="0"/>
           </a:p>
@@ -832,7 +842,7 @@
           <a:p>
             <a:r>
               <a:rPr lang="en-US" dirty="0"/>
-              <a:t>Вісім спринтів у Jira, кожен по одному тижню (не по два). Спринти 1-7 закрито, спринт 8 активний. 44 задачі, 33 виконано. Чесно: статуси в Jira відстають від коду, а внесок Team Lead (Панчук Вадим) у Git відсутній: 0 комітів, його роль у плануванні, Jira й документах.</a:t>
+              <a:t>Запасний слайд. Чотири проєкти: Domain без залежностей, Application залежить від Domain, Infrastructure реалізує репозиторії та перевірку Google-токена, Web API збирає все через DI. Раніше Firebase SDK лежав в Application, тепер він схований за інтерфейсом IGoogleTokenVerifier.</a:t>
             </a:r>
             <a:endParaRPr lang="en-US" dirty="0"/>
           </a:p>
@@ -920,7 +930,7 @@
           <a:p>
             <a:r>
               <a:rPr lang="en-US" dirty="0"/>
-              <a:t>Інструменти: .NET, PostgreSQL, EF Core, React, Vite, xUnit, Docker, GitHub, Jira. Шлях коду: git push, Render збирає Docker, Vercel збирає React, і сайт онлайн.</a:t>
+              <a:t>Запасний слайд. Резервний слайд. Ключові класи за шарами: контролери, сервіси, сутності Domain, репозиторії та DbContext.</a:t>
             </a:r>
             <a:endParaRPr lang="en-US" dirty="0"/>
           </a:p>
@@ -1008,7 +1018,7 @@
           <a:p>
             <a:r>
               <a:rPr lang="en-US" dirty="0"/>
-              <a:t>Живий сайт newbalance.cc.cd у стилі newbalance.com: чорна смуга, біла шапка, герой, плитки категорій, добірка. Каталог з фільтрами ліворуч: стать, категорія, тип, розмір, ціна, сортування; усе в адресі. 70 товарів, UA/EN/FR. Фото й назви з newbalance.com: навчальний макет, не афілійований з брендом.</a:t>
+              <a:t>Запасний слайд. Repository, Dependency Injection, Service Layer, DTO з мапером, Middleware Pipeline, Session State. До кожного патерна одне речення: навіщо він у нашому проєкті.</a:t>
             </a:r>
             <a:endParaRPr lang="en-US" dirty="0"/>
           </a:p>
@@ -1096,7 +1106,7 @@
           <a:p>
             <a:r>
               <a:rPr lang="en-US" dirty="0"/>
-              <a:t>Сценарій покупця: кошик із розмірами, оформлення без обов'язкової реєстрації, обране. Покупець береться із сесії на сервері, гість оформляє на службового Гостя. Оплати немає: це навчальний макет.</a:t>
+              <a:t>Запасний слайд. PostgreSQL: реляційні зв'язки замовлення, позиції, товар, потрібна транзакційність, безкоштовно на Render. У товару список розмірів і галерея, у позиції замовлення обраний розмір. Унікальний Email, покупця із замовленнями видалити не можна. Що покращити: залишок окремо по кожному розміру.</a:t>
             </a:r>
             <a:endParaRPr lang="en-US" dirty="0"/>
           </a:p>
@@ -1184,7 +1194,7 @@
           <a:p>
             <a:r>
               <a:rPr lang="en-US" dirty="0"/>
-              <a:t>Сценарій перший: реєстрація й вхід нового користувача. Одна сторінка з перемикачем, email і пароль від 8 символів, або Google. Куки працюють, бо запити йдуть через домен сайту.</a:t>
+              <a:t>Запасний слайд. Два способи входу: пароль і Google. Паролі зберігаються як PBKDF2 із сіллю, 100 000 ітерацій. Закрито: BOLA (покупець береться із сесії), запис товарів лише для адміністратора, білий список CORS, rate limiting на вхід, унікальний email, пароль адміна прибрано з коду. Заголовки CSP, X-Frame-Options, nosniff, Permissions-Policy додано після звіту OWASP ZAP: було 0 High, 4 Medium, 4 Low. Відкрито чесно: сесії в пам'яті процесу, SRI, COOP/COEP.</a:t>
             </a:r>
             <a:endParaRPr lang="en-US" dirty="0"/>
           </a:p>
@@ -1272,7 +1282,7 @@
           <a:p>
             <a:r>
               <a:rPr lang="en-US" dirty="0"/>
-              <a:t>Сценарій другий: адмін-панель модератора. Користувачі (блокування, видалення), товари (додати, змінити, видалити), замовлення (статуси). Захищено роллю: 401 без входу, 403 для звичайного покупця. Персональні дані на знімку приховано.</a:t>
+              <a:t>Запасний слайд. 295 тестів: 190 unit і 105 integration, усі проходять, покриття рядків 93,4%. Тести знайшли реальні баги: Forbid давав 500, Secure-cookie ламала сесію, конфлікт двох провайдерів БД. CI у GitHub Actions (обидва репозиторії) зелений. Логування: ILogger і глобальний ExceptionHandlingMiddleware.</a:t>
             </a:r>
             <a:endParaRPr lang="en-US" dirty="0"/>
           </a:p>
@@ -1360,7 +1370,7 @@
           <a:p>
             <a:r>
               <a:rPr lang="en-US" dirty="0"/>
-              <a:t>Мобільна версія 390 px: шапка переноситься, меню прокручується, картка товару з мініатюрами. Чесно: сітка каталогу у дві колонки на вузькому екрані має зсув правої колонки, у планах виправлення.</a:t>
+              <a:t>Запасний слайд. 13 із 13 вимог SRS, 34 ендпоїнти, 295 тестів із покриттям 93,4%, 114 комітів (бекенд 71 і фронтенд 43), 70 товарів, 8 тижневих спринтів. CI зелений, ZAP: 0 High. Цифри виміряно з репозиторіїв і прогону тестів 19.10.</a:t>
             </a:r>
             <a:endParaRPr lang="en-US" dirty="0"/>
           </a:p>
@@ -1448,7 +1458,7 @@
           <a:p>
             <a:r>
               <a:rPr lang="en-US" dirty="0"/>
-              <a:t>Для розробників: повний цикл від вимог до деплою, 295 тестів, CI. Для цільової аудиторії: швидка покупка, кабінет, три мови. Монетизація: комісія, доставка, оплата, реклама.</a:t>
+              <a:t>Запасний слайд. Резервний слайд. 78 комітів за днями, гілки feature і fix з merge-комітами, внесок учасників. Внесок Team Lead у планування й Jira у Git не видно.</a:t>
             </a:r>
             <a:endParaRPr lang="en-US" dirty="0"/>
           </a:p>
@@ -1536,7 +1546,7 @@
           <a:p>
             <a:r>
               <a:rPr lang="en-US" dirty="0"/>
-              <a:t>Проблема: складно швидко знайти й купити потрібну пару, часто змушують реєструватися, кошик зникає. Рішення: каталог, кошик у сесії, замовлення без акаунта, кабінет покупця, адмін-функції, три мови. ЦА: покупці 16–40 років, любителі бігу, адміністратор магазину.</a:t>
+              <a:t>Вадим. Проблема: складно швидко знайти й купити потрібну пару. Рішення: каталог, кошик, замовлення без зайвої реєстрації. Аудиторія: покупці 16-40 років.</a:t>
             </a:r>
             <a:endParaRPr lang="en-US" dirty="0"/>
           </a:p>
@@ -1624,7 +1634,7 @@
           <a:p>
             <a:r>
               <a:rPr lang="en-US" dirty="0"/>
-              <a:t>Резервний слайд. Ключові класи за шарами: контролери, сервіси, сутності Domain, репозиторії та DbContext.</a:t>
+              <a:t>Запасний слайд. Інструменти: .NET, PostgreSQL, EF Core, React, Vite, xUnit, Docker, GitHub, Jira. Шлях коду: git push, Render збирає Docker, Vercel збирає React, і сайт онлайн.</a:t>
             </a:r>
             <a:endParaRPr lang="en-US" dirty="0"/>
           </a:p>
@@ -1712,7 +1722,7 @@
           <a:p>
             <a:r>
               <a:rPr lang="en-US" dirty="0"/>
-              <a:t>Резервний слайд. 78 комітів за днями, гілки feature і fix з merge-комітами, внесок учасників. Внесок Team Lead у планування й Jira у Git не видно.</a:t>
+              <a:t>Запасний слайд. Резервний слайд. README за шаблоном викладача, SRS, архітектура, Scalar-документація API, Swagger, DocFX на GitHub Pages.</a:t>
             </a:r>
             <a:endParaRPr lang="en-US" dirty="0"/>
           </a:p>
@@ -1800,7 +1810,7 @@
           <a:p>
             <a:r>
               <a:rPr lang="en-US" dirty="0"/>
-              <a:t>Резервний слайд. README за шаблоном викладача, SRS, архітектура, Scalar-документація API, Swagger, DocFX на GitHub Pages.</a:t>
+              <a:t>Запасний слайд. Живий сайт newbalance.cc.cd у стилі newbalance.com: чорна смуга, біла шапка, герой, плитки категорій, добірка. Каталог з фільтрами ліворуч: стать, категорія, тип, розмір, ціна, сортування; усе в адресі. 70 товарів, UA/EN/FR. Фото й назви з newbalance.com: навчальний макет, не афілійований з брендом.</a:t>
             </a:r>
             <a:endParaRPr lang="en-US" dirty="0"/>
           </a:p>
@@ -1888,7 +1898,7 @@
           <a:p>
             <a:r>
               <a:rPr lang="en-US" dirty="0"/>
-              <a:t>Ключова думка: від каталогу до замовлення за кілька кліків, без зайвої реєстрації. Дякуємо за увагу, готові до запитань. QR-коди ведуть на живий сайт, код і документацію.</a:t>
+              <a:t>Запасний слайд. Сценарій покупця: кошик із розмірами, оформлення без обов'язкової реєстрації, обране. Покупець береться із сесії на сервері, гість оформляє на службового Гостя. Оплати немає: це навчальний макет.</a:t>
             </a:r>
             <a:endParaRPr lang="en-US" dirty="0"/>
           </a:p>
@@ -1912,6 +1922,446 @@
             <a:fld id="{F7021451-1387-4CA6-816F-3879F97B5CBC}" type="slidenum">
               <a:rPr lang="en-US"/>
               <a:t>23</a:t>
+            </a:fld>
+            <a:endParaRPr lang="en-US"/>
+          </a:p>
+        </p:txBody>
+      </p:sp>
+    </p:spTree>
+    <p:extLst>
+      <p:ext uri="{BB962C8B-B14F-4D97-AF65-F5344CB8AC3E}">
+        <p14:creationId xmlns:p14="http://schemas.microsoft.com/office/powerpoint/2010/main" val="1024086991"/>
+      </p:ext>
+    </p:extLst>
+  </p:cSld>
+  <p:clrMapOvr>
+    <a:masterClrMapping/>
+  </p:clrMapOvr>
+</p:notes>
+</file>
+
+<file path=ppt/notesSlides/notesSlide24.xml><?xml version="1.0" encoding="utf-8"?>
+<p:notes xmlns:a="http://schemas.openxmlformats.org/drawingml/2006/main" xmlns:r="http://schemas.openxmlformats.org/officeDocument/2006/relationships" xmlns:p="http://schemas.openxmlformats.org/presentationml/2006/main">
+  <p:cSld>
+    <p:spTree>
+      <p:nvGrpSpPr>
+        <p:cNvPr id="1" name=""/>
+        <p:cNvGrpSpPr/>
+        <p:nvPr/>
+      </p:nvGrpSpPr>
+      <p:grpSpPr>
+        <a:xfrm>
+          <a:off x="0" y="0"/>
+          <a:ext cx="0" cy="0"/>
+          <a:chOff x="0" y="0"/>
+          <a:chExt cx="0" cy="0"/>
+        </a:xfrm>
+      </p:grpSpPr>
+      <p:sp>
+        <p:nvSpPr>
+          <p:cNvPr id="2" name="Slide Image Placeholder 1"/>
+          <p:cNvSpPr>
+            <a:spLocks noGrp="1" noRot="1" noChangeAspect="1"/>
+          </p:cNvSpPr>
+          <p:nvPr>
+            <p:ph type="sldImg"/>
+          </p:nvPr>
+        </p:nvSpPr>
+        <p:spPr/>
+      </p:sp>
+      <p:sp>
+        <p:nvSpPr>
+          <p:cNvPr id="3" name="Notes Placeholder 2"/>
+          <p:cNvSpPr>
+            <a:spLocks noGrp="1"/>
+          </p:cNvSpPr>
+          <p:nvPr>
+            <p:ph type="body" idx="1"/>
+          </p:nvPr>
+        </p:nvSpPr>
+        <p:spPr/>
+        <p:txBody>
+          <a:bodyPr/>
+          <a:lstStyle/>
+          <a:p>
+            <a:r>
+              <a:rPr lang="en-US" dirty="0"/>
+              <a:t>Запасний слайд. Сценарій перший: реєстрація й вхід нового користувача. Одна сторінка з перемикачем, email і пароль від 8 символів, або Google. Куки працюють, бо запити йдуть через домен сайту.</a:t>
+            </a:r>
+            <a:endParaRPr lang="en-US" dirty="0"/>
+          </a:p>
+        </p:txBody>
+      </p:sp>
+      <p:sp>
+        <p:nvSpPr>
+          <p:cNvPr id="4" name="Slide Number Placeholder 3"/>
+          <p:cNvSpPr>
+            <a:spLocks noGrp="1"/>
+          </p:cNvSpPr>
+          <p:nvPr>
+            <p:ph type="sldNum" sz="quarter" idx="10"/>
+          </p:nvPr>
+        </p:nvSpPr>
+        <p:spPr/>
+        <p:txBody>
+          <a:bodyPr/>
+          <a:lstStyle/>
+          <a:p>
+            <a:fld id="{F7021451-1387-4CA6-816F-3879F97B5CBC}" type="slidenum">
+              <a:rPr lang="en-US"/>
+              <a:t>24</a:t>
+            </a:fld>
+            <a:endParaRPr lang="en-US"/>
+          </a:p>
+        </p:txBody>
+      </p:sp>
+    </p:spTree>
+    <p:extLst>
+      <p:ext uri="{BB962C8B-B14F-4D97-AF65-F5344CB8AC3E}">
+        <p14:creationId xmlns:p14="http://schemas.microsoft.com/office/powerpoint/2010/main" val="1024086991"/>
+      </p:ext>
+    </p:extLst>
+  </p:cSld>
+  <p:clrMapOvr>
+    <a:masterClrMapping/>
+  </p:clrMapOvr>
+</p:notes>
+</file>
+
+<file path=ppt/notesSlides/notesSlide25.xml><?xml version="1.0" encoding="utf-8"?>
+<p:notes xmlns:a="http://schemas.openxmlformats.org/drawingml/2006/main" xmlns:r="http://schemas.openxmlformats.org/officeDocument/2006/relationships" xmlns:p="http://schemas.openxmlformats.org/presentationml/2006/main">
+  <p:cSld>
+    <p:spTree>
+      <p:nvGrpSpPr>
+        <p:cNvPr id="1" name=""/>
+        <p:cNvGrpSpPr/>
+        <p:nvPr/>
+      </p:nvGrpSpPr>
+      <p:grpSpPr>
+        <a:xfrm>
+          <a:off x="0" y="0"/>
+          <a:ext cx="0" cy="0"/>
+          <a:chOff x="0" y="0"/>
+          <a:chExt cx="0" cy="0"/>
+        </a:xfrm>
+      </p:grpSpPr>
+      <p:sp>
+        <p:nvSpPr>
+          <p:cNvPr id="2" name="Slide Image Placeholder 1"/>
+          <p:cNvSpPr>
+            <a:spLocks noGrp="1" noRot="1" noChangeAspect="1"/>
+          </p:cNvSpPr>
+          <p:nvPr>
+            <p:ph type="sldImg"/>
+          </p:nvPr>
+        </p:nvSpPr>
+        <p:spPr/>
+      </p:sp>
+      <p:sp>
+        <p:nvSpPr>
+          <p:cNvPr id="3" name="Notes Placeholder 2"/>
+          <p:cNvSpPr>
+            <a:spLocks noGrp="1"/>
+          </p:cNvSpPr>
+          <p:nvPr>
+            <p:ph type="body" idx="1"/>
+          </p:nvPr>
+        </p:nvSpPr>
+        <p:spPr/>
+        <p:txBody>
+          <a:bodyPr/>
+          <a:lstStyle/>
+          <a:p>
+            <a:r>
+              <a:rPr lang="en-US" dirty="0"/>
+              <a:t>Запасний слайд. Сценарій другий: адмін-панель модератора. Користувачі (блокування, видалення), товари (додати, змінити, видалити), замовлення (статуси). Захищено роллю: 401 без входу, 403 для звичайного покупця. Персональні дані на знімку приховано.</a:t>
+            </a:r>
+            <a:endParaRPr lang="en-US" dirty="0"/>
+          </a:p>
+        </p:txBody>
+      </p:sp>
+      <p:sp>
+        <p:nvSpPr>
+          <p:cNvPr id="4" name="Slide Number Placeholder 3"/>
+          <p:cNvSpPr>
+            <a:spLocks noGrp="1"/>
+          </p:cNvSpPr>
+          <p:nvPr>
+            <p:ph type="sldNum" sz="quarter" idx="10"/>
+          </p:nvPr>
+        </p:nvSpPr>
+        <p:spPr/>
+        <p:txBody>
+          <a:bodyPr/>
+          <a:lstStyle/>
+          <a:p>
+            <a:fld id="{F7021451-1387-4CA6-816F-3879F97B5CBC}" type="slidenum">
+              <a:rPr lang="en-US"/>
+              <a:t>25</a:t>
+            </a:fld>
+            <a:endParaRPr lang="en-US"/>
+          </a:p>
+        </p:txBody>
+      </p:sp>
+    </p:spTree>
+    <p:extLst>
+      <p:ext uri="{BB962C8B-B14F-4D97-AF65-F5344CB8AC3E}">
+        <p14:creationId xmlns:p14="http://schemas.microsoft.com/office/powerpoint/2010/main" val="1024086991"/>
+      </p:ext>
+    </p:extLst>
+  </p:cSld>
+  <p:clrMapOvr>
+    <a:masterClrMapping/>
+  </p:clrMapOvr>
+</p:notes>
+</file>
+
+<file path=ppt/notesSlides/notesSlide26.xml><?xml version="1.0" encoding="utf-8"?>
+<p:notes xmlns:a="http://schemas.openxmlformats.org/drawingml/2006/main" xmlns:r="http://schemas.openxmlformats.org/officeDocument/2006/relationships" xmlns:p="http://schemas.openxmlformats.org/presentationml/2006/main">
+  <p:cSld>
+    <p:spTree>
+      <p:nvGrpSpPr>
+        <p:cNvPr id="1" name=""/>
+        <p:cNvGrpSpPr/>
+        <p:nvPr/>
+      </p:nvGrpSpPr>
+      <p:grpSpPr>
+        <a:xfrm>
+          <a:off x="0" y="0"/>
+          <a:ext cx="0" cy="0"/>
+          <a:chOff x="0" y="0"/>
+          <a:chExt cx="0" cy="0"/>
+        </a:xfrm>
+      </p:grpSpPr>
+      <p:sp>
+        <p:nvSpPr>
+          <p:cNvPr id="2" name="Slide Image Placeholder 1"/>
+          <p:cNvSpPr>
+            <a:spLocks noGrp="1" noRot="1" noChangeAspect="1"/>
+          </p:cNvSpPr>
+          <p:nvPr>
+            <p:ph type="sldImg"/>
+          </p:nvPr>
+        </p:nvSpPr>
+        <p:spPr/>
+      </p:sp>
+      <p:sp>
+        <p:nvSpPr>
+          <p:cNvPr id="3" name="Notes Placeholder 2"/>
+          <p:cNvSpPr>
+            <a:spLocks noGrp="1"/>
+          </p:cNvSpPr>
+          <p:nvPr>
+            <p:ph type="body" idx="1"/>
+          </p:nvPr>
+        </p:nvSpPr>
+        <p:spPr/>
+        <p:txBody>
+          <a:bodyPr/>
+          <a:lstStyle/>
+          <a:p>
+            <a:r>
+              <a:rPr lang="en-US" dirty="0"/>
+              <a:t>Запасний слайд. Мобільна версія 390 px: шапка переноситься, меню прокручується, картка товару з мініатюрами. Чесно: сітка каталогу у дві колонки на вузькому екрані має зсув правої колонки, у планах виправлення.</a:t>
+            </a:r>
+            <a:endParaRPr lang="en-US" dirty="0"/>
+          </a:p>
+        </p:txBody>
+      </p:sp>
+      <p:sp>
+        <p:nvSpPr>
+          <p:cNvPr id="4" name="Slide Number Placeholder 3"/>
+          <p:cNvSpPr>
+            <a:spLocks noGrp="1"/>
+          </p:cNvSpPr>
+          <p:nvPr>
+            <p:ph type="sldNum" sz="quarter" idx="10"/>
+          </p:nvPr>
+        </p:nvSpPr>
+        <p:spPr/>
+        <p:txBody>
+          <a:bodyPr/>
+          <a:lstStyle/>
+          <a:p>
+            <a:fld id="{F7021451-1387-4CA6-816F-3879F97B5CBC}" type="slidenum">
+              <a:rPr lang="en-US"/>
+              <a:t>26</a:t>
+            </a:fld>
+            <a:endParaRPr lang="en-US"/>
+          </a:p>
+        </p:txBody>
+      </p:sp>
+    </p:spTree>
+    <p:extLst>
+      <p:ext uri="{BB962C8B-B14F-4D97-AF65-F5344CB8AC3E}">
+        <p14:creationId xmlns:p14="http://schemas.microsoft.com/office/powerpoint/2010/main" val="1024086991"/>
+      </p:ext>
+    </p:extLst>
+  </p:cSld>
+  <p:clrMapOvr>
+    <a:masterClrMapping/>
+  </p:clrMapOvr>
+</p:notes>
+</file>
+
+<file path=ppt/notesSlides/notesSlide27.xml><?xml version="1.0" encoding="utf-8"?>
+<p:notes xmlns:a="http://schemas.openxmlformats.org/drawingml/2006/main" xmlns:r="http://schemas.openxmlformats.org/officeDocument/2006/relationships" xmlns:p="http://schemas.openxmlformats.org/presentationml/2006/main">
+  <p:cSld>
+    <p:spTree>
+      <p:nvGrpSpPr>
+        <p:cNvPr id="1" name=""/>
+        <p:cNvGrpSpPr/>
+        <p:nvPr/>
+      </p:nvGrpSpPr>
+      <p:grpSpPr>
+        <a:xfrm>
+          <a:off x="0" y="0"/>
+          <a:ext cx="0" cy="0"/>
+          <a:chOff x="0" y="0"/>
+          <a:chExt cx="0" cy="0"/>
+        </a:xfrm>
+      </p:grpSpPr>
+      <p:sp>
+        <p:nvSpPr>
+          <p:cNvPr id="2" name="Slide Image Placeholder 1"/>
+          <p:cNvSpPr>
+            <a:spLocks noGrp="1" noRot="1" noChangeAspect="1"/>
+          </p:cNvSpPr>
+          <p:nvPr>
+            <p:ph type="sldImg"/>
+          </p:nvPr>
+        </p:nvSpPr>
+        <p:spPr/>
+      </p:sp>
+      <p:sp>
+        <p:nvSpPr>
+          <p:cNvPr id="3" name="Notes Placeholder 2"/>
+          <p:cNvSpPr>
+            <a:spLocks noGrp="1"/>
+          </p:cNvSpPr>
+          <p:nvPr>
+            <p:ph type="body" idx="1"/>
+          </p:nvPr>
+        </p:nvSpPr>
+        <p:spPr/>
+        <p:txBody>
+          <a:bodyPr/>
+          <a:lstStyle/>
+          <a:p>
+            <a:r>
+              <a:rPr lang="en-US" dirty="0"/>
+              <a:t>Запасний слайд. Для розробників: повний цикл від вимог до деплою, 295 тестів, CI. Для цільової аудиторії: швидка покупка, кабінет, три мови. Монетизація: комісія, доставка, оплата, реклама.</a:t>
+            </a:r>
+            <a:endParaRPr lang="en-US" dirty="0"/>
+          </a:p>
+        </p:txBody>
+      </p:sp>
+      <p:sp>
+        <p:nvSpPr>
+          <p:cNvPr id="4" name="Slide Number Placeholder 3"/>
+          <p:cNvSpPr>
+            <a:spLocks noGrp="1"/>
+          </p:cNvSpPr>
+          <p:nvPr>
+            <p:ph type="sldNum" sz="quarter" idx="10"/>
+          </p:nvPr>
+        </p:nvSpPr>
+        <p:spPr/>
+        <p:txBody>
+          <a:bodyPr/>
+          <a:lstStyle/>
+          <a:p>
+            <a:fld id="{F7021451-1387-4CA6-816F-3879F97B5CBC}" type="slidenum">
+              <a:rPr lang="en-US"/>
+              <a:t>27</a:t>
+            </a:fld>
+            <a:endParaRPr lang="en-US"/>
+          </a:p>
+        </p:txBody>
+      </p:sp>
+    </p:spTree>
+    <p:extLst>
+      <p:ext uri="{BB962C8B-B14F-4D97-AF65-F5344CB8AC3E}">
+        <p14:creationId xmlns:p14="http://schemas.microsoft.com/office/powerpoint/2010/main" val="1024086991"/>
+      </p:ext>
+    </p:extLst>
+  </p:cSld>
+  <p:clrMapOvr>
+    <a:masterClrMapping/>
+  </p:clrMapOvr>
+</p:notes>
+</file>
+
+<file path=ppt/notesSlides/notesSlide28.xml><?xml version="1.0" encoding="utf-8"?>
+<p:notes xmlns:a="http://schemas.openxmlformats.org/drawingml/2006/main" xmlns:r="http://schemas.openxmlformats.org/officeDocument/2006/relationships" xmlns:p="http://schemas.openxmlformats.org/presentationml/2006/main">
+  <p:cSld>
+    <p:spTree>
+      <p:nvGrpSpPr>
+        <p:cNvPr id="1" name=""/>
+        <p:cNvGrpSpPr/>
+        <p:nvPr/>
+      </p:nvGrpSpPr>
+      <p:grpSpPr>
+        <a:xfrm>
+          <a:off x="0" y="0"/>
+          <a:ext cx="0" cy="0"/>
+          <a:chOff x="0" y="0"/>
+          <a:chExt cx="0" cy="0"/>
+        </a:xfrm>
+      </p:grpSpPr>
+      <p:sp>
+        <p:nvSpPr>
+          <p:cNvPr id="2" name="Slide Image Placeholder 1"/>
+          <p:cNvSpPr>
+            <a:spLocks noGrp="1" noRot="1" noChangeAspect="1"/>
+          </p:cNvSpPr>
+          <p:nvPr>
+            <p:ph type="sldImg"/>
+          </p:nvPr>
+        </p:nvSpPr>
+        <p:spPr/>
+      </p:sp>
+      <p:sp>
+        <p:nvSpPr>
+          <p:cNvPr id="3" name="Notes Placeholder 2"/>
+          <p:cNvSpPr>
+            <a:spLocks noGrp="1"/>
+          </p:cNvSpPr>
+          <p:nvPr>
+            <p:ph type="body" idx="1"/>
+          </p:nvPr>
+        </p:nvSpPr>
+        <p:spPr/>
+        <p:txBody>
+          <a:bodyPr/>
+          <a:lstStyle/>
+          <a:p>
+            <a:r>
+              <a:rPr lang="en-US" dirty="0"/>
+              <a:t>Ключова думка: від каталогу до замовлення за кілька кліків. Ваші питання?</a:t>
+            </a:r>
+            <a:endParaRPr lang="en-US" dirty="0"/>
+          </a:p>
+        </p:txBody>
+      </p:sp>
+      <p:sp>
+        <p:nvSpPr>
+          <p:cNvPr id="4" name="Slide Number Placeholder 3"/>
+          <p:cNvSpPr>
+            <a:spLocks noGrp="1"/>
+          </p:cNvSpPr>
+          <p:nvPr>
+            <p:ph type="sldNum" sz="quarter" idx="10"/>
+          </p:nvPr>
+        </p:nvSpPr>
+        <p:spPr/>
+        <p:txBody>
+          <a:bodyPr/>
+          <a:lstStyle/>
+          <a:p>
+            <a:fld id="{F7021451-1387-4CA6-816F-3879F97B5CBC}" type="slidenum">
+              <a:rPr lang="en-US"/>
+              <a:t>28</a:t>
             </a:fld>
             <a:endParaRPr lang="en-US"/>
           </a:p>
@@ -1976,7 +2426,7 @@
           <a:p>
             <a:r>
               <a:rPr lang="en-US" dirty="0"/>
-              <a:t>У SRS 13 функціональних вимог і нефункціональні вимоги. Усі 13 реалізовано, зокрема FR-03: фільтри за категорією, брендом, розміром, ціною, пошук і сортування. Нефункціональні: продуктивність, масштабованість, безпека, надійність, зручність (UA/EN/FR, адаптивна верстка).</a:t>
+              <a:t>Вадим. 13 функціональних вимог, усі реалізовано. План: 8 спринтів по тижню, 5 тижнів розробки.</a:t>
             </a:r>
             <a:endParaRPr lang="en-US" dirty="0"/>
           </a:p>
@@ -2064,7 +2514,7 @@
           <a:p>
             <a:r>
               <a:rPr lang="en-US" dirty="0"/>
-              <a:t>UI Kit: чорне, біле, червоний акцент, заголовки Cormorant Garamond, текст Mulish, круглі кнопки. Орієнтир: newbalance.com. Фото й назви товарів з newbalance.com, навчальний макет без афілійованості з брендом.</a:t>
+              <a:t>Вадим. Jira, 8 тижневих спринтів, 44 задачі, 33 виконано. Чесно: мій внесок у Git нульовий, моя роль планування, вимоги, Jira, документи. Статуси в Jira відстають від коду.</a:t>
             </a:r>
             <a:endParaRPr lang="en-US" dirty="0"/>
           </a:p>
@@ -2152,7 +2602,7 @@
           <a:p>
             <a:r>
               <a:rPr lang="en-US" dirty="0"/>
-              <a:t>React на Vercel, API на ASP.NET Core 9 у Docker на Render, PostgreSQL на Render. Запити /api ідуть на той самий домен сайту, а Vercel проксує їх на сервер: так сесійна кука належить сайту й браузер її не блокує. Вхід: пароль і Google (Firebase), GitHub-вхід прибрано.</a:t>
+              <a:t>Рафаїл. React на Vercel, ASP.NET Core 9 у Docker на Render, PostgreSQL на Render. Чотири шари, Domain без залежностей. Запити /api проксуються через домен сайту.</a:t>
             </a:r>
             <a:endParaRPr lang="en-US" dirty="0"/>
           </a:p>
@@ -2240,7 +2690,7 @@
           <a:p>
             <a:r>
               <a:rPr lang="en-US" dirty="0"/>
-              <a:t>Чотири проєкти: Domain без залежностей, Application залежить від Domain, Infrastructure реалізує репозиторії та перевірку Google-токена, Web API збирає все через DI. Раніше Firebase SDK лежав в Application, тепер він схований за інтерфейсом IGoogleTokenVerifier.</a:t>
+              <a:t>Рафаїл. Сайт у стилі newbalance.com, 70 товарів, фільтри в адресі, кошик, оформлення, кабінет, адмін-панель, мобільна версія, UA/EN/FR. Фото з newbalance.com, навчальний макет.</a:t>
             </a:r>
             <a:endParaRPr lang="en-US" dirty="0"/>
           </a:p>
@@ -2328,7 +2778,7 @@
           <a:p>
             <a:r>
               <a:rPr lang="en-US" dirty="0"/>
-              <a:t>Repository, Dependency Injection, Service Layer, DTO з мапером, Middleware Pipeline, Session State. До кожного патерна одне речення: навіщо він у нашому проєкті.</a:t>
+              <a:t>Рафаїл. 295 тестів, покриття 93,4%, CI зелений, ZAP: 0 High. PBKDF2, захист від BOLA, ролі 401/403, заголовки CSP. Чесно: сесії в пам'яті, БД на Render до 18.11.2026.</a:t>
             </a:r>
             <a:endParaRPr lang="en-US" dirty="0"/>
           </a:p>
@@ -2416,7 +2866,7 @@
           <a:p>
             <a:r>
               <a:rPr lang="en-US" dirty="0"/>
-              <a:t>PostgreSQL: реляційні зв'язки замовлення, позиції, товар, потрібна транзакційність, безкоштовно на Render. У товару список розмірів і галерея, у позиції замовлення обраний розмір. Унікальний Email, покупця із замовленнями видалити не можна. Що покращити: залишок окремо по кожному розміру.</a:t>
+              <a:t>Усі посилання клікабельні: план, SRS, архітектура, Jira, коміти, README, DocFX, Scalar, фронтенд. Далі демо на живому сайті.</a:t>
             </a:r>
             <a:endParaRPr lang="en-US" dirty="0"/>
           </a:p>
@@ -2504,7 +2954,7 @@
           <a:p>
             <a:r>
               <a:rPr lang="en-US" dirty="0"/>
-              <a:t>Два способи входу: пароль і Google. Паролі зберігаються як PBKDF2 із сіллю, 100 000 ітерацій. Закрито: BOLA (покупець береться із сесії), запис товарів лише для адміністратора, білий список CORS, rate limiting на вхід, унікальний email, пароль адміна прибрано з коду. Заголовки CSP, X-Frame-Options, nosniff, Permissions-Policy додано після звіту OWASP ZAP: було 0 High, 4 Medium, 4 Low. Відкрито чесно: сесії в пам'яті процесу, SRI, COOP/COEP.</a:t>
+              <a:t>Запасний слайд. </a:t>
             </a:r>
             <a:endParaRPr lang="en-US" dirty="0"/>
           </a:p>
@@ -2879,7 +3329,7 @@
       </p:grpSpPr>
       <p:pic>
         <p:nvPicPr>
-          <p:cNvPr id="2" name="Image 0" descr="Титульний слайд: Team 1, New Balance Shop, учасники, QR-коди">    </p:cNvPr>
+          <p:cNvPr id="2" name="Image 0" descr="Титул: Team 1, New Balance Shop, ролі">    </p:cNvPr>
           <p:cNvPicPr>
             <a:picLocks noChangeAspect="1"/>
           </p:cNvPicPr>
@@ -2901,6 +3351,126 @@
           </a:prstGeom>
         </p:spPr>
       </p:pic>
+      <p:sp>
+        <p:nvSpPr>
+          <p:cNvPr id="3" name="Shape 0"/>
+          <p:cNvSpPr/>
+          <p:nvPr/>
+        </p:nvSpPr>
+        <p:spPr>
+          <a:xfrm>
+            <a:off x="0" y="6597396"/>
+            <a:ext cx="12191695" cy="260604"/>
+          </a:xfrm>
+          <a:prstGeom prst="rect">
+            <a:avLst/>
+          </a:prstGeom>
+          <a:solidFill>
+            <a:srgbClr val="F4F4F4"/>
+          </a:solidFill>
+          <a:ln w="9525">
+            <a:solidFill>
+              <a:srgbClr val="E2E2E2"/>
+            </a:solidFill>
+            <a:prstDash val="solid"/>
+          </a:ln>
+        </p:spPr>
+      </p:sp>
+      <p:sp>
+        <p:nvSpPr>
+          <p:cNvPr id="4" name="Text 1"/>
+          <p:cNvSpPr/>
+          <p:nvPr/>
+        </p:nvSpPr>
+        <p:spPr>
+          <a:xfrm>
+            <a:off x="457200" y="6597396"/>
+            <a:ext cx="11277295" cy="260604"/>
+          </a:xfrm>
+          <a:prstGeom prst="rect">
+            <a:avLst/>
+          </a:prstGeom>
+          <a:noFill/>
+          <a:ln/>
+        </p:spPr>
+        <p:txBody>
+          <a:bodyPr wrap="square" lIns="0" tIns="0" rIns="0" bIns="0" rtlCol="0" anchor="ctr"/>
+          <a:lstStyle/>
+          <a:p>
+            <a:pPr indent="0" marL="0">
+              <a:buNone/>
+            </a:pPr>
+            <a:r>
+              <a:rPr lang="en-US" sz="1100" b="1" dirty="0">
+                <a:solidFill>
+                  <a:srgbClr val="5C5C5C"/>
+                </a:solidFill>
+                <a:latin typeface="Arial" pitchFamily="34" charset="0"/>
+                <a:ea typeface="Arial" pitchFamily="34" charset="-122"/>
+                <a:cs typeface="Arial" pitchFamily="34" charset="-120"/>
+              </a:rPr>
+              <a:t>Посилання:  </a:t>
+            </a:r>
+            <a:pPr indent="0" marL="0">
+              <a:buNone/>
+            </a:pPr>
+            <a:r>
+              <a:rPr lang="en-US" sz="1100" b="1" u="sng" dirty="0">
+                <a:solidFill>
+                  <a:srgbClr val="000000"/>
+                </a:solidFill>
+                <a:latin typeface="Arial" pitchFamily="34" charset="0"/>
+                <a:ea typeface="Arial" pitchFamily="34" charset="-122"/>
+                <a:cs typeface="Arial" pitchFamily="34" charset="-120"/>
+                <a:hlinkClick r:id="rId2" invalidUrl="" action="" tgtFrame="" tooltip="github.com/vicitmceo/NewBalanceShop" history="1" highlightClick="0" endSnd="0">
+                  <a:extLst>
+                    <a:ext uri="{A12FA001-AC4F-418D-AE19-62706E023703}">
+                      <ahyp:hlinkClr xmlns:ahyp="http://schemas.microsoft.com/office/drawing/2018/hyperlinkcolor" val="tx"/>
+                    </a:ext>
+                  </a:extLst>
+                </a:hlinkClick>
+              </a:rPr>
+              <a:t>Репозиторій</a:t>
+            </a:r>
+            <a:pPr indent="0" marL="0">
+              <a:buNone/>
+            </a:pPr>
+            <a:r>
+              <a:rPr lang="en-US" sz="1100" dirty="0">
+                <a:solidFill>
+                  <a:srgbClr val="8C8C8C"/>
+                </a:solidFill>
+                <a:latin typeface="Arial" pitchFamily="34" charset="0"/>
+                <a:ea typeface="Arial" pitchFamily="34" charset="-122"/>
+                <a:cs typeface="Arial" pitchFamily="34" charset="-120"/>
+              </a:rPr>
+              <a:t>   ·   </a:t>
+            </a:r>
+            <a:pPr indent="0" marL="0">
+              <a:buNone/>
+            </a:pPr>
+            <a:r>
+              <a:rPr lang="en-US" sz="1100" b="1" u="sng" dirty="0">
+                <a:solidFill>
+                  <a:srgbClr val="000000"/>
+                </a:solidFill>
+                <a:latin typeface="Arial" pitchFamily="34" charset="0"/>
+                <a:ea typeface="Arial" pitchFamily="34" charset="-122"/>
+                <a:cs typeface="Arial" pitchFamily="34" charset="-120"/>
+                <a:hlinkClick r:id="rId3" invalidUrl="" action="" tgtFrame="" tooltip="newbalance.cc.cd" history="1" highlightClick="0" endSnd="0">
+                  <a:extLst>
+                    <a:ext uri="{A12FA001-AC4F-418D-AE19-62706E023703}">
+                      <ahyp:hlinkClr xmlns:ahyp="http://schemas.microsoft.com/office/drawing/2018/hyperlinkcolor" val="tx"/>
+                    </a:ext>
+                  </a:extLst>
+                </a:hlinkClick>
+              </a:rPr>
+              <a:t>Сайт</a:t>
+            </a:r>
+            <a:endParaRPr lang="en-US" sz="1100" dirty="0"/>
+          </a:p>
+        </p:txBody>
+      </p:sp>
     </p:spTree>
   </p:cSld>
   <p:clrMapOvr>
@@ -2935,7 +3505,7 @@
       </p:grpSpPr>
       <p:pic>
         <p:nvPicPr>
-          <p:cNvPr id="2" name="Image 0" descr="Тестування та логування">    </p:cNvPr>
+          <p:cNvPr id="2" name="Image 0" descr="Додаток: UI Kit: кольори, типографіка, кнопки, картка товару">    </p:cNvPr>
           <p:cNvPicPr>
             <a:picLocks noChangeAspect="1"/>
           </p:cNvPicPr>
@@ -2991,7 +3561,7 @@
       </p:grpSpPr>
       <p:pic>
         <p:nvPicPr>
-          <p:cNvPr id="2" name="Image 0" descr="Ключові метрики проєкту">    </p:cNvPr>
+          <p:cNvPr id="2" name="Image 0" descr="Додаток: Архітектура системи і розміщення">    </p:cNvPr>
           <p:cNvPicPr>
             <a:picLocks noChangeAspect="1"/>
           </p:cNvPicPr>
@@ -3047,7 +3617,7 @@
       </p:grpSpPr>
       <p:pic>
         <p:nvPicPr>
-          <p:cNvPr id="2" name="Image 0" descr="Scrum: спринти, беклог, канбан">    </p:cNvPr>
+          <p:cNvPr id="2" name="Image 0" descr="Додаток: Чиста архітектура: проєкти та зв'язки">    </p:cNvPr>
           <p:cNvPicPr>
             <a:picLocks noChangeAspect="1"/>
           </p:cNvPicPr>
@@ -3103,7 +3673,7 @@
       </p:grpSpPr>
       <p:pic>
         <p:nvPicPr>
-          <p:cNvPr id="2" name="Image 0" descr="Інструменти та робочий процес">    </p:cNvPr>
+          <p:cNvPr id="2" name="Image 0" descr="Додаток: Додаток: діаграма класів">    </p:cNvPr>
           <p:cNvPicPr>
             <a:picLocks noChangeAspect="1"/>
           </p:cNvPicPr>
@@ -3159,7 +3729,7 @@
       </p:grpSpPr>
       <p:pic>
         <p:nvPicPr>
-          <p:cNvPr id="2" name="Image 0" descr="Каталог і картка товару на живому сайті">    </p:cNvPr>
+          <p:cNvPr id="2" name="Image 0" descr="Додаток: Використані патерни проєктування">    </p:cNvPr>
           <p:cNvPicPr>
             <a:picLocks noChangeAspect="1"/>
           </p:cNvPicPr>
@@ -3215,7 +3785,7 @@
       </p:grpSpPr>
       <p:pic>
         <p:nvPicPr>
-          <p:cNvPr id="2" name="Image 0" descr="Кошик, оформлення і обране">    </p:cNvPr>
+          <p:cNvPr id="2" name="Image 0" descr="Додаток: ER-діаграма бази даних PostgreSQL">    </p:cNvPr>
           <p:cNvPicPr>
             <a:picLocks noChangeAspect="1"/>
           </p:cNvPicPr>
@@ -3271,7 +3841,7 @@
       </p:grpSpPr>
       <p:pic>
         <p:nvPicPr>
-          <p:cNvPr id="2" name="Image 0" descr="Вхід і реєстрація">    </p:cNvPr>
+          <p:cNvPr id="2" name="Image 0" descr="Додаток: Автентифікація, авторизація та безпека">    </p:cNvPr>
           <p:cNvPicPr>
             <a:picLocks noChangeAspect="1"/>
           </p:cNvPicPr>
@@ -3327,7 +3897,7 @@
       </p:grpSpPr>
       <p:pic>
         <p:nvPicPr>
-          <p:cNvPr id="2" name="Image 0" descr="Адмін-панель модератора">    </p:cNvPr>
+          <p:cNvPr id="2" name="Image 0" descr="Додаток: Тестування та логування">    </p:cNvPr>
           <p:cNvPicPr>
             <a:picLocks noChangeAspect="1"/>
           </p:cNvPicPr>
@@ -3383,7 +3953,7 @@
       </p:grpSpPr>
       <p:pic>
         <p:nvPicPr>
-          <p:cNvPr id="2" name="Image 0" descr="Мобільна версія сайту: скріни з телефона">    </p:cNvPr>
+          <p:cNvPr id="2" name="Image 0" descr="Додаток: Ключові метрики проєкту">    </p:cNvPr>
           <p:cNvPicPr>
             <a:picLocks noChangeAspect="1"/>
           </p:cNvPicPr>
@@ -3439,7 +4009,7 @@
       </p:grpSpPr>
       <p:pic>
         <p:nvPicPr>
-          <p:cNvPr id="2" name="Image 0" descr="Портфоліо-цінність проєкту">    </p:cNvPr>
+          <p:cNvPr id="2" name="Image 0" descr="Додаток: Додаток: Git, гілки і внесок">    </p:cNvPr>
           <p:cNvPicPr>
             <a:picLocks noChangeAspect="1"/>
           </p:cNvPicPr>
@@ -3495,7 +4065,7 @@
       </p:grpSpPr>
       <p:pic>
         <p:nvPicPr>
-          <p:cNvPr id="2" name="Image 0" descr="Навіщо проєкт: проблема, рішення, цільова аудиторія">    </p:cNvPr>
+          <p:cNvPr id="2" name="Image 0" descr="Навіщо проєкт: проблема, рішення, аудиторія">    </p:cNvPr>
           <p:cNvPicPr>
             <a:picLocks noChangeAspect="1"/>
           </p:cNvPicPr>
@@ -3517,6 +4087,91 @@
           </a:prstGeom>
         </p:spPr>
       </p:pic>
+      <p:sp>
+        <p:nvSpPr>
+          <p:cNvPr id="3" name="Shape 0"/>
+          <p:cNvSpPr/>
+          <p:nvPr/>
+        </p:nvSpPr>
+        <p:spPr>
+          <a:xfrm>
+            <a:off x="0" y="6597396"/>
+            <a:ext cx="12191695" cy="260604"/>
+          </a:xfrm>
+          <a:prstGeom prst="rect">
+            <a:avLst/>
+          </a:prstGeom>
+          <a:solidFill>
+            <a:srgbClr val="F4F4F4"/>
+          </a:solidFill>
+          <a:ln w="9525">
+            <a:solidFill>
+              <a:srgbClr val="E2E2E2"/>
+            </a:solidFill>
+            <a:prstDash val="solid"/>
+          </a:ln>
+        </p:spPr>
+      </p:sp>
+      <p:sp>
+        <p:nvSpPr>
+          <p:cNvPr id="4" name="Text 1"/>
+          <p:cNvSpPr/>
+          <p:nvPr/>
+        </p:nvSpPr>
+        <p:spPr>
+          <a:xfrm>
+            <a:off x="457200" y="6597396"/>
+            <a:ext cx="11277295" cy="260604"/>
+          </a:xfrm>
+          <a:prstGeom prst="rect">
+            <a:avLst/>
+          </a:prstGeom>
+          <a:noFill/>
+          <a:ln/>
+        </p:spPr>
+        <p:txBody>
+          <a:bodyPr wrap="square" lIns="0" tIns="0" rIns="0" bIns="0" rtlCol="0" anchor="ctr"/>
+          <a:lstStyle/>
+          <a:p>
+            <a:pPr indent="0" marL="0">
+              <a:buNone/>
+            </a:pPr>
+            <a:r>
+              <a:rPr lang="en-US" sz="1100" b="1" dirty="0">
+                <a:solidFill>
+                  <a:srgbClr val="5C5C5C"/>
+                </a:solidFill>
+                <a:latin typeface="Arial" pitchFamily="34" charset="0"/>
+                <a:ea typeface="Arial" pitchFamily="34" charset="-122"/>
+                <a:cs typeface="Arial" pitchFamily="34" charset="-120"/>
+              </a:rPr>
+              <a:t>Посилання:  </a:t>
+            </a:r>
+            <a:pPr indent="0" marL="0">
+              <a:buNone/>
+            </a:pPr>
+            <a:r>
+              <a:rPr lang="en-US" sz="1100" b="1" u="sng" dirty="0">
+                <a:solidFill>
+                  <a:srgbClr val="000000"/>
+                </a:solidFill>
+                <a:latin typeface="Arial" pitchFamily="34" charset="0"/>
+                <a:ea typeface="Arial" pitchFamily="34" charset="-122"/>
+                <a:cs typeface="Arial" pitchFamily="34" charset="-120"/>
+                <a:hlinkClick r:id="rId2" invalidUrl="" action="" tgtFrame="" tooltip="github.com/vicitmceo/NewBalanceShop#readme" history="1" highlightClick="0" endSnd="0">
+                  <a:extLst>
+                    <a:ext uri="{A12FA001-AC4F-418D-AE19-62706E023703}">
+                      <ahyp:hlinkClr xmlns:ahyp="http://schemas.microsoft.com/office/drawing/2018/hyperlinkcolor" val="tx"/>
+                    </a:ext>
+                  </a:extLst>
+                </a:hlinkClick>
+              </a:rPr>
+              <a:t>README</a:t>
+            </a:r>
+            <a:endParaRPr lang="en-US" sz="1100" dirty="0"/>
+          </a:p>
+        </p:txBody>
+      </p:sp>
     </p:spTree>
   </p:cSld>
   <p:clrMapOvr>
@@ -3551,7 +4206,7 @@
       </p:grpSpPr>
       <p:pic>
         <p:nvPicPr>
-          <p:cNvPr id="2" name="Image 0" descr="Додаток: діаграма класів">    </p:cNvPr>
+          <p:cNvPr id="2" name="Image 0" descr="Додаток: Інструменти та робочий процес">    </p:cNvPr>
           <p:cNvPicPr>
             <a:picLocks noChangeAspect="1"/>
           </p:cNvPicPr>
@@ -3607,7 +4262,7 @@
       </p:grpSpPr>
       <p:pic>
         <p:nvPicPr>
-          <p:cNvPr id="2" name="Image 0" descr="Додаток: Git, гілки і внесок">    </p:cNvPr>
+          <p:cNvPr id="2" name="Image 0" descr="Додаток: Додаток: документація">    </p:cNvPr>
           <p:cNvPicPr>
             <a:picLocks noChangeAspect="1"/>
           </p:cNvPicPr>
@@ -3663,7 +4318,7 @@
       </p:grpSpPr>
       <p:pic>
         <p:nvPicPr>
-          <p:cNvPr id="2" name="Image 0" descr="Додаток: документація">    </p:cNvPr>
+          <p:cNvPr id="2" name="Image 0" descr="Додаток: Каталог і картка товару на живому сайті">    </p:cNvPr>
           <p:cNvPicPr>
             <a:picLocks noChangeAspect="1"/>
           </p:cNvPicPr>
@@ -3719,7 +4374,7 @@
       </p:grpSpPr>
       <p:pic>
         <p:nvPicPr>
-          <p:cNvPr id="2" name="Image 0" descr="Ключова думка проєкту і запитання">    </p:cNvPr>
+          <p:cNvPr id="2" name="Image 0" descr="Додаток: Кошик, оформлення і обране">    </p:cNvPr>
           <p:cNvPicPr>
             <a:picLocks noChangeAspect="1"/>
           </p:cNvPicPr>
@@ -3741,6 +4396,406 @@
           </a:prstGeom>
         </p:spPr>
       </p:pic>
+    </p:spTree>
+  </p:cSld>
+  <p:clrMapOvr>
+    <a:masterClrMapping/>
+  </p:clrMapOvr>
+</p:sld>
+</file>
+
+<file path=ppt/slides/slide24.xml><?xml version="1.0" encoding="utf-8"?>
+<p:sld xmlns:a="http://schemas.openxmlformats.org/drawingml/2006/main" xmlns:r="http://schemas.openxmlformats.org/officeDocument/2006/relationships" xmlns:p="http://schemas.openxmlformats.org/presentationml/2006/main">
+  <p:cSld name="Slide 24">
+    <p:bg>
+      <p:bgPr>
+        <a:solidFill>
+          <a:srgbClr val="111111"/>
+        </a:solidFill>
+      </p:bgPr>
+    </p:bg>
+    <p:spTree>
+      <p:nvGrpSpPr>
+        <p:cNvPr id="1" name=""/>
+        <p:cNvGrpSpPr/>
+        <p:nvPr/>
+      </p:nvGrpSpPr>
+      <p:grpSpPr>
+        <a:xfrm>
+          <a:off x="0" y="0"/>
+          <a:ext cx="0" cy="0"/>
+          <a:chOff x="0" y="0"/>
+          <a:chExt cx="0" cy="0"/>
+        </a:xfrm>
+      </p:grpSpPr>
+      <p:pic>
+        <p:nvPicPr>
+          <p:cNvPr id="2" name="Image 0" descr="Додаток: Вхід і реєстрація">    </p:cNvPr>
+          <p:cNvPicPr>
+            <a:picLocks noChangeAspect="1"/>
+          </p:cNvPicPr>
+          <p:nvPr/>
+        </p:nvPicPr>
+        <p:blipFill>
+          <a:blip r:embed="rId1"/>
+          <a:stretch>
+            <a:fillRect/>
+          </a:stretch>
+        </p:blipFill>
+        <p:spPr>
+          <a:xfrm>
+            <a:off x="0" y="0"/>
+            <a:ext cx="12191695" cy="6858000"/>
+          </a:xfrm>
+          <a:prstGeom prst="rect">
+            <a:avLst/>
+          </a:prstGeom>
+        </p:spPr>
+      </p:pic>
+    </p:spTree>
+  </p:cSld>
+  <p:clrMapOvr>
+    <a:masterClrMapping/>
+  </p:clrMapOvr>
+</p:sld>
+</file>
+
+<file path=ppt/slides/slide25.xml><?xml version="1.0" encoding="utf-8"?>
+<p:sld xmlns:a="http://schemas.openxmlformats.org/drawingml/2006/main" xmlns:r="http://schemas.openxmlformats.org/officeDocument/2006/relationships" xmlns:p="http://schemas.openxmlformats.org/presentationml/2006/main">
+  <p:cSld name="Slide 25">
+    <p:bg>
+      <p:bgPr>
+        <a:solidFill>
+          <a:srgbClr val="111111"/>
+        </a:solidFill>
+      </p:bgPr>
+    </p:bg>
+    <p:spTree>
+      <p:nvGrpSpPr>
+        <p:cNvPr id="1" name=""/>
+        <p:cNvGrpSpPr/>
+        <p:nvPr/>
+      </p:nvGrpSpPr>
+      <p:grpSpPr>
+        <a:xfrm>
+          <a:off x="0" y="0"/>
+          <a:ext cx="0" cy="0"/>
+          <a:chOff x="0" y="0"/>
+          <a:chExt cx="0" cy="0"/>
+        </a:xfrm>
+      </p:grpSpPr>
+      <p:pic>
+        <p:nvPicPr>
+          <p:cNvPr id="2" name="Image 0" descr="Додаток: Адмін-панель модератора">    </p:cNvPr>
+          <p:cNvPicPr>
+            <a:picLocks noChangeAspect="1"/>
+          </p:cNvPicPr>
+          <p:nvPr/>
+        </p:nvPicPr>
+        <p:blipFill>
+          <a:blip r:embed="rId1"/>
+          <a:stretch>
+            <a:fillRect/>
+          </a:stretch>
+        </p:blipFill>
+        <p:spPr>
+          <a:xfrm>
+            <a:off x="0" y="0"/>
+            <a:ext cx="12191695" cy="6858000"/>
+          </a:xfrm>
+          <a:prstGeom prst="rect">
+            <a:avLst/>
+          </a:prstGeom>
+        </p:spPr>
+      </p:pic>
+    </p:spTree>
+  </p:cSld>
+  <p:clrMapOvr>
+    <a:masterClrMapping/>
+  </p:clrMapOvr>
+</p:sld>
+</file>
+
+<file path=ppt/slides/slide26.xml><?xml version="1.0" encoding="utf-8"?>
+<p:sld xmlns:a="http://schemas.openxmlformats.org/drawingml/2006/main" xmlns:r="http://schemas.openxmlformats.org/officeDocument/2006/relationships" xmlns:p="http://schemas.openxmlformats.org/presentationml/2006/main">
+  <p:cSld name="Slide 26">
+    <p:bg>
+      <p:bgPr>
+        <a:solidFill>
+          <a:srgbClr val="111111"/>
+        </a:solidFill>
+      </p:bgPr>
+    </p:bg>
+    <p:spTree>
+      <p:nvGrpSpPr>
+        <p:cNvPr id="1" name=""/>
+        <p:cNvGrpSpPr/>
+        <p:nvPr/>
+      </p:nvGrpSpPr>
+      <p:grpSpPr>
+        <a:xfrm>
+          <a:off x="0" y="0"/>
+          <a:ext cx="0" cy="0"/>
+          <a:chOff x="0" y="0"/>
+          <a:chExt cx="0" cy="0"/>
+        </a:xfrm>
+      </p:grpSpPr>
+      <p:pic>
+        <p:nvPicPr>
+          <p:cNvPr id="2" name="Image 0" descr="Додаток: Мобільна версія сайту: скріни з телефона">    </p:cNvPr>
+          <p:cNvPicPr>
+            <a:picLocks noChangeAspect="1"/>
+          </p:cNvPicPr>
+          <p:nvPr/>
+        </p:nvPicPr>
+        <p:blipFill>
+          <a:blip r:embed="rId1"/>
+          <a:stretch>
+            <a:fillRect/>
+          </a:stretch>
+        </p:blipFill>
+        <p:spPr>
+          <a:xfrm>
+            <a:off x="0" y="0"/>
+            <a:ext cx="12191695" cy="6858000"/>
+          </a:xfrm>
+          <a:prstGeom prst="rect">
+            <a:avLst/>
+          </a:prstGeom>
+        </p:spPr>
+      </p:pic>
+    </p:spTree>
+  </p:cSld>
+  <p:clrMapOvr>
+    <a:masterClrMapping/>
+  </p:clrMapOvr>
+</p:sld>
+</file>
+
+<file path=ppt/slides/slide27.xml><?xml version="1.0" encoding="utf-8"?>
+<p:sld xmlns:a="http://schemas.openxmlformats.org/drawingml/2006/main" xmlns:r="http://schemas.openxmlformats.org/officeDocument/2006/relationships" xmlns:p="http://schemas.openxmlformats.org/presentationml/2006/main">
+  <p:cSld name="Slide 27">
+    <p:bg>
+      <p:bgPr>
+        <a:solidFill>
+          <a:srgbClr val="111111"/>
+        </a:solidFill>
+      </p:bgPr>
+    </p:bg>
+    <p:spTree>
+      <p:nvGrpSpPr>
+        <p:cNvPr id="1" name=""/>
+        <p:cNvGrpSpPr/>
+        <p:nvPr/>
+      </p:nvGrpSpPr>
+      <p:grpSpPr>
+        <a:xfrm>
+          <a:off x="0" y="0"/>
+          <a:ext cx="0" cy="0"/>
+          <a:chOff x="0" y="0"/>
+          <a:chExt cx="0" cy="0"/>
+        </a:xfrm>
+      </p:grpSpPr>
+      <p:pic>
+        <p:nvPicPr>
+          <p:cNvPr id="2" name="Image 0" descr="Додаток: Портфоліо-цінність проєкту">    </p:cNvPr>
+          <p:cNvPicPr>
+            <a:picLocks noChangeAspect="1"/>
+          </p:cNvPicPr>
+          <p:nvPr/>
+        </p:nvPicPr>
+        <p:blipFill>
+          <a:blip r:embed="rId1"/>
+          <a:stretch>
+            <a:fillRect/>
+          </a:stretch>
+        </p:blipFill>
+        <p:spPr>
+          <a:xfrm>
+            <a:off x="0" y="0"/>
+            <a:ext cx="12191695" cy="6858000"/>
+          </a:xfrm>
+          <a:prstGeom prst="rect">
+            <a:avLst/>
+          </a:prstGeom>
+        </p:spPr>
+      </p:pic>
+    </p:spTree>
+  </p:cSld>
+  <p:clrMapOvr>
+    <a:masterClrMapping/>
+  </p:clrMapOvr>
+</p:sld>
+</file>
+
+<file path=ppt/slides/slide28.xml><?xml version="1.0" encoding="utf-8"?>
+<p:sld xmlns:a="http://schemas.openxmlformats.org/drawingml/2006/main" xmlns:r="http://schemas.openxmlformats.org/officeDocument/2006/relationships" xmlns:p="http://schemas.openxmlformats.org/presentationml/2006/main">
+  <p:cSld name="Slide 28">
+    <p:bg>
+      <p:bgPr>
+        <a:solidFill>
+          <a:srgbClr val="111111"/>
+        </a:solidFill>
+      </p:bgPr>
+    </p:bg>
+    <p:spTree>
+      <p:nvGrpSpPr>
+        <p:cNvPr id="1" name=""/>
+        <p:cNvGrpSpPr/>
+        <p:nvPr/>
+      </p:nvGrpSpPr>
+      <p:grpSpPr>
+        <a:xfrm>
+          <a:off x="0" y="0"/>
+          <a:ext cx="0" cy="0"/>
+          <a:chOff x="0" y="0"/>
+          <a:chExt cx="0" cy="0"/>
+        </a:xfrm>
+      </p:grpSpPr>
+      <p:pic>
+        <p:nvPicPr>
+          <p:cNvPr id="2" name="Image 0" descr="Ваші питання?">    </p:cNvPr>
+          <p:cNvPicPr>
+            <a:picLocks noChangeAspect="1"/>
+          </p:cNvPicPr>
+          <p:nvPr/>
+        </p:nvPicPr>
+        <p:blipFill>
+          <a:blip r:embed="rId1"/>
+          <a:stretch>
+            <a:fillRect/>
+          </a:stretch>
+        </p:blipFill>
+        <p:spPr>
+          <a:xfrm>
+            <a:off x="0" y="0"/>
+            <a:ext cx="12191695" cy="6858000"/>
+          </a:xfrm>
+          <a:prstGeom prst="rect">
+            <a:avLst/>
+          </a:prstGeom>
+        </p:spPr>
+      </p:pic>
+      <p:sp>
+        <p:nvSpPr>
+          <p:cNvPr id="3" name="Shape 0"/>
+          <p:cNvSpPr/>
+          <p:nvPr/>
+        </p:nvSpPr>
+        <p:spPr>
+          <a:xfrm>
+            <a:off x="0" y="6597396"/>
+            <a:ext cx="12191695" cy="260604"/>
+          </a:xfrm>
+          <a:prstGeom prst="rect">
+            <a:avLst/>
+          </a:prstGeom>
+          <a:solidFill>
+            <a:srgbClr val="F4F4F4"/>
+          </a:solidFill>
+          <a:ln w="9525">
+            <a:solidFill>
+              <a:srgbClr val="E2E2E2"/>
+            </a:solidFill>
+            <a:prstDash val="solid"/>
+          </a:ln>
+        </p:spPr>
+      </p:sp>
+      <p:sp>
+        <p:nvSpPr>
+          <p:cNvPr id="4" name="Text 1"/>
+          <p:cNvSpPr/>
+          <p:nvPr/>
+        </p:nvSpPr>
+        <p:spPr>
+          <a:xfrm>
+            <a:off x="457200" y="6597396"/>
+            <a:ext cx="11277295" cy="260604"/>
+          </a:xfrm>
+          <a:prstGeom prst="rect">
+            <a:avLst/>
+          </a:prstGeom>
+          <a:noFill/>
+          <a:ln/>
+        </p:spPr>
+        <p:txBody>
+          <a:bodyPr wrap="square" lIns="0" tIns="0" rIns="0" bIns="0" rtlCol="0" anchor="ctr"/>
+          <a:lstStyle/>
+          <a:p>
+            <a:pPr indent="0" marL="0">
+              <a:buNone/>
+            </a:pPr>
+            <a:r>
+              <a:rPr lang="en-US" sz="1100" b="1" dirty="0">
+                <a:solidFill>
+                  <a:srgbClr val="5C5C5C"/>
+                </a:solidFill>
+                <a:latin typeface="Arial" pitchFamily="34" charset="0"/>
+                <a:ea typeface="Arial" pitchFamily="34" charset="-122"/>
+                <a:cs typeface="Arial" pitchFamily="34" charset="-120"/>
+              </a:rPr>
+              <a:t>Посилання:  </a:t>
+            </a:r>
+            <a:pPr indent="0" marL="0">
+              <a:buNone/>
+            </a:pPr>
+            <a:r>
+              <a:rPr lang="en-US" sz="1100" b="1" u="sng" dirty="0">
+                <a:solidFill>
+                  <a:srgbClr val="000000"/>
+                </a:solidFill>
+                <a:latin typeface="Arial" pitchFamily="34" charset="0"/>
+                <a:ea typeface="Arial" pitchFamily="34" charset="-122"/>
+                <a:cs typeface="Arial" pitchFamily="34" charset="-120"/>
+                <a:hlinkClick r:id="rId2" invalidUrl="" action="" tgtFrame="" tooltip="newbalance.cc.cd" history="1" highlightClick="0" endSnd="0">
+                  <a:extLst>
+                    <a:ext uri="{A12FA001-AC4F-418D-AE19-62706E023703}">
+                      <ahyp:hlinkClr xmlns:ahyp="http://schemas.microsoft.com/office/drawing/2018/hyperlinkcolor" val="tx"/>
+                    </a:ext>
+                  </a:extLst>
+                </a:hlinkClick>
+              </a:rPr>
+              <a:t>Сайт</a:t>
+            </a:r>
+            <a:pPr indent="0" marL="0">
+              <a:buNone/>
+            </a:pPr>
+            <a:r>
+              <a:rPr lang="en-US" sz="1100" dirty="0">
+                <a:solidFill>
+                  <a:srgbClr val="8C8C8C"/>
+                </a:solidFill>
+                <a:latin typeface="Arial" pitchFamily="34" charset="0"/>
+                <a:ea typeface="Arial" pitchFamily="34" charset="-122"/>
+                <a:cs typeface="Arial" pitchFamily="34" charset="-120"/>
+              </a:rPr>
+              <a:t>   ·   </a:t>
+            </a:r>
+            <a:pPr indent="0" marL="0">
+              <a:buNone/>
+            </a:pPr>
+            <a:r>
+              <a:rPr lang="en-US" sz="1100" b="1" u="sng" dirty="0">
+                <a:solidFill>
+                  <a:srgbClr val="000000"/>
+                </a:solidFill>
+                <a:latin typeface="Arial" pitchFamily="34" charset="0"/>
+                <a:ea typeface="Arial" pitchFamily="34" charset="-122"/>
+                <a:cs typeface="Arial" pitchFamily="34" charset="-120"/>
+                <a:hlinkClick r:id="rId3" invalidUrl="" action="" tgtFrame="" tooltip="github.com/vicitmceo/NewBalanceShop" history="1" highlightClick="0" endSnd="0">
+                  <a:extLst>
+                    <a:ext uri="{A12FA001-AC4F-418D-AE19-62706E023703}">
+                      <ahyp:hlinkClr xmlns:ahyp="http://schemas.microsoft.com/office/drawing/2018/hyperlinkcolor" val="tx"/>
+                    </a:ext>
+                  </a:extLst>
+                </a:hlinkClick>
+              </a:rPr>
+              <a:t>Репозиторій</a:t>
+            </a:r>
+            <a:endParaRPr lang="en-US" sz="1100" dirty="0"/>
+          </a:p>
+        </p:txBody>
+      </p:sp>
     </p:spTree>
   </p:cSld>
   <p:clrMapOvr>
@@ -3775,7 +4830,7 @@
       </p:grpSpPr>
       <p:pic>
         <p:nvPicPr>
-          <p:cNvPr id="2" name="Image 0" descr="SRS: 13 функціональних вимог, усі реалізовано">    </p:cNvPr>
+          <p:cNvPr id="2" name="Image 0" descr="Вимоги SRS і план робіт">    </p:cNvPr>
           <p:cNvPicPr>
             <a:picLocks noChangeAspect="1"/>
           </p:cNvPicPr>
@@ -3797,6 +4852,126 @@
           </a:prstGeom>
         </p:spPr>
       </p:pic>
+      <p:sp>
+        <p:nvSpPr>
+          <p:cNvPr id="3" name="Shape 0"/>
+          <p:cNvSpPr/>
+          <p:nvPr/>
+        </p:nvSpPr>
+        <p:spPr>
+          <a:xfrm>
+            <a:off x="0" y="6597396"/>
+            <a:ext cx="12191695" cy="260604"/>
+          </a:xfrm>
+          <a:prstGeom prst="rect">
+            <a:avLst/>
+          </a:prstGeom>
+          <a:solidFill>
+            <a:srgbClr val="F4F4F4"/>
+          </a:solidFill>
+          <a:ln w="9525">
+            <a:solidFill>
+              <a:srgbClr val="E2E2E2"/>
+            </a:solidFill>
+            <a:prstDash val="solid"/>
+          </a:ln>
+        </p:spPr>
+      </p:sp>
+      <p:sp>
+        <p:nvSpPr>
+          <p:cNvPr id="4" name="Text 1"/>
+          <p:cNvSpPr/>
+          <p:nvPr/>
+        </p:nvSpPr>
+        <p:spPr>
+          <a:xfrm>
+            <a:off x="457200" y="6597396"/>
+            <a:ext cx="11277295" cy="260604"/>
+          </a:xfrm>
+          <a:prstGeom prst="rect">
+            <a:avLst/>
+          </a:prstGeom>
+          <a:noFill/>
+          <a:ln/>
+        </p:spPr>
+        <p:txBody>
+          <a:bodyPr wrap="square" lIns="0" tIns="0" rIns="0" bIns="0" rtlCol="0" anchor="ctr"/>
+          <a:lstStyle/>
+          <a:p>
+            <a:pPr indent="0" marL="0">
+              <a:buNone/>
+            </a:pPr>
+            <a:r>
+              <a:rPr lang="en-US" sz="1100" b="1" dirty="0">
+                <a:solidFill>
+                  <a:srgbClr val="5C5C5C"/>
+                </a:solidFill>
+                <a:latin typeface="Arial" pitchFamily="34" charset="0"/>
+                <a:ea typeface="Arial" pitchFamily="34" charset="-122"/>
+                <a:cs typeface="Arial" pitchFamily="34" charset="-120"/>
+              </a:rPr>
+              <a:t>Посилання:  </a:t>
+            </a:r>
+            <a:pPr indent="0" marL="0">
+              <a:buNone/>
+            </a:pPr>
+            <a:r>
+              <a:rPr lang="en-US" sz="1100" b="1" u="sng" dirty="0">
+                <a:solidFill>
+                  <a:srgbClr val="000000"/>
+                </a:solidFill>
+                <a:latin typeface="Arial" pitchFamily="34" charset="0"/>
+                <a:ea typeface="Arial" pitchFamily="34" charset="-122"/>
+                <a:cs typeface="Arial" pitchFamily="34" charset="-120"/>
+                <a:hlinkClick r:id="rId2" invalidUrl="" action="" tgtFrame="" tooltip="github.com/vicitmceo/NewBalanceShop → weekly-plan.png" history="1" highlightClick="0" endSnd="0">
+                  <a:extLst>
+                    <a:ext uri="{A12FA001-AC4F-418D-AE19-62706E023703}">
+                      <ahyp:hlinkClr xmlns:ahyp="http://schemas.microsoft.com/office/drawing/2018/hyperlinkcolor" val="tx"/>
+                    </a:ext>
+                  </a:extLst>
+                </a:hlinkClick>
+              </a:rPr>
+              <a:t>План робіт</a:t>
+            </a:r>
+            <a:pPr indent="0" marL="0">
+              <a:buNone/>
+            </a:pPr>
+            <a:r>
+              <a:rPr lang="en-US" sz="1100" dirty="0">
+                <a:solidFill>
+                  <a:srgbClr val="8C8C8C"/>
+                </a:solidFill>
+                <a:latin typeface="Arial" pitchFamily="34" charset="0"/>
+                <a:ea typeface="Arial" pitchFamily="34" charset="-122"/>
+                <a:cs typeface="Arial" pitchFamily="34" charset="-120"/>
+              </a:rPr>
+              <a:t>   ·   </a:t>
+            </a:r>
+            <a:pPr indent="0" marL="0">
+              <a:buNone/>
+            </a:pPr>
+            <a:r>
+              <a:rPr lang="en-US" sz="1100" b="1" u="sng" dirty="0">
+                <a:solidFill>
+                  <a:srgbClr val="000000"/>
+                </a:solidFill>
+                <a:latin typeface="Arial" pitchFamily="34" charset="0"/>
+                <a:ea typeface="Arial" pitchFamily="34" charset="-122"/>
+                <a:cs typeface="Arial" pitchFamily="34" charset="-120"/>
+                <a:hlinkClick r:id="rId3" invalidUrl="" action="" tgtFrame="" tooltip="github.com/vicitmceo/NewBalanceShop → SRS.md" history="1" highlightClick="0" endSnd="0">
+                  <a:extLst>
+                    <a:ext uri="{A12FA001-AC4F-418D-AE19-62706E023703}">
+                      <ahyp:hlinkClr xmlns:ahyp="http://schemas.microsoft.com/office/drawing/2018/hyperlinkcolor" val="tx"/>
+                    </a:ext>
+                  </a:extLst>
+                </a:hlinkClick>
+              </a:rPr>
+              <a:t>SRS</a:t>
+            </a:r>
+            <a:endParaRPr lang="en-US" sz="1100" dirty="0"/>
+          </a:p>
+        </p:txBody>
+      </p:sp>
     </p:spTree>
   </p:cSld>
   <p:clrMapOvr>
@@ -3831,7 +5006,7 @@
       </p:grpSpPr>
       <p:pic>
         <p:nvPicPr>
-          <p:cNvPr id="2" name="Image 0" descr="UI Kit: кольори, типографіка, кнопки, картка товару">    </p:cNvPr>
+          <p:cNvPr id="2" name="Image 0" descr="Scrum: спринти, беклог, Jira">    </p:cNvPr>
           <p:cNvPicPr>
             <a:picLocks noChangeAspect="1"/>
           </p:cNvPicPr>
@@ -3853,6 +5028,161 @@
           </a:prstGeom>
         </p:spPr>
       </p:pic>
+      <p:sp>
+        <p:nvSpPr>
+          <p:cNvPr id="3" name="Shape 0"/>
+          <p:cNvSpPr/>
+          <p:nvPr/>
+        </p:nvSpPr>
+        <p:spPr>
+          <a:xfrm>
+            <a:off x="0" y="6597396"/>
+            <a:ext cx="12191695" cy="260604"/>
+          </a:xfrm>
+          <a:prstGeom prst="rect">
+            <a:avLst/>
+          </a:prstGeom>
+          <a:solidFill>
+            <a:srgbClr val="F4F4F4"/>
+          </a:solidFill>
+          <a:ln w="9525">
+            <a:solidFill>
+              <a:srgbClr val="E2E2E2"/>
+            </a:solidFill>
+            <a:prstDash val="solid"/>
+          </a:ln>
+        </p:spPr>
+      </p:sp>
+      <p:sp>
+        <p:nvSpPr>
+          <p:cNvPr id="4" name="Text 1"/>
+          <p:cNvSpPr/>
+          <p:nvPr/>
+        </p:nvSpPr>
+        <p:spPr>
+          <a:xfrm>
+            <a:off x="457200" y="6597396"/>
+            <a:ext cx="11277295" cy="260604"/>
+          </a:xfrm>
+          <a:prstGeom prst="rect">
+            <a:avLst/>
+          </a:prstGeom>
+          <a:noFill/>
+          <a:ln/>
+        </p:spPr>
+        <p:txBody>
+          <a:bodyPr wrap="square" lIns="0" tIns="0" rIns="0" bIns="0" rtlCol="0" anchor="ctr"/>
+          <a:lstStyle/>
+          <a:p>
+            <a:pPr indent="0" marL="0">
+              <a:buNone/>
+            </a:pPr>
+            <a:r>
+              <a:rPr lang="en-US" sz="1100" b="1" dirty="0">
+                <a:solidFill>
+                  <a:srgbClr val="5C5C5C"/>
+                </a:solidFill>
+                <a:latin typeface="Arial" pitchFamily="34" charset="0"/>
+                <a:ea typeface="Arial" pitchFamily="34" charset="-122"/>
+                <a:cs typeface="Arial" pitchFamily="34" charset="-120"/>
+              </a:rPr>
+              <a:t>Посилання:  </a:t>
+            </a:r>
+            <a:pPr indent="0" marL="0">
+              <a:buNone/>
+            </a:pPr>
+            <a:r>
+              <a:rPr lang="en-US" sz="1100" b="1" u="sng" dirty="0">
+                <a:solidFill>
+                  <a:srgbClr val="000000"/>
+                </a:solidFill>
+                <a:latin typeface="Arial" pitchFamily="34" charset="0"/>
+                <a:ea typeface="Arial" pitchFamily="34" charset="-122"/>
+                <a:cs typeface="Arial" pitchFamily="34" charset="-120"/>
+                <a:hlinkClick r:id="rId2" invalidUrl="" action="" tgtFrame="" tooltip="newbalance-team1.atlassian.net → SCRUM board" history="1" highlightClick="0" endSnd="0">
+                  <a:extLst>
+                    <a:ext uri="{A12FA001-AC4F-418D-AE19-62706E023703}">
+                      <ahyp:hlinkClr xmlns:ahyp="http://schemas.microsoft.com/office/drawing/2018/hyperlinkcolor" val="tx"/>
+                    </a:ext>
+                  </a:extLst>
+                </a:hlinkClick>
+              </a:rPr>
+              <a:t>Jira</a:t>
+            </a:r>
+            <a:pPr indent="0" marL="0">
+              <a:buNone/>
+            </a:pPr>
+            <a:r>
+              <a:rPr lang="en-US" sz="1100" dirty="0">
+                <a:solidFill>
+                  <a:srgbClr val="8C8C8C"/>
+                </a:solidFill>
+                <a:latin typeface="Arial" pitchFamily="34" charset="0"/>
+                <a:ea typeface="Arial" pitchFamily="34" charset="-122"/>
+                <a:cs typeface="Arial" pitchFamily="34" charset="-120"/>
+              </a:rPr>
+              <a:t>   ·   </a:t>
+            </a:r>
+            <a:pPr indent="0" marL="0">
+              <a:buNone/>
+            </a:pPr>
+            <a:r>
+              <a:rPr lang="en-US" sz="1100" b="1" u="sng" dirty="0">
+                <a:solidFill>
+                  <a:srgbClr val="000000"/>
+                </a:solidFill>
+                <a:latin typeface="Arial" pitchFamily="34" charset="0"/>
+                <a:ea typeface="Arial" pitchFamily="34" charset="-122"/>
+                <a:cs typeface="Arial" pitchFamily="34" charset="-120"/>
+                <a:hlinkClick r:id="rId3" invalidUrl="" action="" tgtFrame="" tooltip="github.com/vicitmceo/NewBalanceShop/commits/master" history="1" highlightClick="0" endSnd="0">
+                  <a:extLst>
+                    <a:ext uri="{A12FA001-AC4F-418D-AE19-62706E023703}">
+                      <ahyp:hlinkClr xmlns:ahyp="http://schemas.microsoft.com/office/drawing/2018/hyperlinkcolor" val="tx"/>
+                    </a:ext>
+                  </a:extLst>
+                </a:hlinkClick>
+              </a:rPr>
+              <a:t>Коміти</a:t>
+            </a:r>
+            <a:pPr indent="0" marL="0">
+              <a:buNone/>
+            </a:pPr>
+            <a:r>
+              <a:rPr lang="en-US" sz="1100" dirty="0">
+                <a:solidFill>
+                  <a:srgbClr val="8C8C8C"/>
+                </a:solidFill>
+                <a:latin typeface="Arial" pitchFamily="34" charset="0"/>
+                <a:ea typeface="Arial" pitchFamily="34" charset="-122"/>
+                <a:cs typeface="Arial" pitchFamily="34" charset="-120"/>
+              </a:rPr>
+              <a:t>   ·   </a:t>
+            </a:r>
+            <a:pPr indent="0" marL="0">
+              <a:buNone/>
+            </a:pPr>
+            <a:r>
+              <a:rPr lang="en-US" sz="1100" b="1" u="sng" dirty="0">
+                <a:solidFill>
+                  <a:srgbClr val="000000"/>
+                </a:solidFill>
+                <a:latin typeface="Arial" pitchFamily="34" charset="0"/>
+                <a:ea typeface="Arial" pitchFamily="34" charset="-122"/>
+                <a:cs typeface="Arial" pitchFamily="34" charset="-120"/>
+                <a:hlinkClick r:id="rId4" invalidUrl="" action="" tgtFrame="" tooltip="github.com/vicitmceo/NewBalanceShop → weekly-plan.png" history="1" highlightClick="0" endSnd="0">
+                  <a:extLst>
+                    <a:ext uri="{A12FA001-AC4F-418D-AE19-62706E023703}">
+                      <ahyp:hlinkClr xmlns:ahyp="http://schemas.microsoft.com/office/drawing/2018/hyperlinkcolor" val="tx"/>
+                    </a:ext>
+                  </a:extLst>
+                </a:hlinkClick>
+              </a:rPr>
+              <a:t>План робіт</a:t>
+            </a:r>
+            <a:endParaRPr lang="en-US" sz="1100" dirty="0"/>
+          </a:p>
+        </p:txBody>
+      </p:sp>
     </p:spTree>
   </p:cSld>
   <p:clrMapOvr>
@@ -3887,7 +5217,7 @@
       </p:grpSpPr>
       <p:pic>
         <p:nvPicPr>
-          <p:cNvPr id="2" name="Image 0" descr="Архітектура системи і розміщення">    </p:cNvPr>
+          <p:cNvPr id="2" name="Image 0" descr="Архітектура: Clean Architecture і розміщення">    </p:cNvPr>
           <p:cNvPicPr>
             <a:picLocks noChangeAspect="1"/>
           </p:cNvPicPr>
@@ -3909,6 +5239,196 @@
           </a:prstGeom>
         </p:spPr>
       </p:pic>
+      <p:sp>
+        <p:nvSpPr>
+          <p:cNvPr id="3" name="Shape 0"/>
+          <p:cNvSpPr/>
+          <p:nvPr/>
+        </p:nvSpPr>
+        <p:spPr>
+          <a:xfrm>
+            <a:off x="0" y="6597396"/>
+            <a:ext cx="12191695" cy="260604"/>
+          </a:xfrm>
+          <a:prstGeom prst="rect">
+            <a:avLst/>
+          </a:prstGeom>
+          <a:solidFill>
+            <a:srgbClr val="F4F4F4"/>
+          </a:solidFill>
+          <a:ln w="9525">
+            <a:solidFill>
+              <a:srgbClr val="E2E2E2"/>
+            </a:solidFill>
+            <a:prstDash val="solid"/>
+          </a:ln>
+        </p:spPr>
+      </p:sp>
+      <p:sp>
+        <p:nvSpPr>
+          <p:cNvPr id="4" name="Text 1"/>
+          <p:cNvSpPr/>
+          <p:nvPr/>
+        </p:nvSpPr>
+        <p:spPr>
+          <a:xfrm>
+            <a:off x="457200" y="6597396"/>
+            <a:ext cx="11277295" cy="260604"/>
+          </a:xfrm>
+          <a:prstGeom prst="rect">
+            <a:avLst/>
+          </a:prstGeom>
+          <a:noFill/>
+          <a:ln/>
+        </p:spPr>
+        <p:txBody>
+          <a:bodyPr wrap="square" lIns="0" tIns="0" rIns="0" bIns="0" rtlCol="0" anchor="ctr"/>
+          <a:lstStyle/>
+          <a:p>
+            <a:pPr indent="0" marL="0">
+              <a:buNone/>
+            </a:pPr>
+            <a:r>
+              <a:rPr lang="en-US" sz="1100" b="1" dirty="0">
+                <a:solidFill>
+                  <a:srgbClr val="5C5C5C"/>
+                </a:solidFill>
+                <a:latin typeface="Arial" pitchFamily="34" charset="0"/>
+                <a:ea typeface="Arial" pitchFamily="34" charset="-122"/>
+                <a:cs typeface="Arial" pitchFamily="34" charset="-120"/>
+              </a:rPr>
+              <a:t>Посилання:  </a:t>
+            </a:r>
+            <a:pPr indent="0" marL="0">
+              <a:buNone/>
+            </a:pPr>
+            <a:r>
+              <a:rPr lang="en-US" sz="1100" b="1" u="sng" dirty="0">
+                <a:solidFill>
+                  <a:srgbClr val="000000"/>
+                </a:solidFill>
+                <a:latin typeface="Arial" pitchFamily="34" charset="0"/>
+                <a:ea typeface="Arial" pitchFamily="34" charset="-122"/>
+                <a:cs typeface="Arial" pitchFamily="34" charset="-120"/>
+                <a:hlinkClick r:id="rId2" invalidUrl="" action="" tgtFrame="" tooltip="github.com/vicitmceo/NewBalanceShop → docs/ARCHITECTURE.md" history="1" highlightClick="0" endSnd="0">
+                  <a:extLst>
+                    <a:ext uri="{A12FA001-AC4F-418D-AE19-62706E023703}">
+                      <ahyp:hlinkClr xmlns:ahyp="http://schemas.microsoft.com/office/drawing/2018/hyperlinkcolor" val="tx"/>
+                    </a:ext>
+                  </a:extLst>
+                </a:hlinkClick>
+              </a:rPr>
+              <a:t>Архітектура</a:t>
+            </a:r>
+            <a:pPr indent="0" marL="0">
+              <a:buNone/>
+            </a:pPr>
+            <a:r>
+              <a:rPr lang="en-US" sz="1100" dirty="0">
+                <a:solidFill>
+                  <a:srgbClr val="8C8C8C"/>
+                </a:solidFill>
+                <a:latin typeface="Arial" pitchFamily="34" charset="0"/>
+                <a:ea typeface="Arial" pitchFamily="34" charset="-122"/>
+                <a:cs typeface="Arial" pitchFamily="34" charset="-120"/>
+              </a:rPr>
+              <a:t>   ·   </a:t>
+            </a:r>
+            <a:pPr indent="0" marL="0">
+              <a:buNone/>
+            </a:pPr>
+            <a:r>
+              <a:rPr lang="en-US" sz="1100" b="1" u="sng" dirty="0">
+                <a:solidFill>
+                  <a:srgbClr val="000000"/>
+                </a:solidFill>
+                <a:latin typeface="Arial" pitchFamily="34" charset="0"/>
+                <a:ea typeface="Arial" pitchFamily="34" charset="-122"/>
+                <a:cs typeface="Arial" pitchFamily="34" charset="-120"/>
+                <a:hlinkClick r:id="rId3" invalidUrl="" action="" tgtFrame="" tooltip="vicitmceo.github.io/NewBalanceShop/code/" history="1" highlightClick="0" endSnd="0">
+                  <a:extLst>
+                    <a:ext uri="{A12FA001-AC4F-418D-AE19-62706E023703}">
+                      <ahyp:hlinkClr xmlns:ahyp="http://schemas.microsoft.com/office/drawing/2018/hyperlinkcolor" val="tx"/>
+                    </a:ext>
+                  </a:extLst>
+                </a:hlinkClick>
+              </a:rPr>
+              <a:t>DocFX</a:t>
+            </a:r>
+            <a:pPr indent="0" marL="0">
+              <a:buNone/>
+            </a:pPr>
+            <a:r>
+              <a:rPr lang="en-US" sz="1100" dirty="0">
+                <a:solidFill>
+                  <a:srgbClr val="8C8C8C"/>
+                </a:solidFill>
+                <a:latin typeface="Arial" pitchFamily="34" charset="0"/>
+                <a:ea typeface="Arial" pitchFamily="34" charset="-122"/>
+                <a:cs typeface="Arial" pitchFamily="34" charset="-120"/>
+              </a:rPr>
+              <a:t>   ·   </a:t>
+            </a:r>
+            <a:pPr indent="0" marL="0">
+              <a:buNone/>
+            </a:pPr>
+            <a:r>
+              <a:rPr lang="en-US" sz="1100" b="1" u="sng" dirty="0">
+                <a:solidFill>
+                  <a:srgbClr val="000000"/>
+                </a:solidFill>
+                <a:latin typeface="Arial" pitchFamily="34" charset="0"/>
+                <a:ea typeface="Arial" pitchFamily="34" charset="-122"/>
+                <a:cs typeface="Arial" pitchFamily="34" charset="-120"/>
+                <a:hlinkClick r:id="rId4" invalidUrl="" action="" tgtFrame="" tooltip="vicitmceo.github.io/NewBalanceShop/api/" history="1" highlightClick="0" endSnd="0">
+                  <a:extLst>
+                    <a:ext uri="{A12FA001-AC4F-418D-AE19-62706E023703}">
+                      <ahyp:hlinkClr xmlns:ahyp="http://schemas.microsoft.com/office/drawing/2018/hyperlinkcolor" val="tx"/>
+                    </a:ext>
+                  </a:extLst>
+                </a:hlinkClick>
+              </a:rPr>
+              <a:t>Scalar (API)</a:t>
+            </a:r>
+            <a:pPr indent="0" marL="0">
+              <a:buNone/>
+            </a:pPr>
+            <a:r>
+              <a:rPr lang="en-US" sz="1100" dirty="0">
+                <a:solidFill>
+                  <a:srgbClr val="8C8C8C"/>
+                </a:solidFill>
+                <a:latin typeface="Arial" pitchFamily="34" charset="0"/>
+                <a:ea typeface="Arial" pitchFamily="34" charset="-122"/>
+                <a:cs typeface="Arial" pitchFamily="34" charset="-120"/>
+              </a:rPr>
+              <a:t>   ·   </a:t>
+            </a:r>
+            <a:pPr indent="0" marL="0">
+              <a:buNone/>
+            </a:pPr>
+            <a:r>
+              <a:rPr lang="en-US" sz="1100" b="1" u="sng" dirty="0">
+                <a:solidFill>
+                  <a:srgbClr val="000000"/>
+                </a:solidFill>
+                <a:latin typeface="Arial" pitchFamily="34" charset="0"/>
+                <a:ea typeface="Arial" pitchFamily="34" charset="-122"/>
+                <a:cs typeface="Arial" pitchFamily="34" charset="-120"/>
+                <a:hlinkClick r:id="rId5" invalidUrl="" action="" tgtFrame="" tooltip="github.com/vicitmceo/NewBalanceShop#readme" history="1" highlightClick="0" endSnd="0">
+                  <a:extLst>
+                    <a:ext uri="{A12FA001-AC4F-418D-AE19-62706E023703}">
+                      <ahyp:hlinkClr xmlns:ahyp="http://schemas.microsoft.com/office/drawing/2018/hyperlinkcolor" val="tx"/>
+                    </a:ext>
+                  </a:extLst>
+                </a:hlinkClick>
+              </a:rPr>
+              <a:t>README</a:t>
+            </a:r>
+            <a:endParaRPr lang="en-US" sz="1100" dirty="0"/>
+          </a:p>
+        </p:txBody>
+      </p:sp>
     </p:spTree>
   </p:cSld>
   <p:clrMapOvr>
@@ -3943,7 +5463,7 @@
       </p:grpSpPr>
       <p:pic>
         <p:nvPicPr>
-          <p:cNvPr id="2" name="Image 0" descr="Чиста архітектура: проєкти та зв'язки">    </p:cNvPr>
+          <p:cNvPr id="2" name="Image 0" descr="Живий сайт: каталог, кошик, адмін, мобільна версія">    </p:cNvPr>
           <p:cNvPicPr>
             <a:picLocks noChangeAspect="1"/>
           </p:cNvPicPr>
@@ -3965,6 +5485,126 @@
           </a:prstGeom>
         </p:spPr>
       </p:pic>
+      <p:sp>
+        <p:nvSpPr>
+          <p:cNvPr id="3" name="Shape 0"/>
+          <p:cNvSpPr/>
+          <p:nvPr/>
+        </p:nvSpPr>
+        <p:spPr>
+          <a:xfrm>
+            <a:off x="0" y="6597396"/>
+            <a:ext cx="12191695" cy="260604"/>
+          </a:xfrm>
+          <a:prstGeom prst="rect">
+            <a:avLst/>
+          </a:prstGeom>
+          <a:solidFill>
+            <a:srgbClr val="F4F4F4"/>
+          </a:solidFill>
+          <a:ln w="9525">
+            <a:solidFill>
+              <a:srgbClr val="E2E2E2"/>
+            </a:solidFill>
+            <a:prstDash val="solid"/>
+          </a:ln>
+        </p:spPr>
+      </p:sp>
+      <p:sp>
+        <p:nvSpPr>
+          <p:cNvPr id="4" name="Text 1"/>
+          <p:cNvSpPr/>
+          <p:nvPr/>
+        </p:nvSpPr>
+        <p:spPr>
+          <a:xfrm>
+            <a:off x="457200" y="6597396"/>
+            <a:ext cx="11277295" cy="260604"/>
+          </a:xfrm>
+          <a:prstGeom prst="rect">
+            <a:avLst/>
+          </a:prstGeom>
+          <a:noFill/>
+          <a:ln/>
+        </p:spPr>
+        <p:txBody>
+          <a:bodyPr wrap="square" lIns="0" tIns="0" rIns="0" bIns="0" rtlCol="0" anchor="ctr"/>
+          <a:lstStyle/>
+          <a:p>
+            <a:pPr indent="0" marL="0">
+              <a:buNone/>
+            </a:pPr>
+            <a:r>
+              <a:rPr lang="en-US" sz="1100" b="1" dirty="0">
+                <a:solidFill>
+                  <a:srgbClr val="5C5C5C"/>
+                </a:solidFill>
+                <a:latin typeface="Arial" pitchFamily="34" charset="0"/>
+                <a:ea typeface="Arial" pitchFamily="34" charset="-122"/>
+                <a:cs typeface="Arial" pitchFamily="34" charset="-120"/>
+              </a:rPr>
+              <a:t>Посилання:  </a:t>
+            </a:r>
+            <a:pPr indent="0" marL="0">
+              <a:buNone/>
+            </a:pPr>
+            <a:r>
+              <a:rPr lang="en-US" sz="1100" b="1" u="sng" dirty="0">
+                <a:solidFill>
+                  <a:srgbClr val="000000"/>
+                </a:solidFill>
+                <a:latin typeface="Arial" pitchFamily="34" charset="0"/>
+                <a:ea typeface="Arial" pitchFamily="34" charset="-122"/>
+                <a:cs typeface="Arial" pitchFamily="34" charset="-120"/>
+                <a:hlinkClick r:id="rId2" invalidUrl="" action="" tgtFrame="" tooltip="newbalance.cc.cd" history="1" highlightClick="0" endSnd="0">
+                  <a:extLst>
+                    <a:ext uri="{A12FA001-AC4F-418D-AE19-62706E023703}">
+                      <ahyp:hlinkClr xmlns:ahyp="http://schemas.microsoft.com/office/drawing/2018/hyperlinkcolor" val="tx"/>
+                    </a:ext>
+                  </a:extLst>
+                </a:hlinkClick>
+              </a:rPr>
+              <a:t>Сайт</a:t>
+            </a:r>
+            <a:pPr indent="0" marL="0">
+              <a:buNone/>
+            </a:pPr>
+            <a:r>
+              <a:rPr lang="en-US" sz="1100" dirty="0">
+                <a:solidFill>
+                  <a:srgbClr val="8C8C8C"/>
+                </a:solidFill>
+                <a:latin typeface="Arial" pitchFamily="34" charset="0"/>
+                <a:ea typeface="Arial" pitchFamily="34" charset="-122"/>
+                <a:cs typeface="Arial" pitchFamily="34" charset="-120"/>
+              </a:rPr>
+              <a:t>   ·   </a:t>
+            </a:r>
+            <a:pPr indent="0" marL="0">
+              <a:buNone/>
+            </a:pPr>
+            <a:r>
+              <a:rPr lang="en-US" sz="1100" b="1" u="sng" dirty="0">
+                <a:solidFill>
+                  <a:srgbClr val="000000"/>
+                </a:solidFill>
+                <a:latin typeface="Arial" pitchFamily="34" charset="0"/>
+                <a:ea typeface="Arial" pitchFamily="34" charset="-122"/>
+                <a:cs typeface="Arial" pitchFamily="34" charset="-120"/>
+                <a:hlinkClick r:id="rId3" invalidUrl="" action="" tgtFrame="" tooltip="github.com/vicitmceo/newbalanceshop-frontend" history="1" highlightClick="0" endSnd="0">
+                  <a:extLst>
+                    <a:ext uri="{A12FA001-AC4F-418D-AE19-62706E023703}">
+                      <ahyp:hlinkClr xmlns:ahyp="http://schemas.microsoft.com/office/drawing/2018/hyperlinkcolor" val="tx"/>
+                    </a:ext>
+                  </a:extLst>
+                </a:hlinkClick>
+              </a:rPr>
+              <a:t>Фронтенд (репо)</a:t>
+            </a:r>
+            <a:endParaRPr lang="en-US" sz="1100" dirty="0"/>
+          </a:p>
+        </p:txBody>
+      </p:sp>
     </p:spTree>
   </p:cSld>
   <p:clrMapOvr>
@@ -3999,7 +5639,7 @@
       </p:grpSpPr>
       <p:pic>
         <p:nvPicPr>
-          <p:cNvPr id="2" name="Image 0" descr="Використані патерни проєктування">    </p:cNvPr>
+          <p:cNvPr id="2" name="Image 0" descr="Безпека, тести, CI, метрики">    </p:cNvPr>
           <p:cNvPicPr>
             <a:picLocks noChangeAspect="1"/>
           </p:cNvPicPr>
@@ -4021,6 +5661,161 @@
           </a:prstGeom>
         </p:spPr>
       </p:pic>
+      <p:sp>
+        <p:nvSpPr>
+          <p:cNvPr id="3" name="Shape 0"/>
+          <p:cNvSpPr/>
+          <p:nvPr/>
+        </p:nvSpPr>
+        <p:spPr>
+          <a:xfrm>
+            <a:off x="0" y="6597396"/>
+            <a:ext cx="12191695" cy="260604"/>
+          </a:xfrm>
+          <a:prstGeom prst="rect">
+            <a:avLst/>
+          </a:prstGeom>
+          <a:solidFill>
+            <a:srgbClr val="F4F4F4"/>
+          </a:solidFill>
+          <a:ln w="9525">
+            <a:solidFill>
+              <a:srgbClr val="E2E2E2"/>
+            </a:solidFill>
+            <a:prstDash val="solid"/>
+          </a:ln>
+        </p:spPr>
+      </p:sp>
+      <p:sp>
+        <p:nvSpPr>
+          <p:cNvPr id="4" name="Text 1"/>
+          <p:cNvSpPr/>
+          <p:nvPr/>
+        </p:nvSpPr>
+        <p:spPr>
+          <a:xfrm>
+            <a:off x="457200" y="6597396"/>
+            <a:ext cx="11277295" cy="260604"/>
+          </a:xfrm>
+          <a:prstGeom prst="rect">
+            <a:avLst/>
+          </a:prstGeom>
+          <a:noFill/>
+          <a:ln/>
+        </p:spPr>
+        <p:txBody>
+          <a:bodyPr wrap="square" lIns="0" tIns="0" rIns="0" bIns="0" rtlCol="0" anchor="ctr"/>
+          <a:lstStyle/>
+          <a:p>
+            <a:pPr indent="0" marL="0">
+              <a:buNone/>
+            </a:pPr>
+            <a:r>
+              <a:rPr lang="en-US" sz="1100" b="1" dirty="0">
+                <a:solidFill>
+                  <a:srgbClr val="5C5C5C"/>
+                </a:solidFill>
+                <a:latin typeface="Arial" pitchFamily="34" charset="0"/>
+                <a:ea typeface="Arial" pitchFamily="34" charset="-122"/>
+                <a:cs typeface="Arial" pitchFamily="34" charset="-120"/>
+              </a:rPr>
+              <a:t>Посилання:  </a:t>
+            </a:r>
+            <a:pPr indent="0" marL="0">
+              <a:buNone/>
+            </a:pPr>
+            <a:r>
+              <a:rPr lang="en-US" sz="1100" b="1" u="sng" dirty="0">
+                <a:solidFill>
+                  <a:srgbClr val="000000"/>
+                </a:solidFill>
+                <a:latin typeface="Arial" pitchFamily="34" charset="0"/>
+                <a:ea typeface="Arial" pitchFamily="34" charset="-122"/>
+                <a:cs typeface="Arial" pitchFamily="34" charset="-120"/>
+                <a:hlinkClick r:id="rId2" invalidUrl="" action="" tgtFrame="" tooltip="github.com/vicitmceo/NewBalanceShop/commits/master" history="1" highlightClick="0" endSnd="0">
+                  <a:extLst>
+                    <a:ext uri="{A12FA001-AC4F-418D-AE19-62706E023703}">
+                      <ahyp:hlinkClr xmlns:ahyp="http://schemas.microsoft.com/office/drawing/2018/hyperlinkcolor" val="tx"/>
+                    </a:ext>
+                  </a:extLst>
+                </a:hlinkClick>
+              </a:rPr>
+              <a:t>Коміти</a:t>
+            </a:r>
+            <a:pPr indent="0" marL="0">
+              <a:buNone/>
+            </a:pPr>
+            <a:r>
+              <a:rPr lang="en-US" sz="1100" dirty="0">
+                <a:solidFill>
+                  <a:srgbClr val="8C8C8C"/>
+                </a:solidFill>
+                <a:latin typeface="Arial" pitchFamily="34" charset="0"/>
+                <a:ea typeface="Arial" pitchFamily="34" charset="-122"/>
+                <a:cs typeface="Arial" pitchFamily="34" charset="-120"/>
+              </a:rPr>
+              <a:t>   ·   </a:t>
+            </a:r>
+            <a:pPr indent="0" marL="0">
+              <a:buNone/>
+            </a:pPr>
+            <a:r>
+              <a:rPr lang="en-US" sz="1100" b="1" u="sng" dirty="0">
+                <a:solidFill>
+                  <a:srgbClr val="000000"/>
+                </a:solidFill>
+                <a:latin typeface="Arial" pitchFamily="34" charset="0"/>
+                <a:ea typeface="Arial" pitchFamily="34" charset="-122"/>
+                <a:cs typeface="Arial" pitchFamily="34" charset="-120"/>
+                <a:hlinkClick r:id="rId3" invalidUrl="" action="" tgtFrame="" tooltip="github.com/vicitmceo/NewBalanceShop#readme" history="1" highlightClick="0" endSnd="0">
+                  <a:extLst>
+                    <a:ext uri="{A12FA001-AC4F-418D-AE19-62706E023703}">
+                      <ahyp:hlinkClr xmlns:ahyp="http://schemas.microsoft.com/office/drawing/2018/hyperlinkcolor" val="tx"/>
+                    </a:ext>
+                  </a:extLst>
+                </a:hlinkClick>
+              </a:rPr>
+              <a:t>README</a:t>
+            </a:r>
+            <a:pPr indent="0" marL="0">
+              <a:buNone/>
+            </a:pPr>
+            <a:r>
+              <a:rPr lang="en-US" sz="1100" dirty="0">
+                <a:solidFill>
+                  <a:srgbClr val="8C8C8C"/>
+                </a:solidFill>
+                <a:latin typeface="Arial" pitchFamily="34" charset="0"/>
+                <a:ea typeface="Arial" pitchFamily="34" charset="-122"/>
+                <a:cs typeface="Arial" pitchFamily="34" charset="-120"/>
+              </a:rPr>
+              <a:t>   ·   </a:t>
+            </a:r>
+            <a:pPr indent="0" marL="0">
+              <a:buNone/>
+            </a:pPr>
+            <a:r>
+              <a:rPr lang="en-US" sz="1100" b="1" u="sng" dirty="0">
+                <a:solidFill>
+                  <a:srgbClr val="000000"/>
+                </a:solidFill>
+                <a:latin typeface="Arial" pitchFamily="34" charset="0"/>
+                <a:ea typeface="Arial" pitchFamily="34" charset="-122"/>
+                <a:cs typeface="Arial" pitchFamily="34" charset="-120"/>
+                <a:hlinkClick r:id="rId4" invalidUrl="" action="" tgtFrame="" tooltip="vicitmceo.github.io/NewBalanceShop/api/" history="1" highlightClick="0" endSnd="0">
+                  <a:extLst>
+                    <a:ext uri="{A12FA001-AC4F-418D-AE19-62706E023703}">
+                      <ahyp:hlinkClr xmlns:ahyp="http://schemas.microsoft.com/office/drawing/2018/hyperlinkcolor" val="tx"/>
+                    </a:ext>
+                  </a:extLst>
+                </a:hlinkClick>
+              </a:rPr>
+              <a:t>Scalar (API)</a:t>
+            </a:r>
+            <a:endParaRPr lang="en-US" sz="1100" dirty="0"/>
+          </a:p>
+        </p:txBody>
+      </p:sp>
     </p:spTree>
   </p:cSld>
   <p:clrMapOvr>
@@ -4035,7 +5830,7 @@
     <p:bg>
       <p:bgPr>
         <a:solidFill>
-          <a:srgbClr val="111111"/>
+          <a:srgbClr val="FFFFFF"/>
         </a:solidFill>
       </p:bgPr>
     </p:bg>
@@ -4053,30 +5848,1019 @@
           <a:chExt cx="0" cy="0"/>
         </a:xfrm>
       </p:grpSpPr>
-      <p:pic>
-        <p:nvPicPr>
-          <p:cNvPr id="2" name="Image 0" descr="ER-діаграма бази даних PostgreSQL">    </p:cNvPr>
-          <p:cNvPicPr>
-            <a:picLocks noChangeAspect="1"/>
-          </p:cNvPicPr>
+      <p:sp>
+        <p:nvSpPr>
+          <p:cNvPr id="2" name="Text 0"/>
+          <p:cNvSpPr/>
           <p:nvPr/>
-        </p:nvPicPr>
-        <p:blipFill>
-          <a:blip r:embed="rId1"/>
-          <a:stretch>
-            <a:fillRect/>
-          </a:stretch>
-        </p:blipFill>
+        </p:nvSpPr>
         <p:spPr>
           <a:xfrm>
-            <a:off x="0" y="0"/>
-            <a:ext cx="12191695" cy="6858000"/>
+            <a:off x="502920" y="228600"/>
+            <a:ext cx="7315200" cy="731520"/>
           </a:xfrm>
           <a:prstGeom prst="rect">
             <a:avLst/>
           </a:prstGeom>
+          <a:noFill/>
+          <a:ln/>
         </p:spPr>
-      </p:pic>
+        <p:txBody>
+          <a:bodyPr wrap="square" lIns="0" tIns="0" rIns="0" bIns="0" rtlCol="0" anchor="ctr"/>
+          <a:lstStyle/>
+          <a:p>
+            <a:pPr indent="0" marL="0">
+              <a:buNone/>
+            </a:pPr>
+            <a:r>
+              <a:rPr lang="en-US" sz="3800" b="1" dirty="0">
+                <a:solidFill>
+                  <a:srgbClr val="111111"/>
+                </a:solidFill>
+                <a:latin typeface="Arial" pitchFamily="34" charset="0"/>
+                <a:ea typeface="Arial" pitchFamily="34" charset="-122"/>
+                <a:cs typeface="Arial" pitchFamily="34" charset="-120"/>
+              </a:rPr>
+              <a:t>Посилання</a:t>
+            </a:r>
+            <a:endParaRPr lang="en-US" sz="3800" dirty="0"/>
+          </a:p>
+        </p:txBody>
+      </p:sp>
+      <p:sp>
+        <p:nvSpPr>
+          <p:cNvPr id="3" name="Text 1"/>
+          <p:cNvSpPr/>
+          <p:nvPr/>
+        </p:nvSpPr>
+        <p:spPr>
+          <a:xfrm>
+            <a:off x="502920" y="868680"/>
+            <a:ext cx="8229600" cy="320040"/>
+          </a:xfrm>
+          <a:prstGeom prst="rect">
+            <a:avLst/>
+          </a:prstGeom>
+          <a:noFill/>
+          <a:ln/>
+        </p:spPr>
+        <p:txBody>
+          <a:bodyPr wrap="square" lIns="0" tIns="0" rIns="0" bIns="0" rtlCol="0" anchor="ctr"/>
+          <a:lstStyle/>
+          <a:p>
+            <a:pPr indent="0" marL="0">
+              <a:buNone/>
+            </a:pPr>
+            <a:r>
+              <a:rPr lang="en-US" sz="1500" b="1" dirty="0">
+                <a:solidFill>
+                  <a:srgbClr val="5C5C5C"/>
+                </a:solidFill>
+                <a:latin typeface="Arial" pitchFamily="34" charset="0"/>
+                <a:ea typeface="Arial" pitchFamily="34" charset="-122"/>
+                <a:cs typeface="Arial" pitchFamily="34" charset="-120"/>
+              </a:rPr>
+              <a:t>Усі матеріали проєкту клікабельні</a:t>
+            </a:r>
+            <a:endParaRPr lang="en-US" sz="1500" dirty="0"/>
+          </a:p>
+        </p:txBody>
+      </p:sp>
+      <p:sp>
+        <p:nvSpPr>
+          <p:cNvPr id="4" name="Shape 2"/>
+          <p:cNvSpPr/>
+          <p:nvPr/>
+        </p:nvSpPr>
+        <p:spPr>
+          <a:xfrm>
+            <a:off x="0" y="1325880"/>
+            <a:ext cx="12191695" cy="0"/>
+          </a:xfrm>
+          <a:prstGeom prst="line">
+            <a:avLst/>
+          </a:prstGeom>
+          <a:noFill/>
+          <a:ln w="12700">
+            <a:solidFill>
+              <a:srgbClr val="E2E2E2"/>
+            </a:solidFill>
+            <a:prstDash val="solid"/>
+          </a:ln>
+        </p:spPr>
+      </p:sp>
+      <p:sp>
+        <p:nvSpPr>
+          <p:cNvPr id="5" name="Shape 3"/>
+          <p:cNvSpPr/>
+          <p:nvPr/>
+        </p:nvSpPr>
+        <p:spPr>
+          <a:xfrm>
+            <a:off x="502920" y="1554480"/>
+            <a:ext cx="3611880" cy="1371600"/>
+          </a:xfrm>
+          <a:prstGeom prst="roundRect">
+            <a:avLst>
+              <a:gd name="adj" fmla="val 6667"/>
+            </a:avLst>
+          </a:prstGeom>
+          <a:solidFill>
+            <a:srgbClr val="FFFFFF"/>
+          </a:solidFill>
+          <a:ln w="12700">
+            <a:solidFill>
+              <a:srgbClr val="E2E2E2"/>
+            </a:solidFill>
+            <a:prstDash val="solid"/>
+          </a:ln>
+        </p:spPr>
+      </p:sp>
+      <p:sp>
+        <p:nvSpPr>
+          <p:cNvPr id="6" name="Text 4"/>
+          <p:cNvSpPr/>
+          <p:nvPr/>
+        </p:nvSpPr>
+        <p:spPr>
+          <a:xfrm>
+            <a:off x="685800" y="1664208"/>
+            <a:ext cx="3246120" cy="1152144"/>
+          </a:xfrm>
+          <a:prstGeom prst="rect">
+            <a:avLst/>
+          </a:prstGeom>
+          <a:noFill/>
+          <a:ln/>
+        </p:spPr>
+        <p:txBody>
+          <a:bodyPr wrap="square" lIns="0" tIns="0" rIns="0" bIns="0" rtlCol="0" anchor="ctr"/>
+          <a:lstStyle/>
+          <a:p>
+            <a:pPr indent="0" marL="0">
+              <a:buNone/>
+            </a:pPr>
+            <a:r>
+              <a:rPr lang="en-US" sz="2400" b="1" u="sng" dirty="0">
+                <a:solidFill>
+                  <a:srgbClr val="000000"/>
+                </a:solidFill>
+                <a:latin typeface="Arial" pitchFamily="34" charset="0"/>
+                <a:ea typeface="Arial" pitchFamily="34" charset="-122"/>
+                <a:cs typeface="Arial" pitchFamily="34" charset="-120"/>
+                <a:hlinkClick r:id="rId1" invalidUrl="" action="" tgtFrame="" tooltip="https://github.com/vicitmceo/NewBalanceShop/blob/master/defense-materials/02-srs-and-plan/weekly-plan.png" history="1" highlightClick="0" endSnd="0">
+                  <a:extLst>
+                    <a:ext uri="{A12FA001-AC4F-418D-AE19-62706E023703}">
+                      <ahyp:hlinkClr xmlns:ahyp="http://schemas.microsoft.com/office/drawing/2018/hyperlinkcolor" val="tx"/>
+                    </a:ext>
+                  </a:extLst>
+                </a:hlinkClick>
+              </a:rPr>
+              <a:t>План робіт</a:t>
+            </a:r>
+            <a:endParaRPr lang="en-US" sz="2400" dirty="0"/>
+          </a:p>
+          <a:p>
+            <a:pPr indent="0" marL="0">
+              <a:buNone/>
+            </a:pPr>
+            <a:r>
+              <a:rPr lang="en-US" sz="1200" u="sng" dirty="0">
+                <a:solidFill>
+                  <a:srgbClr val="000000"/>
+                </a:solidFill>
+                <a:latin typeface="Arial" pitchFamily="34" charset="0"/>
+                <a:ea typeface="Arial" pitchFamily="34" charset="-122"/>
+                <a:cs typeface="Arial" pitchFamily="34" charset="-120"/>
+                <a:hlinkClick r:id="rId2" invalidUrl="" action="" tgtFrame="" tooltip="https://github.com/vicitmceo/NewBalanceShop/blob/master/defense-materials/02-srs-and-plan/weekly-plan.png" history="1" highlightClick="0" endSnd="0">
+                  <a:extLst>
+                    <a:ext uri="{A12FA001-AC4F-418D-AE19-62706E023703}">
+                      <ahyp:hlinkClr xmlns:ahyp="http://schemas.microsoft.com/office/drawing/2018/hyperlinkcolor" val="tx"/>
+                    </a:ext>
+                  </a:extLst>
+                </a:hlinkClick>
+              </a:rPr>
+              <a:t>github.com/vicitmceo/NewBalanceShop → weekly-plan.png</a:t>
+            </a:r>
+            <a:endParaRPr lang="en-US" sz="2400" dirty="0"/>
+          </a:p>
+        </p:txBody>
+      </p:sp>
+      <p:sp>
+        <p:nvSpPr>
+          <p:cNvPr id="7" name="Shape 5"/>
+          <p:cNvSpPr/>
+          <p:nvPr/>
+        </p:nvSpPr>
+        <p:spPr>
+          <a:xfrm>
+            <a:off x="4297680" y="1554480"/>
+            <a:ext cx="3611880" cy="1371600"/>
+          </a:xfrm>
+          <a:prstGeom prst="roundRect">
+            <a:avLst>
+              <a:gd name="adj" fmla="val 6667"/>
+            </a:avLst>
+          </a:prstGeom>
+          <a:solidFill>
+            <a:srgbClr val="FFFFFF"/>
+          </a:solidFill>
+          <a:ln w="12700">
+            <a:solidFill>
+              <a:srgbClr val="E2E2E2"/>
+            </a:solidFill>
+            <a:prstDash val="solid"/>
+          </a:ln>
+        </p:spPr>
+      </p:sp>
+      <p:sp>
+        <p:nvSpPr>
+          <p:cNvPr id="8" name="Text 6"/>
+          <p:cNvSpPr/>
+          <p:nvPr/>
+        </p:nvSpPr>
+        <p:spPr>
+          <a:xfrm>
+            <a:off x="4480560" y="1664208"/>
+            <a:ext cx="3246120" cy="1152144"/>
+          </a:xfrm>
+          <a:prstGeom prst="rect">
+            <a:avLst/>
+          </a:prstGeom>
+          <a:noFill/>
+          <a:ln/>
+        </p:spPr>
+        <p:txBody>
+          <a:bodyPr wrap="square" lIns="0" tIns="0" rIns="0" bIns="0" rtlCol="0" anchor="ctr"/>
+          <a:lstStyle/>
+          <a:p>
+            <a:pPr indent="0" marL="0">
+              <a:buNone/>
+            </a:pPr>
+            <a:r>
+              <a:rPr lang="en-US" sz="2400" b="1" u="sng" dirty="0">
+                <a:solidFill>
+                  <a:srgbClr val="000000"/>
+                </a:solidFill>
+                <a:latin typeface="Arial" pitchFamily="34" charset="0"/>
+                <a:ea typeface="Arial" pitchFamily="34" charset="-122"/>
+                <a:cs typeface="Arial" pitchFamily="34" charset="-120"/>
+                <a:hlinkClick r:id="rId3" invalidUrl="" action="" tgtFrame="" tooltip="https://github.com/vicitmceo/NewBalanceShop/blob/master/SRS.md" history="1" highlightClick="0" endSnd="0">
+                  <a:extLst>
+                    <a:ext uri="{A12FA001-AC4F-418D-AE19-62706E023703}">
+                      <ahyp:hlinkClr xmlns:ahyp="http://schemas.microsoft.com/office/drawing/2018/hyperlinkcolor" val="tx"/>
+                    </a:ext>
+                  </a:extLst>
+                </a:hlinkClick>
+              </a:rPr>
+              <a:t>SRS</a:t>
+            </a:r>
+            <a:endParaRPr lang="en-US" sz="2400" dirty="0"/>
+          </a:p>
+          <a:p>
+            <a:pPr indent="0" marL="0">
+              <a:buNone/>
+            </a:pPr>
+            <a:r>
+              <a:rPr lang="en-US" sz="1200" u="sng" dirty="0">
+                <a:solidFill>
+                  <a:srgbClr val="000000"/>
+                </a:solidFill>
+                <a:latin typeface="Arial" pitchFamily="34" charset="0"/>
+                <a:ea typeface="Arial" pitchFamily="34" charset="-122"/>
+                <a:cs typeface="Arial" pitchFamily="34" charset="-120"/>
+                <a:hlinkClick r:id="rId4" invalidUrl="" action="" tgtFrame="" tooltip="https://github.com/vicitmceo/NewBalanceShop/blob/master/SRS.md" history="1" highlightClick="0" endSnd="0">
+                  <a:extLst>
+                    <a:ext uri="{A12FA001-AC4F-418D-AE19-62706E023703}">
+                      <ahyp:hlinkClr xmlns:ahyp="http://schemas.microsoft.com/office/drawing/2018/hyperlinkcolor" val="tx"/>
+                    </a:ext>
+                  </a:extLst>
+                </a:hlinkClick>
+              </a:rPr>
+              <a:t>github.com/vicitmceo/NewBalanceShop → SRS.md</a:t>
+            </a:r>
+            <a:endParaRPr lang="en-US" sz="2400" dirty="0"/>
+          </a:p>
+        </p:txBody>
+      </p:sp>
+      <p:sp>
+        <p:nvSpPr>
+          <p:cNvPr id="9" name="Shape 7"/>
+          <p:cNvSpPr/>
+          <p:nvPr/>
+        </p:nvSpPr>
+        <p:spPr>
+          <a:xfrm>
+            <a:off x="8092440" y="1554480"/>
+            <a:ext cx="3611880" cy="1371600"/>
+          </a:xfrm>
+          <a:prstGeom prst="roundRect">
+            <a:avLst>
+              <a:gd name="adj" fmla="val 6667"/>
+            </a:avLst>
+          </a:prstGeom>
+          <a:solidFill>
+            <a:srgbClr val="FFFFFF"/>
+          </a:solidFill>
+          <a:ln w="12700">
+            <a:solidFill>
+              <a:srgbClr val="E2E2E2"/>
+            </a:solidFill>
+            <a:prstDash val="solid"/>
+          </a:ln>
+        </p:spPr>
+      </p:sp>
+      <p:sp>
+        <p:nvSpPr>
+          <p:cNvPr id="10" name="Text 8"/>
+          <p:cNvSpPr/>
+          <p:nvPr/>
+        </p:nvSpPr>
+        <p:spPr>
+          <a:xfrm>
+            <a:off x="8275320" y="1664208"/>
+            <a:ext cx="3246120" cy="1152144"/>
+          </a:xfrm>
+          <a:prstGeom prst="rect">
+            <a:avLst/>
+          </a:prstGeom>
+          <a:noFill/>
+          <a:ln/>
+        </p:spPr>
+        <p:txBody>
+          <a:bodyPr wrap="square" lIns="0" tIns="0" rIns="0" bIns="0" rtlCol="0" anchor="ctr"/>
+          <a:lstStyle/>
+          <a:p>
+            <a:pPr indent="0" marL="0">
+              <a:buNone/>
+            </a:pPr>
+            <a:r>
+              <a:rPr lang="en-US" sz="2400" b="1" u="sng" dirty="0">
+                <a:solidFill>
+                  <a:srgbClr val="000000"/>
+                </a:solidFill>
+                <a:latin typeface="Arial" pitchFamily="34" charset="0"/>
+                <a:ea typeface="Arial" pitchFamily="34" charset="-122"/>
+                <a:cs typeface="Arial" pitchFamily="34" charset="-120"/>
+                <a:hlinkClick r:id="rId5" invalidUrl="" action="" tgtFrame="" tooltip="https://github.com/vicitmceo/NewBalanceShop/blob/master/docs/ARCHITECTURE.md" history="1" highlightClick="0" endSnd="0">
+                  <a:extLst>
+                    <a:ext uri="{A12FA001-AC4F-418D-AE19-62706E023703}">
+                      <ahyp:hlinkClr xmlns:ahyp="http://schemas.microsoft.com/office/drawing/2018/hyperlinkcolor" val="tx"/>
+                    </a:ext>
+                  </a:extLst>
+                </a:hlinkClick>
+              </a:rPr>
+              <a:t>Архітектура</a:t>
+            </a:r>
+            <a:endParaRPr lang="en-US" sz="2400" dirty="0"/>
+          </a:p>
+          <a:p>
+            <a:pPr indent="0" marL="0">
+              <a:buNone/>
+            </a:pPr>
+            <a:r>
+              <a:rPr lang="en-US" sz="1200" u="sng" dirty="0">
+                <a:solidFill>
+                  <a:srgbClr val="000000"/>
+                </a:solidFill>
+                <a:latin typeface="Arial" pitchFamily="34" charset="0"/>
+                <a:ea typeface="Arial" pitchFamily="34" charset="-122"/>
+                <a:cs typeface="Arial" pitchFamily="34" charset="-120"/>
+                <a:hlinkClick r:id="rId6" invalidUrl="" action="" tgtFrame="" tooltip="https://github.com/vicitmceo/NewBalanceShop/blob/master/docs/ARCHITECTURE.md" history="1" highlightClick="0" endSnd="0">
+                  <a:extLst>
+                    <a:ext uri="{A12FA001-AC4F-418D-AE19-62706E023703}">
+                      <ahyp:hlinkClr xmlns:ahyp="http://schemas.microsoft.com/office/drawing/2018/hyperlinkcolor" val="tx"/>
+                    </a:ext>
+                  </a:extLst>
+                </a:hlinkClick>
+              </a:rPr>
+              <a:t>github.com/vicitmceo/NewBalanceShop → docs/ARCHITECTURE.md</a:t>
+            </a:r>
+            <a:endParaRPr lang="en-US" sz="2400" dirty="0"/>
+          </a:p>
+        </p:txBody>
+      </p:sp>
+      <p:sp>
+        <p:nvSpPr>
+          <p:cNvPr id="11" name="Shape 9"/>
+          <p:cNvSpPr/>
+          <p:nvPr/>
+        </p:nvSpPr>
+        <p:spPr>
+          <a:xfrm>
+            <a:off x="502920" y="3108960"/>
+            <a:ext cx="3611880" cy="1371600"/>
+          </a:xfrm>
+          <a:prstGeom prst="roundRect">
+            <a:avLst>
+              <a:gd name="adj" fmla="val 6667"/>
+            </a:avLst>
+          </a:prstGeom>
+          <a:solidFill>
+            <a:srgbClr val="FFFFFF"/>
+          </a:solidFill>
+          <a:ln w="12700">
+            <a:solidFill>
+              <a:srgbClr val="E2E2E2"/>
+            </a:solidFill>
+            <a:prstDash val="solid"/>
+          </a:ln>
+        </p:spPr>
+      </p:sp>
+      <p:sp>
+        <p:nvSpPr>
+          <p:cNvPr id="12" name="Text 10"/>
+          <p:cNvSpPr/>
+          <p:nvPr/>
+        </p:nvSpPr>
+        <p:spPr>
+          <a:xfrm>
+            <a:off x="685800" y="3218688"/>
+            <a:ext cx="3246120" cy="1152144"/>
+          </a:xfrm>
+          <a:prstGeom prst="rect">
+            <a:avLst/>
+          </a:prstGeom>
+          <a:noFill/>
+          <a:ln/>
+        </p:spPr>
+        <p:txBody>
+          <a:bodyPr wrap="square" lIns="0" tIns="0" rIns="0" bIns="0" rtlCol="0" anchor="ctr"/>
+          <a:lstStyle/>
+          <a:p>
+            <a:pPr indent="0" marL="0">
+              <a:buNone/>
+            </a:pPr>
+            <a:r>
+              <a:rPr lang="en-US" sz="2400" b="1" u="sng" dirty="0">
+                <a:solidFill>
+                  <a:srgbClr val="000000"/>
+                </a:solidFill>
+                <a:latin typeface="Arial" pitchFamily="34" charset="0"/>
+                <a:ea typeface="Arial" pitchFamily="34" charset="-122"/>
+                <a:cs typeface="Arial" pitchFamily="34" charset="-120"/>
+                <a:hlinkClick r:id="rId7" invalidUrl="" action="" tgtFrame="" tooltip="https://newbalance-team1.atlassian.net/jira/software/projects/SCRUM/boards/1/backlog" history="1" highlightClick="0" endSnd="0">
+                  <a:extLst>
+                    <a:ext uri="{A12FA001-AC4F-418D-AE19-62706E023703}">
+                      <ahyp:hlinkClr xmlns:ahyp="http://schemas.microsoft.com/office/drawing/2018/hyperlinkcolor" val="tx"/>
+                    </a:ext>
+                  </a:extLst>
+                </a:hlinkClick>
+              </a:rPr>
+              <a:t>Jira</a:t>
+            </a:r>
+            <a:endParaRPr lang="en-US" sz="2400" dirty="0"/>
+          </a:p>
+          <a:p>
+            <a:pPr indent="0" marL="0">
+              <a:buNone/>
+            </a:pPr>
+            <a:r>
+              <a:rPr lang="en-US" sz="1200" u="sng" dirty="0">
+                <a:solidFill>
+                  <a:srgbClr val="000000"/>
+                </a:solidFill>
+                <a:latin typeface="Arial" pitchFamily="34" charset="0"/>
+                <a:ea typeface="Arial" pitchFamily="34" charset="-122"/>
+                <a:cs typeface="Arial" pitchFamily="34" charset="-120"/>
+                <a:hlinkClick r:id="rId8" invalidUrl="" action="" tgtFrame="" tooltip="https://newbalance-team1.atlassian.net/jira/software/projects/SCRUM/boards/1/backlog" history="1" highlightClick="0" endSnd="0">
+                  <a:extLst>
+                    <a:ext uri="{A12FA001-AC4F-418D-AE19-62706E023703}">
+                      <ahyp:hlinkClr xmlns:ahyp="http://schemas.microsoft.com/office/drawing/2018/hyperlinkcolor" val="tx"/>
+                    </a:ext>
+                  </a:extLst>
+                </a:hlinkClick>
+              </a:rPr>
+              <a:t>newbalance-team1.atlassian.net → SCRUM board</a:t>
+            </a:r>
+            <a:endParaRPr lang="en-US" sz="2400" dirty="0"/>
+          </a:p>
+        </p:txBody>
+      </p:sp>
+      <p:sp>
+        <p:nvSpPr>
+          <p:cNvPr id="13" name="Shape 11"/>
+          <p:cNvSpPr/>
+          <p:nvPr/>
+        </p:nvSpPr>
+        <p:spPr>
+          <a:xfrm>
+            <a:off x="4297680" y="3108960"/>
+            <a:ext cx="3611880" cy="1371600"/>
+          </a:xfrm>
+          <a:prstGeom prst="roundRect">
+            <a:avLst>
+              <a:gd name="adj" fmla="val 6667"/>
+            </a:avLst>
+          </a:prstGeom>
+          <a:solidFill>
+            <a:srgbClr val="FFFFFF"/>
+          </a:solidFill>
+          <a:ln w="12700">
+            <a:solidFill>
+              <a:srgbClr val="E2E2E2"/>
+            </a:solidFill>
+            <a:prstDash val="solid"/>
+          </a:ln>
+        </p:spPr>
+      </p:sp>
+      <p:sp>
+        <p:nvSpPr>
+          <p:cNvPr id="14" name="Text 12"/>
+          <p:cNvSpPr/>
+          <p:nvPr/>
+        </p:nvSpPr>
+        <p:spPr>
+          <a:xfrm>
+            <a:off x="4480560" y="3218688"/>
+            <a:ext cx="3246120" cy="1152144"/>
+          </a:xfrm>
+          <a:prstGeom prst="rect">
+            <a:avLst/>
+          </a:prstGeom>
+          <a:noFill/>
+          <a:ln/>
+        </p:spPr>
+        <p:txBody>
+          <a:bodyPr wrap="square" lIns="0" tIns="0" rIns="0" bIns="0" rtlCol="0" anchor="ctr"/>
+          <a:lstStyle/>
+          <a:p>
+            <a:pPr indent="0" marL="0">
+              <a:buNone/>
+            </a:pPr>
+            <a:r>
+              <a:rPr lang="en-US" sz="2400" b="1" u="sng" dirty="0">
+                <a:solidFill>
+                  <a:srgbClr val="000000"/>
+                </a:solidFill>
+                <a:latin typeface="Arial" pitchFamily="34" charset="0"/>
+                <a:ea typeface="Arial" pitchFamily="34" charset="-122"/>
+                <a:cs typeface="Arial" pitchFamily="34" charset="-120"/>
+                <a:hlinkClick r:id="rId9" invalidUrl="" action="" tgtFrame="" tooltip="https://github.com/vicitmceo/NewBalanceShop/commits/master" history="1" highlightClick="0" endSnd="0">
+                  <a:extLst>
+                    <a:ext uri="{A12FA001-AC4F-418D-AE19-62706E023703}">
+                      <ahyp:hlinkClr xmlns:ahyp="http://schemas.microsoft.com/office/drawing/2018/hyperlinkcolor" val="tx"/>
+                    </a:ext>
+                  </a:extLst>
+                </a:hlinkClick>
+              </a:rPr>
+              <a:t>Коміти</a:t>
+            </a:r>
+            <a:endParaRPr lang="en-US" sz="2400" dirty="0"/>
+          </a:p>
+          <a:p>
+            <a:pPr indent="0" marL="0">
+              <a:buNone/>
+            </a:pPr>
+            <a:r>
+              <a:rPr lang="en-US" sz="1200" u="sng" dirty="0">
+                <a:solidFill>
+                  <a:srgbClr val="000000"/>
+                </a:solidFill>
+                <a:latin typeface="Arial" pitchFamily="34" charset="0"/>
+                <a:ea typeface="Arial" pitchFamily="34" charset="-122"/>
+                <a:cs typeface="Arial" pitchFamily="34" charset="-120"/>
+                <a:hlinkClick r:id="rId10" invalidUrl="" action="" tgtFrame="" tooltip="https://github.com/vicitmceo/NewBalanceShop/commits/master" history="1" highlightClick="0" endSnd="0">
+                  <a:extLst>
+                    <a:ext uri="{A12FA001-AC4F-418D-AE19-62706E023703}">
+                      <ahyp:hlinkClr xmlns:ahyp="http://schemas.microsoft.com/office/drawing/2018/hyperlinkcolor" val="tx"/>
+                    </a:ext>
+                  </a:extLst>
+                </a:hlinkClick>
+              </a:rPr>
+              <a:t>github.com/vicitmceo/NewBalanceShop/commits/master</a:t>
+            </a:r>
+            <a:endParaRPr lang="en-US" sz="2400" dirty="0"/>
+          </a:p>
+        </p:txBody>
+      </p:sp>
+      <p:sp>
+        <p:nvSpPr>
+          <p:cNvPr id="15" name="Shape 13"/>
+          <p:cNvSpPr/>
+          <p:nvPr/>
+        </p:nvSpPr>
+        <p:spPr>
+          <a:xfrm>
+            <a:off x="8092440" y="3108960"/>
+            <a:ext cx="3611880" cy="1371600"/>
+          </a:xfrm>
+          <a:prstGeom prst="roundRect">
+            <a:avLst>
+              <a:gd name="adj" fmla="val 6667"/>
+            </a:avLst>
+          </a:prstGeom>
+          <a:solidFill>
+            <a:srgbClr val="FFFFFF"/>
+          </a:solidFill>
+          <a:ln w="12700">
+            <a:solidFill>
+              <a:srgbClr val="E2E2E2"/>
+            </a:solidFill>
+            <a:prstDash val="solid"/>
+          </a:ln>
+        </p:spPr>
+      </p:sp>
+      <p:sp>
+        <p:nvSpPr>
+          <p:cNvPr id="16" name="Text 14"/>
+          <p:cNvSpPr/>
+          <p:nvPr/>
+        </p:nvSpPr>
+        <p:spPr>
+          <a:xfrm>
+            <a:off x="8275320" y="3218688"/>
+            <a:ext cx="3246120" cy="1152144"/>
+          </a:xfrm>
+          <a:prstGeom prst="rect">
+            <a:avLst/>
+          </a:prstGeom>
+          <a:noFill/>
+          <a:ln/>
+        </p:spPr>
+        <p:txBody>
+          <a:bodyPr wrap="square" lIns="0" tIns="0" rIns="0" bIns="0" rtlCol="0" anchor="ctr"/>
+          <a:lstStyle/>
+          <a:p>
+            <a:pPr indent="0" marL="0">
+              <a:buNone/>
+            </a:pPr>
+            <a:r>
+              <a:rPr lang="en-US" sz="2400" b="1" u="sng" dirty="0">
+                <a:solidFill>
+                  <a:srgbClr val="000000"/>
+                </a:solidFill>
+                <a:latin typeface="Arial" pitchFamily="34" charset="0"/>
+                <a:ea typeface="Arial" pitchFamily="34" charset="-122"/>
+                <a:cs typeface="Arial" pitchFamily="34" charset="-120"/>
+                <a:hlinkClick r:id="rId11" invalidUrl="" action="" tgtFrame="" tooltip="https://github.com/vicitmceo/NewBalanceShop#readme" history="1" highlightClick="0" endSnd="0">
+                  <a:extLst>
+                    <a:ext uri="{A12FA001-AC4F-418D-AE19-62706E023703}">
+                      <ahyp:hlinkClr xmlns:ahyp="http://schemas.microsoft.com/office/drawing/2018/hyperlinkcolor" val="tx"/>
+                    </a:ext>
+                  </a:extLst>
+                </a:hlinkClick>
+              </a:rPr>
+              <a:t>README</a:t>
+            </a:r>
+            <a:endParaRPr lang="en-US" sz="2400" dirty="0"/>
+          </a:p>
+          <a:p>
+            <a:pPr indent="0" marL="0">
+              <a:buNone/>
+            </a:pPr>
+            <a:r>
+              <a:rPr lang="en-US" sz="1200" u="sng" dirty="0">
+                <a:solidFill>
+                  <a:srgbClr val="000000"/>
+                </a:solidFill>
+                <a:latin typeface="Arial" pitchFamily="34" charset="0"/>
+                <a:ea typeface="Arial" pitchFamily="34" charset="-122"/>
+                <a:cs typeface="Arial" pitchFamily="34" charset="-120"/>
+                <a:hlinkClick r:id="rId12" invalidUrl="" action="" tgtFrame="" tooltip="https://github.com/vicitmceo/NewBalanceShop#readme" history="1" highlightClick="0" endSnd="0">
+                  <a:extLst>
+                    <a:ext uri="{A12FA001-AC4F-418D-AE19-62706E023703}">
+                      <ahyp:hlinkClr xmlns:ahyp="http://schemas.microsoft.com/office/drawing/2018/hyperlinkcolor" val="tx"/>
+                    </a:ext>
+                  </a:extLst>
+                </a:hlinkClick>
+              </a:rPr>
+              <a:t>github.com/vicitmceo/NewBalanceShop#readme</a:t>
+            </a:r>
+            <a:endParaRPr lang="en-US" sz="2400" dirty="0"/>
+          </a:p>
+        </p:txBody>
+      </p:sp>
+      <p:sp>
+        <p:nvSpPr>
+          <p:cNvPr id="17" name="Shape 15"/>
+          <p:cNvSpPr/>
+          <p:nvPr/>
+        </p:nvSpPr>
+        <p:spPr>
+          <a:xfrm>
+            <a:off x="502920" y="4663440"/>
+            <a:ext cx="3611880" cy="1371600"/>
+          </a:xfrm>
+          <a:prstGeom prst="roundRect">
+            <a:avLst>
+              <a:gd name="adj" fmla="val 6667"/>
+            </a:avLst>
+          </a:prstGeom>
+          <a:solidFill>
+            <a:srgbClr val="FFFFFF"/>
+          </a:solidFill>
+          <a:ln w="12700">
+            <a:solidFill>
+              <a:srgbClr val="E2E2E2"/>
+            </a:solidFill>
+            <a:prstDash val="solid"/>
+          </a:ln>
+        </p:spPr>
+      </p:sp>
+      <p:sp>
+        <p:nvSpPr>
+          <p:cNvPr id="18" name="Text 16"/>
+          <p:cNvSpPr/>
+          <p:nvPr/>
+        </p:nvSpPr>
+        <p:spPr>
+          <a:xfrm>
+            <a:off x="685800" y="4773168"/>
+            <a:ext cx="3246120" cy="1152144"/>
+          </a:xfrm>
+          <a:prstGeom prst="rect">
+            <a:avLst/>
+          </a:prstGeom>
+          <a:noFill/>
+          <a:ln/>
+        </p:spPr>
+        <p:txBody>
+          <a:bodyPr wrap="square" lIns="0" tIns="0" rIns="0" bIns="0" rtlCol="0" anchor="ctr"/>
+          <a:lstStyle/>
+          <a:p>
+            <a:pPr indent="0" marL="0">
+              <a:buNone/>
+            </a:pPr>
+            <a:r>
+              <a:rPr lang="en-US" sz="2400" b="1" u="sng" dirty="0">
+                <a:solidFill>
+                  <a:srgbClr val="000000"/>
+                </a:solidFill>
+                <a:latin typeface="Arial" pitchFamily="34" charset="0"/>
+                <a:ea typeface="Arial" pitchFamily="34" charset="-122"/>
+                <a:cs typeface="Arial" pitchFamily="34" charset="-120"/>
+                <a:hlinkClick r:id="rId13" invalidUrl="" action="" tgtFrame="" tooltip="https://vicitmceo.github.io/NewBalanceShop/code/" history="1" highlightClick="0" endSnd="0">
+                  <a:extLst>
+                    <a:ext uri="{A12FA001-AC4F-418D-AE19-62706E023703}">
+                      <ahyp:hlinkClr xmlns:ahyp="http://schemas.microsoft.com/office/drawing/2018/hyperlinkcolor" val="tx"/>
+                    </a:ext>
+                  </a:extLst>
+                </a:hlinkClick>
+              </a:rPr>
+              <a:t>DocFX</a:t>
+            </a:r>
+            <a:endParaRPr lang="en-US" sz="2400" dirty="0"/>
+          </a:p>
+          <a:p>
+            <a:pPr indent="0" marL="0">
+              <a:buNone/>
+            </a:pPr>
+            <a:r>
+              <a:rPr lang="en-US" sz="1200" u="sng" dirty="0">
+                <a:solidFill>
+                  <a:srgbClr val="000000"/>
+                </a:solidFill>
+                <a:latin typeface="Arial" pitchFamily="34" charset="0"/>
+                <a:ea typeface="Arial" pitchFamily="34" charset="-122"/>
+                <a:cs typeface="Arial" pitchFamily="34" charset="-120"/>
+                <a:hlinkClick r:id="rId14" invalidUrl="" action="" tgtFrame="" tooltip="https://vicitmceo.github.io/NewBalanceShop/code/" history="1" highlightClick="0" endSnd="0">
+                  <a:extLst>
+                    <a:ext uri="{A12FA001-AC4F-418D-AE19-62706E023703}">
+                      <ahyp:hlinkClr xmlns:ahyp="http://schemas.microsoft.com/office/drawing/2018/hyperlinkcolor" val="tx"/>
+                    </a:ext>
+                  </a:extLst>
+                </a:hlinkClick>
+              </a:rPr>
+              <a:t>vicitmceo.github.io/NewBalanceShop/code/</a:t>
+            </a:r>
+            <a:endParaRPr lang="en-US" sz="2400" dirty="0"/>
+          </a:p>
+        </p:txBody>
+      </p:sp>
+      <p:sp>
+        <p:nvSpPr>
+          <p:cNvPr id="19" name="Shape 17"/>
+          <p:cNvSpPr/>
+          <p:nvPr/>
+        </p:nvSpPr>
+        <p:spPr>
+          <a:xfrm>
+            <a:off x="4297680" y="4663440"/>
+            <a:ext cx="3611880" cy="1371600"/>
+          </a:xfrm>
+          <a:prstGeom prst="roundRect">
+            <a:avLst>
+              <a:gd name="adj" fmla="val 6667"/>
+            </a:avLst>
+          </a:prstGeom>
+          <a:solidFill>
+            <a:srgbClr val="FFFFFF"/>
+          </a:solidFill>
+          <a:ln w="12700">
+            <a:solidFill>
+              <a:srgbClr val="E2E2E2"/>
+            </a:solidFill>
+            <a:prstDash val="solid"/>
+          </a:ln>
+        </p:spPr>
+      </p:sp>
+      <p:sp>
+        <p:nvSpPr>
+          <p:cNvPr id="20" name="Text 18"/>
+          <p:cNvSpPr/>
+          <p:nvPr/>
+        </p:nvSpPr>
+        <p:spPr>
+          <a:xfrm>
+            <a:off x="4480560" y="4773168"/>
+            <a:ext cx="3246120" cy="1152144"/>
+          </a:xfrm>
+          <a:prstGeom prst="rect">
+            <a:avLst/>
+          </a:prstGeom>
+          <a:noFill/>
+          <a:ln/>
+        </p:spPr>
+        <p:txBody>
+          <a:bodyPr wrap="square" lIns="0" tIns="0" rIns="0" bIns="0" rtlCol="0" anchor="ctr"/>
+          <a:lstStyle/>
+          <a:p>
+            <a:pPr indent="0" marL="0">
+              <a:buNone/>
+            </a:pPr>
+            <a:r>
+              <a:rPr lang="en-US" sz="2400" b="1" u="sng" dirty="0">
+                <a:solidFill>
+                  <a:srgbClr val="000000"/>
+                </a:solidFill>
+                <a:latin typeface="Arial" pitchFamily="34" charset="0"/>
+                <a:ea typeface="Arial" pitchFamily="34" charset="-122"/>
+                <a:cs typeface="Arial" pitchFamily="34" charset="-120"/>
+                <a:hlinkClick r:id="rId15" invalidUrl="" action="" tgtFrame="" tooltip="https://vicitmceo.github.io/NewBalanceShop/api/" history="1" highlightClick="0" endSnd="0">
+                  <a:extLst>
+                    <a:ext uri="{A12FA001-AC4F-418D-AE19-62706E023703}">
+                      <ahyp:hlinkClr xmlns:ahyp="http://schemas.microsoft.com/office/drawing/2018/hyperlinkcolor" val="tx"/>
+                    </a:ext>
+                  </a:extLst>
+                </a:hlinkClick>
+              </a:rPr>
+              <a:t>Scalar (API)</a:t>
+            </a:r>
+            <a:endParaRPr lang="en-US" sz="2400" dirty="0"/>
+          </a:p>
+          <a:p>
+            <a:pPr indent="0" marL="0">
+              <a:buNone/>
+            </a:pPr>
+            <a:r>
+              <a:rPr lang="en-US" sz="1200" u="sng" dirty="0">
+                <a:solidFill>
+                  <a:srgbClr val="000000"/>
+                </a:solidFill>
+                <a:latin typeface="Arial" pitchFamily="34" charset="0"/>
+                <a:ea typeface="Arial" pitchFamily="34" charset="-122"/>
+                <a:cs typeface="Arial" pitchFamily="34" charset="-120"/>
+                <a:hlinkClick r:id="rId16" invalidUrl="" action="" tgtFrame="" tooltip="https://vicitmceo.github.io/NewBalanceShop/api/" history="1" highlightClick="0" endSnd="0">
+                  <a:extLst>
+                    <a:ext uri="{A12FA001-AC4F-418D-AE19-62706E023703}">
+                      <ahyp:hlinkClr xmlns:ahyp="http://schemas.microsoft.com/office/drawing/2018/hyperlinkcolor" val="tx"/>
+                    </a:ext>
+                  </a:extLst>
+                </a:hlinkClick>
+              </a:rPr>
+              <a:t>vicitmceo.github.io/NewBalanceShop/api/</a:t>
+            </a:r>
+            <a:endParaRPr lang="en-US" sz="2400" dirty="0"/>
+          </a:p>
+        </p:txBody>
+      </p:sp>
+      <p:sp>
+        <p:nvSpPr>
+          <p:cNvPr id="21" name="Shape 19"/>
+          <p:cNvSpPr/>
+          <p:nvPr/>
+        </p:nvSpPr>
+        <p:spPr>
+          <a:xfrm>
+            <a:off x="8092440" y="4663440"/>
+            <a:ext cx="3611880" cy="1371600"/>
+          </a:xfrm>
+          <a:prstGeom prst="roundRect">
+            <a:avLst>
+              <a:gd name="adj" fmla="val 6667"/>
+            </a:avLst>
+          </a:prstGeom>
+          <a:solidFill>
+            <a:srgbClr val="FFFFFF"/>
+          </a:solidFill>
+          <a:ln w="12700">
+            <a:solidFill>
+              <a:srgbClr val="E2E2E2"/>
+            </a:solidFill>
+            <a:prstDash val="solid"/>
+          </a:ln>
+        </p:spPr>
+      </p:sp>
+      <p:sp>
+        <p:nvSpPr>
+          <p:cNvPr id="22" name="Text 20"/>
+          <p:cNvSpPr/>
+          <p:nvPr/>
+        </p:nvSpPr>
+        <p:spPr>
+          <a:xfrm>
+            <a:off x="8275320" y="4773168"/>
+            <a:ext cx="3246120" cy="1152144"/>
+          </a:xfrm>
+          <a:prstGeom prst="rect">
+            <a:avLst/>
+          </a:prstGeom>
+          <a:noFill/>
+          <a:ln/>
+        </p:spPr>
+        <p:txBody>
+          <a:bodyPr wrap="square" lIns="0" tIns="0" rIns="0" bIns="0" rtlCol="0" anchor="ctr"/>
+          <a:lstStyle/>
+          <a:p>
+            <a:pPr indent="0" marL="0">
+              <a:buNone/>
+            </a:pPr>
+            <a:r>
+              <a:rPr lang="en-US" sz="2400" b="1" u="sng" dirty="0">
+                <a:solidFill>
+                  <a:srgbClr val="000000"/>
+                </a:solidFill>
+                <a:latin typeface="Arial" pitchFamily="34" charset="0"/>
+                <a:ea typeface="Arial" pitchFamily="34" charset="-122"/>
+                <a:cs typeface="Arial" pitchFamily="34" charset="-120"/>
+                <a:hlinkClick r:id="rId17" invalidUrl="" action="" tgtFrame="" tooltip="https://github.com/vicitmceo/newbalanceshop-frontend" history="1" highlightClick="0" endSnd="0">
+                  <a:extLst>
+                    <a:ext uri="{A12FA001-AC4F-418D-AE19-62706E023703}">
+                      <ahyp:hlinkClr xmlns:ahyp="http://schemas.microsoft.com/office/drawing/2018/hyperlinkcolor" val="tx"/>
+                    </a:ext>
+                  </a:extLst>
+                </a:hlinkClick>
+              </a:rPr>
+              <a:t>Фронтенд (репо)</a:t>
+            </a:r>
+            <a:endParaRPr lang="en-US" sz="2400" dirty="0"/>
+          </a:p>
+          <a:p>
+            <a:pPr indent="0" marL="0">
+              <a:buNone/>
+            </a:pPr>
+            <a:r>
+              <a:rPr lang="en-US" sz="1200" u="sng" dirty="0">
+                <a:solidFill>
+                  <a:srgbClr val="000000"/>
+                </a:solidFill>
+                <a:latin typeface="Arial" pitchFamily="34" charset="0"/>
+                <a:ea typeface="Arial" pitchFamily="34" charset="-122"/>
+                <a:cs typeface="Arial" pitchFamily="34" charset="-120"/>
+                <a:hlinkClick r:id="rId18" invalidUrl="" action="" tgtFrame="" tooltip="https://github.com/vicitmceo/newbalanceshop-frontend" history="1" highlightClick="0" endSnd="0">
+                  <a:extLst>
+                    <a:ext uri="{A12FA001-AC4F-418D-AE19-62706E023703}">
+                      <ahyp:hlinkClr xmlns:ahyp="http://schemas.microsoft.com/office/drawing/2018/hyperlinkcolor" val="tx"/>
+                    </a:ext>
+                  </a:extLst>
+                </a:hlinkClick>
+              </a:rPr>
+              <a:t>github.com/vicitmceo/newbalanceshop-frontend</a:t>
+            </a:r>
+            <a:endParaRPr lang="en-US" sz="2400" dirty="0"/>
+          </a:p>
+        </p:txBody>
+      </p:sp>
+      <p:sp>
+        <p:nvSpPr>
+          <p:cNvPr id="23" name="Text 21"/>
+          <p:cNvSpPr/>
+          <p:nvPr/>
+        </p:nvSpPr>
+        <p:spPr>
+          <a:xfrm>
+            <a:off x="502920" y="6172200"/>
+            <a:ext cx="10972800" cy="274320"/>
+          </a:xfrm>
+          <a:prstGeom prst="rect">
+            <a:avLst/>
+          </a:prstGeom>
+          <a:noFill/>
+          <a:ln/>
+        </p:spPr>
+        <p:txBody>
+          <a:bodyPr wrap="square" lIns="0" tIns="0" rIns="0" bIns="0" rtlCol="0" anchor="ctr"/>
+          <a:lstStyle/>
+          <a:p>
+            <a:pPr indent="0" marL="0">
+              <a:buNone/>
+            </a:pPr>
+            <a:r>
+              <a:rPr lang="en-US" sz="1200" dirty="0">
+                <a:solidFill>
+                  <a:srgbClr val="5C5C5C"/>
+                </a:solidFill>
+                <a:latin typeface="Arial" pitchFamily="34" charset="0"/>
+                <a:ea typeface="Arial" pitchFamily="34" charset="-122"/>
+                <a:cs typeface="Arial" pitchFamily="34" charset="-120"/>
+              </a:rPr>
+              <a:t>Сайт: newbalance.cc.cd  ·  API: newbalanceshop-api.onrender.com</a:t>
+            </a:r>
+            <a:endParaRPr lang="en-US" sz="1200" dirty="0"/>
+          </a:p>
+        </p:txBody>
+      </p:sp>
     </p:spTree>
   </p:cSld>
   <p:clrMapOvr>
@@ -4111,7 +6895,7 @@
       </p:grpSpPr>
       <p:pic>
         <p:nvPicPr>
-          <p:cNvPr id="2" name="Image 0" descr="Автентифікація, авторизація та безпека">    </p:cNvPr>
+          <p:cNvPr id="2" name="Image 0" descr="Додаток: 01-why-project/personas.png">    </p:cNvPr>
           <p:cNvPicPr>
             <a:picLocks noChangeAspect="1"/>
           </p:cNvPicPr>

</xml_diff>

<commit_message>
docs: rebuild deck with updated speaker notes
</commit_message>
<xml_diff>
--- a/defense-materials/NewBalanceShop-presentation.pptx
+++ b/defense-materials/NewBalanceShop-presentation.pptx
@@ -134,7 +134,7 @@
   <p:extLst>
     <p:ext uri="{521415D9-36F7-43E2-AB2F-B90AF26B5E84}">
       <p14:sectionLst xmlns:p14="http://schemas.microsoft.com/office/powerpoint/2010/main">
-        <p14:section name="Доповідь" id="{bbfbffc3-593c-097b-7294-c63454278678}">
+        <p14:section name="Доповідь" id="{d93e7ecf-d744-f234-ab25-3445abb848f7}">
           <p14:sldIdLst>
             <p14:sldId id="256"/>
             <p14:sldId id="257"/>
@@ -146,7 +146,7 @@
             <p14:sldId id="263"/>
           </p14:sldIdLst>
         </p14:section>
-        <p14:section name="Додатки (запасні слайди)" id="{267287c3-39fc-c54b-32d3-72d4ea457d9f}">
+        <p14:section name="Додатки (запасні слайди)" id="{60432a6e-2222-6416-3324-320c6b49ff6b}">
           <p14:sldIdLst>
             <p14:sldId id="264"/>
             <p14:sldId id="265"/>
@@ -169,7 +169,7 @@
             <p14:sldId id="282"/>
           </p14:sldIdLst>
         </p14:section>
-        <p14:section name="Запитання" id="{32e45559-ee65-695b-86c2-02fcb5ccdfd5}">
+        <p14:section name="Запитання" id="{4b37c035-6e02-77ae-81f6-adbe7d2e86ad}">
           <p14:sldIdLst>
             <p14:sldId id="283"/>
           </p14:sldIdLst>
@@ -578,7 +578,7 @@
           <a:p>
             <a:r>
               <a:rPr lang="en-US" dirty="0"/>
-              <a:t>Вадим. Команда Team 1, проєкт New Balance Shop. Двоє учасників: Вадим Панчук, Team Lead, вимоги, план, Scrum; Рафаїл Ноцколіні, full-stack: код, архітектура, безпека, демо.</a:t>
+              <a:t>Вадим відкриває доповідь. Команда Team 1, проєкт New Balance Shop. Двоє учасників: Вадим Панчук, Team Lead, вимоги, план, Scrum; Рафаїл Ноцколіні, full-stack: код, архітектура, безпека, демо.</a:t>
             </a:r>
             <a:endParaRPr lang="en-US" dirty="0"/>
           </a:p>
@@ -1546,7 +1546,7 @@
           <a:p>
             <a:r>
               <a:rPr lang="en-US" dirty="0"/>
-              <a:t>Вадим. Проблема: складно швидко знайти й купити потрібну пару. Рішення: каталог, кошик, замовлення без зайвої реєстрації. Аудиторія: покупці 16-40 років.</a:t>
+              <a:t>Рафаїл. Проблема: складно швидко знайти й купити потрібну пару. Рішення: каталог, кошик, замовлення без зайвої реєстрації. Аудиторія: покупці 16-40 років.</a:t>
             </a:r>
             <a:endParaRPr lang="en-US" dirty="0"/>
           </a:p>
@@ -2162,7 +2162,7 @@
           <a:p>
             <a:r>
               <a:rPr lang="en-US" dirty="0"/>
-              <a:t>Запасний слайд. Мобільна версія 390 px: шапка переноситься, меню прокручується, картка товару з мініатюрами. Чесно: сітка каталогу у дві колонки на вузькому екрані має зсув правої колонки, у планах виправлення.</a:t>
+              <a:t>Запасний слайд. Мобільна версія 390 px: шапка переноситься, меню прокручується, картка товару з мініатюрами. Сітка товарів у дві колонки, розміри на плитці.</a:t>
             </a:r>
             <a:endParaRPr lang="en-US" dirty="0"/>
           </a:p>
@@ -2426,7 +2426,7 @@
           <a:p>
             <a:r>
               <a:rPr lang="en-US" dirty="0"/>
-              <a:t>Вадим. 13 функціональних вимог, усі реалізовано. План: 8 спринтів по тижню, 5 тижнів розробки.</a:t>
+              <a:t>Рафаїл. 13 функціональних вимог, усі реалізовано. План: 8 спринтів по тижню, 5 тижнів розробки.</a:t>
             </a:r>
             <a:endParaRPr lang="en-US" dirty="0"/>
           </a:p>
@@ -2514,7 +2514,7 @@
           <a:p>
             <a:r>
               <a:rPr lang="en-US" dirty="0"/>
-              <a:t>Вадим. Jira, 8 тижневих спринтів, 44 задачі, 33 виконано. Чесно: мій внесок у Git нульовий, моя роль планування, вимоги, Jira, документи. Статуси в Jira відстають від коду.</a:t>
+              <a:t>Рафаїл. Jira, 8 тижневих спринтів, 44 задачі, 33 виконано. Чесно: внесок Вадима (Team Lead) у Git нульовий, його роль планування, вимоги, Jira, документи. Статуси в Jira відстають від коду.</a:t>
             </a:r>
             <a:endParaRPr lang="en-US" dirty="0"/>
           </a:p>

</xml_diff>